<commit_message>
docs(trimestre3): agregar presentacion oficial con entregables
</commit_message>
<xml_diff>
--- a/Tercer Trimestre/Presentación - 3 Trimestre.pptx
+++ b/Tercer Trimestre/Presentación - 3 Trimestre.pptx
@@ -265,17 +265,17 @@
   <p:extLst>
     <p:ext uri="{EFAFB233-063F-42B5-8137-9DF3F51BA10A}">
       <p15:sldGuideLst xmlns:p15="http://schemas.microsoft.com/office/powerpoint/2012/main">
-        <p15:guide id="1" orient="horz" pos="595">
+        <p15:guide id="1" orient="horz" pos="595" userDrawn="1">
           <p15:clr>
             <a:srgbClr val="A4A3A4"/>
           </p15:clr>
         </p15:guide>
-        <p15:guide id="2" pos="3840">
+        <p15:guide id="2" pos="3840" userDrawn="1">
           <p15:clr>
             <a:srgbClr val="A4A3A4"/>
           </p15:clr>
         </p15:guide>
-        <p15:guide id="3" orient="horz" pos="187">
+        <p15:guide id="3" orient="horz" pos="187" userDrawn="1">
           <p15:clr>
             <a:srgbClr val="A4A3A4"/>
           </p15:clr>
@@ -283,7 +283,7 @@
       </p15:sldGuideLst>
     </p:ext>
     <p:ext uri="GoogleSlidesCustomDataVersion2">
-      <go:slidesCustomData xmlns:go="http://customooxmlschemas.google.com/" xmlns:ahyp="http://schemas.microsoft.com/office/drawing/2018/hyperlinkcolor" xmlns:p15="http://schemas.microsoft.com/office/powerpoint/2012/main" xmlns:p14="http://schemas.microsoft.com/office/powerpoint/2010/main" xmlns:com="http://schemas.openxmlformats.org/drawingml/2006/compatibility" xmlns:pvml="urn:schemas-microsoft-com:office:powerpoint" xmlns:v="urn:schemas-microsoft-com:vml" xmlns:o="urn:schemas-microsoft-com:office:office" xmlns:dgm="http://schemas.openxmlformats.org/drawingml/2006/diagram" xmlns:c="http://schemas.openxmlformats.org/drawingml/2006/chart" xmlns:mv="urn:schemas-microsoft-com:mac:vml" xmlns:mc="http://schemas.openxmlformats.org/markup-compatibility/2006" xmlns="" r:id="rId24" roundtripDataSignature="AMtx7mg8ATteeCZnY9oSBywHj+xxF5qVxA=="/>
+      <go:slidesCustomData xmlns="" xmlns:mc="http://schemas.openxmlformats.org/markup-compatibility/2006" xmlns:mv="urn:schemas-microsoft-com:mac:vml" xmlns:c="http://schemas.openxmlformats.org/drawingml/2006/chart" xmlns:dgm="http://schemas.openxmlformats.org/drawingml/2006/diagram" xmlns:o="urn:schemas-microsoft-com:office:office" xmlns:v="urn:schemas-microsoft-com:vml" xmlns:pvml="urn:schemas-microsoft-com:office:powerpoint" xmlns:com="http://schemas.openxmlformats.org/drawingml/2006/compatibility" xmlns:p14="http://schemas.microsoft.com/office/powerpoint/2010/main" xmlns:p15="http://schemas.microsoft.com/office/powerpoint/2012/main" xmlns:ahyp="http://schemas.microsoft.com/office/drawing/2018/hyperlinkcolor" xmlns:go="http://customooxmlschemas.google.com/" r:id="rId24" roundtripDataSignature="AMtx7mg8ATteeCZnY9oSBywHj+xxF5qVxA=="/>
     </p:ext>
   </p:extLst>
 </p:presentation>
@@ -3002,7 +3002,7 @@
         </p:nvSpPr>
         <p:spPr>
           <a:xfrm>
-            <a:off x="838200" y="6356350"/>
+            <a:off x="838200" y="6356354"/>
             <a:ext cx="2743200" cy="365125"/>
           </a:xfrm>
           <a:prstGeom prst="rect">
@@ -3135,7 +3135,7 @@
         </p:nvSpPr>
         <p:spPr>
           <a:xfrm>
-            <a:off x="4038600" y="6356350"/>
+            <a:off x="4038600" y="6356354"/>
             <a:ext cx="4114800" cy="365125"/>
           </a:xfrm>
           <a:prstGeom prst="rect">
@@ -3268,7 +3268,7 @@
         </p:nvSpPr>
         <p:spPr>
           <a:xfrm>
-            <a:off x="8610600" y="6356350"/>
+            <a:off x="8610600" y="6356354"/>
             <a:ext cx="2743200" cy="365125"/>
           </a:xfrm>
           <a:prstGeom prst="rect">
@@ -3349,20 +3349,12 @@
             </a:lvl9pPr>
           </a:lstStyle>
           <a:p>
-            <a:pPr marL="0" lvl="0" indent="0" algn="r" rtl="0">
-              <a:spcBef>
-                <a:spcPts val="0"/>
-              </a:spcBef>
-              <a:spcAft>
-                <a:spcPts val="0"/>
-              </a:spcAft>
-              <a:buNone/>
-            </a:pPr>
             <a:fld id="{00000000-1234-1234-1234-123412341234}" type="slidenum">
-              <a:rPr lang="es-CO"/>
+              <a:rPr lang="es-CO" smtClean="0"/>
+              <a:pPr/>
               <a:t>‹Nº›</a:t>
             </a:fld>
-            <a:endParaRPr/>
+            <a:endParaRPr lang="es-CO"/>
           </a:p>
         </p:txBody>
       </p:sp>
@@ -3374,12 +3366,12 @@
   <p:extLst>
     <p:ext uri="{DCECCB84-F9BA-43D5-87BE-67443E8EF086}">
       <p15:sldGuideLst xmlns:p15="http://schemas.microsoft.com/office/powerpoint/2012/main">
-        <p15:guide id="1" orient="horz" pos="2160">
+        <p15:guide id="1" orient="horz" pos="2160" userDrawn="1">
           <p15:clr>
             <a:srgbClr val="FBAE40"/>
           </p15:clr>
         </p15:guide>
-        <p15:guide id="2" pos="3840">
+        <p15:guide id="2" pos="3840" userDrawn="1">
           <p15:clr>
             <a:srgbClr val="FBAE40"/>
           </p15:clr>
@@ -3419,7 +3411,7 @@
         </p:nvSpPr>
         <p:spPr>
           <a:xfrm>
-            <a:off x="838200" y="365125"/>
+            <a:off x="838200" y="365129"/>
             <a:ext cx="10515600" cy="1325563"/>
           </a:xfrm>
           <a:prstGeom prst="rect">
@@ -3574,7 +3566,7 @@
             <a:normAutofit/>
           </a:bodyPr>
           <a:lstStyle>
-            <a:lvl1pPr marL="457200" lvl="0" indent="-342900" algn="l">
+            <a:lvl1pPr marL="457189" lvl="0" indent="-342891" algn="l">
               <a:lnSpc>
                 <a:spcPct val="90000"/>
               </a:lnSpc>
@@ -3591,7 +3583,7 @@
               <a:buChar char="•"/>
               <a:defRPr/>
             </a:lvl1pPr>
-            <a:lvl2pPr marL="914400" lvl="1" indent="-342900" algn="l">
+            <a:lvl2pPr marL="914377" lvl="1" indent="-342891" algn="l">
               <a:lnSpc>
                 <a:spcPct val="90000"/>
               </a:lnSpc>
@@ -3608,7 +3600,7 @@
               <a:buChar char="•"/>
               <a:defRPr/>
             </a:lvl2pPr>
-            <a:lvl3pPr marL="1371600" lvl="2" indent="-342900" algn="l">
+            <a:lvl3pPr marL="1371566" lvl="2" indent="-342891" algn="l">
               <a:lnSpc>
                 <a:spcPct val="90000"/>
               </a:lnSpc>
@@ -3625,7 +3617,7 @@
               <a:buChar char="•"/>
               <a:defRPr/>
             </a:lvl3pPr>
-            <a:lvl4pPr marL="1828800" lvl="3" indent="-342900" algn="l">
+            <a:lvl4pPr marL="1828754" lvl="3" indent="-342891" algn="l">
               <a:lnSpc>
                 <a:spcPct val="90000"/>
               </a:lnSpc>
@@ -3642,7 +3634,7 @@
               <a:buChar char="•"/>
               <a:defRPr/>
             </a:lvl4pPr>
-            <a:lvl5pPr marL="2286000" lvl="4" indent="-342900" algn="l">
+            <a:lvl5pPr marL="2285943" lvl="4" indent="-342891" algn="l">
               <a:lnSpc>
                 <a:spcPct val="90000"/>
               </a:lnSpc>
@@ -3659,7 +3651,7 @@
               <a:buChar char="•"/>
               <a:defRPr/>
             </a:lvl5pPr>
-            <a:lvl6pPr marL="2743200" lvl="5" indent="-342900" algn="l">
+            <a:lvl6pPr marL="2743131" lvl="5" indent="-342891" algn="l">
               <a:lnSpc>
                 <a:spcPct val="90000"/>
               </a:lnSpc>
@@ -3676,7 +3668,7 @@
               <a:buChar char="•"/>
               <a:defRPr/>
             </a:lvl6pPr>
-            <a:lvl7pPr marL="3200400" lvl="6" indent="-342900" algn="l">
+            <a:lvl7pPr marL="3200320" lvl="6" indent="-342891" algn="l">
               <a:lnSpc>
                 <a:spcPct val="90000"/>
               </a:lnSpc>
@@ -3693,7 +3685,7 @@
               <a:buChar char="•"/>
               <a:defRPr/>
             </a:lvl7pPr>
-            <a:lvl8pPr marL="3657600" lvl="7" indent="-342900" algn="l">
+            <a:lvl8pPr marL="3657509" lvl="7" indent="-342891" algn="l">
               <a:lnSpc>
                 <a:spcPct val="90000"/>
               </a:lnSpc>
@@ -3710,7 +3702,7 @@
               <a:buChar char="•"/>
               <a:defRPr/>
             </a:lvl8pPr>
-            <a:lvl9pPr marL="4114800" lvl="8" indent="-342900" algn="l">
+            <a:lvl9pPr marL="4114697" lvl="8" indent="-342891" algn="l">
               <a:lnSpc>
                 <a:spcPct val="90000"/>
               </a:lnSpc>
@@ -3745,7 +3737,7 @@
         </p:nvSpPr>
         <p:spPr>
           <a:xfrm>
-            <a:off x="838200" y="6356350"/>
+            <a:off x="838200" y="6356354"/>
             <a:ext cx="2743200" cy="365125"/>
           </a:xfrm>
           <a:prstGeom prst="rect">
@@ -3878,7 +3870,7 @@
         </p:nvSpPr>
         <p:spPr>
           <a:xfrm>
-            <a:off x="4038600" y="6356350"/>
+            <a:off x="4038600" y="6356354"/>
             <a:ext cx="4114800" cy="365125"/>
           </a:xfrm>
           <a:prstGeom prst="rect">
@@ -4011,7 +4003,7 @@
         </p:nvSpPr>
         <p:spPr>
           <a:xfrm>
-            <a:off x="8610600" y="6356350"/>
+            <a:off x="8610600" y="6356354"/>
             <a:ext cx="2743200" cy="365125"/>
           </a:xfrm>
           <a:prstGeom prst="rect">
@@ -4092,20 +4084,12 @@
             </a:lvl9pPr>
           </a:lstStyle>
           <a:p>
-            <a:pPr marL="0" lvl="0" indent="0" algn="r" rtl="0">
-              <a:spcBef>
-                <a:spcPts val="0"/>
-              </a:spcBef>
-              <a:spcAft>
-                <a:spcPts val="0"/>
-              </a:spcAft>
-              <a:buNone/>
-            </a:pPr>
             <a:fld id="{00000000-1234-1234-1234-123412341234}" type="slidenum">
-              <a:rPr lang="es-CO"/>
+              <a:rPr lang="es-CO" smtClean="0"/>
+              <a:pPr/>
               <a:t>‹Nº›</a:t>
             </a:fld>
-            <a:endParaRPr/>
+            <a:endParaRPr lang="es-CO"/>
           </a:p>
         </p:txBody>
       </p:sp>
@@ -4146,7 +4130,7 @@
         </p:nvSpPr>
         <p:spPr>
           <a:xfrm rot="5400000">
-            <a:off x="7133431" y="1956594"/>
+            <a:off x="7133432" y="1956596"/>
             <a:ext cx="5811838" cy="2628900"/>
           </a:xfrm>
           <a:prstGeom prst="rect">
@@ -4285,7 +4269,7 @@
         </p:nvSpPr>
         <p:spPr>
           <a:xfrm rot="5400000">
-            <a:off x="1799431" y="-596106"/>
+            <a:off x="1799432" y="-596104"/>
             <a:ext cx="5811838" cy="7734300"/>
           </a:xfrm>
           <a:prstGeom prst="rect">
@@ -4301,7 +4285,7 @@
             <a:normAutofit/>
           </a:bodyPr>
           <a:lstStyle>
-            <a:lvl1pPr marL="457200" lvl="0" indent="-342900" algn="l">
+            <a:lvl1pPr marL="457189" lvl="0" indent="-342891" algn="l">
               <a:lnSpc>
                 <a:spcPct val="90000"/>
               </a:lnSpc>
@@ -4318,7 +4302,7 @@
               <a:buChar char="•"/>
               <a:defRPr/>
             </a:lvl1pPr>
-            <a:lvl2pPr marL="914400" lvl="1" indent="-342900" algn="l">
+            <a:lvl2pPr marL="914377" lvl="1" indent="-342891" algn="l">
               <a:lnSpc>
                 <a:spcPct val="90000"/>
               </a:lnSpc>
@@ -4335,7 +4319,7 @@
               <a:buChar char="•"/>
               <a:defRPr/>
             </a:lvl2pPr>
-            <a:lvl3pPr marL="1371600" lvl="2" indent="-342900" algn="l">
+            <a:lvl3pPr marL="1371566" lvl="2" indent="-342891" algn="l">
               <a:lnSpc>
                 <a:spcPct val="90000"/>
               </a:lnSpc>
@@ -4352,7 +4336,7 @@
               <a:buChar char="•"/>
               <a:defRPr/>
             </a:lvl3pPr>
-            <a:lvl4pPr marL="1828800" lvl="3" indent="-342900" algn="l">
+            <a:lvl4pPr marL="1828754" lvl="3" indent="-342891" algn="l">
               <a:lnSpc>
                 <a:spcPct val="90000"/>
               </a:lnSpc>
@@ -4369,7 +4353,7 @@
               <a:buChar char="•"/>
               <a:defRPr/>
             </a:lvl4pPr>
-            <a:lvl5pPr marL="2286000" lvl="4" indent="-342900" algn="l">
+            <a:lvl5pPr marL="2285943" lvl="4" indent="-342891" algn="l">
               <a:lnSpc>
                 <a:spcPct val="90000"/>
               </a:lnSpc>
@@ -4386,7 +4370,7 @@
               <a:buChar char="•"/>
               <a:defRPr/>
             </a:lvl5pPr>
-            <a:lvl6pPr marL="2743200" lvl="5" indent="-342900" algn="l">
+            <a:lvl6pPr marL="2743131" lvl="5" indent="-342891" algn="l">
               <a:lnSpc>
                 <a:spcPct val="90000"/>
               </a:lnSpc>
@@ -4403,7 +4387,7 @@
               <a:buChar char="•"/>
               <a:defRPr/>
             </a:lvl6pPr>
-            <a:lvl7pPr marL="3200400" lvl="6" indent="-342900" algn="l">
+            <a:lvl7pPr marL="3200320" lvl="6" indent="-342891" algn="l">
               <a:lnSpc>
                 <a:spcPct val="90000"/>
               </a:lnSpc>
@@ -4420,7 +4404,7 @@
               <a:buChar char="•"/>
               <a:defRPr/>
             </a:lvl7pPr>
-            <a:lvl8pPr marL="3657600" lvl="7" indent="-342900" algn="l">
+            <a:lvl8pPr marL="3657509" lvl="7" indent="-342891" algn="l">
               <a:lnSpc>
                 <a:spcPct val="90000"/>
               </a:lnSpc>
@@ -4437,7 +4421,7 @@
               <a:buChar char="•"/>
               <a:defRPr/>
             </a:lvl8pPr>
-            <a:lvl9pPr marL="4114800" lvl="8" indent="-342900" algn="l">
+            <a:lvl9pPr marL="4114697" lvl="8" indent="-342891" algn="l">
               <a:lnSpc>
                 <a:spcPct val="90000"/>
               </a:lnSpc>
@@ -4472,7 +4456,7 @@
         </p:nvSpPr>
         <p:spPr>
           <a:xfrm>
-            <a:off x="838200" y="6356350"/>
+            <a:off x="838200" y="6356354"/>
             <a:ext cx="2743200" cy="365125"/>
           </a:xfrm>
           <a:prstGeom prst="rect">
@@ -4605,7 +4589,7 @@
         </p:nvSpPr>
         <p:spPr>
           <a:xfrm>
-            <a:off x="4038600" y="6356350"/>
+            <a:off x="4038600" y="6356354"/>
             <a:ext cx="4114800" cy="365125"/>
           </a:xfrm>
           <a:prstGeom prst="rect">
@@ -4738,7 +4722,7 @@
         </p:nvSpPr>
         <p:spPr>
           <a:xfrm>
-            <a:off x="8610600" y="6356350"/>
+            <a:off x="8610600" y="6356354"/>
             <a:ext cx="2743200" cy="365125"/>
           </a:xfrm>
           <a:prstGeom prst="rect">
@@ -4819,20 +4803,12 @@
             </a:lvl9pPr>
           </a:lstStyle>
           <a:p>
-            <a:pPr marL="0" lvl="0" indent="0" algn="r" rtl="0">
-              <a:spcBef>
-                <a:spcPts val="0"/>
-              </a:spcBef>
-              <a:spcAft>
-                <a:spcPts val="0"/>
-              </a:spcAft>
-              <a:buNone/>
-            </a:pPr>
             <a:fld id="{00000000-1234-1234-1234-123412341234}" type="slidenum">
-              <a:rPr lang="es-CO"/>
+              <a:rPr lang="es-CO" smtClean="0"/>
+              <a:pPr/>
               <a:t>‹Nº›</a:t>
             </a:fld>
-            <a:endParaRPr/>
+            <a:endParaRPr lang="es-CO"/>
           </a:p>
         </p:txBody>
       </p:sp>
@@ -4886,7 +4862,7 @@
         </p:nvSpPr>
         <p:spPr>
           <a:xfrm>
-            <a:off x="838200" y="365125"/>
+            <a:off x="838200" y="365129"/>
             <a:ext cx="10515600" cy="1325563"/>
           </a:xfrm>
           <a:prstGeom prst="rect">
@@ -5025,7 +5001,7 @@
         </p:nvSpPr>
         <p:spPr>
           <a:xfrm>
-            <a:off x="838200" y="6356350"/>
+            <a:off x="838200" y="6356354"/>
             <a:ext cx="2743200" cy="365125"/>
           </a:xfrm>
           <a:prstGeom prst="rect">
@@ -5158,7 +5134,7 @@
         </p:nvSpPr>
         <p:spPr>
           <a:xfrm>
-            <a:off x="4038600" y="6356350"/>
+            <a:off x="4038600" y="6356354"/>
             <a:ext cx="4114800" cy="365125"/>
           </a:xfrm>
           <a:prstGeom prst="rect">
@@ -5291,7 +5267,7 @@
         </p:nvSpPr>
         <p:spPr>
           <a:xfrm>
-            <a:off x="8610600" y="6356350"/>
+            <a:off x="8610600" y="6356354"/>
             <a:ext cx="2743200" cy="365125"/>
           </a:xfrm>
           <a:prstGeom prst="rect">
@@ -5372,20 +5348,12 @@
             </a:lvl9pPr>
           </a:lstStyle>
           <a:p>
-            <a:pPr marL="0" lvl="0" indent="0" algn="r" rtl="0">
-              <a:spcBef>
-                <a:spcPts val="0"/>
-              </a:spcBef>
-              <a:spcAft>
-                <a:spcPts val="0"/>
-              </a:spcAft>
-              <a:buNone/>
-            </a:pPr>
             <a:fld id="{00000000-1234-1234-1234-123412341234}" type="slidenum">
-              <a:rPr lang="es-CO"/>
+              <a:rPr lang="es-CO" smtClean="0"/>
+              <a:pPr/>
               <a:t>‹Nº›</a:t>
             </a:fld>
-            <a:endParaRPr/>
+            <a:endParaRPr lang="es-CO"/>
           </a:p>
         </p:txBody>
       </p:sp>
@@ -5753,7 +5721,7 @@
         </p:nvSpPr>
         <p:spPr>
           <a:xfrm>
-            <a:off x="838200" y="6356350"/>
+            <a:off x="838200" y="6356354"/>
             <a:ext cx="2743200" cy="365125"/>
           </a:xfrm>
           <a:prstGeom prst="rect">
@@ -5886,7 +5854,7 @@
         </p:nvSpPr>
         <p:spPr>
           <a:xfrm>
-            <a:off x="4038600" y="6356350"/>
+            <a:off x="4038600" y="6356354"/>
             <a:ext cx="4114800" cy="365125"/>
           </a:xfrm>
           <a:prstGeom prst="rect">
@@ -6019,7 +5987,7 @@
         </p:nvSpPr>
         <p:spPr>
           <a:xfrm>
-            <a:off x="8610600" y="6356350"/>
+            <a:off x="8610600" y="6356354"/>
             <a:ext cx="2743200" cy="365125"/>
           </a:xfrm>
           <a:prstGeom prst="rect">
@@ -6100,20 +6068,12 @@
             </a:lvl9pPr>
           </a:lstStyle>
           <a:p>
-            <a:pPr marL="0" lvl="0" indent="0" algn="r" rtl="0">
-              <a:spcBef>
-                <a:spcPts val="0"/>
-              </a:spcBef>
-              <a:spcAft>
-                <a:spcPts val="0"/>
-              </a:spcAft>
-              <a:buNone/>
-            </a:pPr>
             <a:fld id="{00000000-1234-1234-1234-123412341234}" type="slidenum">
-              <a:rPr lang="es-CO"/>
+              <a:rPr lang="es-CO" smtClean="0"/>
+              <a:pPr/>
               <a:t>‹Nº›</a:t>
             </a:fld>
-            <a:endParaRPr/>
+            <a:endParaRPr lang="es-CO"/>
           </a:p>
         </p:txBody>
       </p:sp>
@@ -6154,7 +6114,7 @@
         </p:nvSpPr>
         <p:spPr>
           <a:xfrm>
-            <a:off x="838200" y="365125"/>
+            <a:off x="838200" y="365129"/>
             <a:ext cx="10515600" cy="1325563"/>
           </a:xfrm>
           <a:prstGeom prst="rect">
@@ -6309,7 +6269,7 @@
             <a:normAutofit/>
           </a:bodyPr>
           <a:lstStyle>
-            <a:lvl1pPr marL="457200" lvl="0" indent="-342900" algn="l">
+            <a:lvl1pPr marL="457189" lvl="0" indent="-342891" algn="l">
               <a:lnSpc>
                 <a:spcPct val="90000"/>
               </a:lnSpc>
@@ -6326,7 +6286,7 @@
               <a:buChar char="•"/>
               <a:defRPr/>
             </a:lvl1pPr>
-            <a:lvl2pPr marL="914400" lvl="1" indent="-342900" algn="l">
+            <a:lvl2pPr marL="914377" lvl="1" indent="-342891" algn="l">
               <a:lnSpc>
                 <a:spcPct val="90000"/>
               </a:lnSpc>
@@ -6343,7 +6303,7 @@
               <a:buChar char="•"/>
               <a:defRPr/>
             </a:lvl2pPr>
-            <a:lvl3pPr marL="1371600" lvl="2" indent="-342900" algn="l">
+            <a:lvl3pPr marL="1371566" lvl="2" indent="-342891" algn="l">
               <a:lnSpc>
                 <a:spcPct val="90000"/>
               </a:lnSpc>
@@ -6360,7 +6320,7 @@
               <a:buChar char="•"/>
               <a:defRPr/>
             </a:lvl3pPr>
-            <a:lvl4pPr marL="1828800" lvl="3" indent="-342900" algn="l">
+            <a:lvl4pPr marL="1828754" lvl="3" indent="-342891" algn="l">
               <a:lnSpc>
                 <a:spcPct val="90000"/>
               </a:lnSpc>
@@ -6377,7 +6337,7 @@
               <a:buChar char="•"/>
               <a:defRPr/>
             </a:lvl4pPr>
-            <a:lvl5pPr marL="2286000" lvl="4" indent="-342900" algn="l">
+            <a:lvl5pPr marL="2285943" lvl="4" indent="-342891" algn="l">
               <a:lnSpc>
                 <a:spcPct val="90000"/>
               </a:lnSpc>
@@ -6394,7 +6354,7 @@
               <a:buChar char="•"/>
               <a:defRPr/>
             </a:lvl5pPr>
-            <a:lvl6pPr marL="2743200" lvl="5" indent="-342900" algn="l">
+            <a:lvl6pPr marL="2743131" lvl="5" indent="-342891" algn="l">
               <a:lnSpc>
                 <a:spcPct val="90000"/>
               </a:lnSpc>
@@ -6411,7 +6371,7 @@
               <a:buChar char="•"/>
               <a:defRPr/>
             </a:lvl6pPr>
-            <a:lvl7pPr marL="3200400" lvl="6" indent="-342900" algn="l">
+            <a:lvl7pPr marL="3200320" lvl="6" indent="-342891" algn="l">
               <a:lnSpc>
                 <a:spcPct val="90000"/>
               </a:lnSpc>
@@ -6428,7 +6388,7 @@
               <a:buChar char="•"/>
               <a:defRPr/>
             </a:lvl7pPr>
-            <a:lvl8pPr marL="3657600" lvl="7" indent="-342900" algn="l">
+            <a:lvl8pPr marL="3657509" lvl="7" indent="-342891" algn="l">
               <a:lnSpc>
                 <a:spcPct val="90000"/>
               </a:lnSpc>
@@ -6445,7 +6405,7 @@
               <a:buChar char="•"/>
               <a:defRPr/>
             </a:lvl8pPr>
-            <a:lvl9pPr marL="4114800" lvl="8" indent="-342900" algn="l">
+            <a:lvl9pPr marL="4114697" lvl="8" indent="-342891" algn="l">
               <a:lnSpc>
                 <a:spcPct val="90000"/>
               </a:lnSpc>
@@ -6480,7 +6440,7 @@
         </p:nvSpPr>
         <p:spPr>
           <a:xfrm>
-            <a:off x="838200" y="6356350"/>
+            <a:off x="838200" y="6356354"/>
             <a:ext cx="2743200" cy="365125"/>
           </a:xfrm>
           <a:prstGeom prst="rect">
@@ -6613,7 +6573,7 @@
         </p:nvSpPr>
         <p:spPr>
           <a:xfrm>
-            <a:off x="4038600" y="6356350"/>
+            <a:off x="4038600" y="6356354"/>
             <a:ext cx="4114800" cy="365125"/>
           </a:xfrm>
           <a:prstGeom prst="rect">
@@ -6746,7 +6706,7 @@
         </p:nvSpPr>
         <p:spPr>
           <a:xfrm>
-            <a:off x="8610600" y="6356350"/>
+            <a:off x="8610600" y="6356354"/>
             <a:ext cx="2743200" cy="365125"/>
           </a:xfrm>
           <a:prstGeom prst="rect">
@@ -6827,20 +6787,12 @@
             </a:lvl9pPr>
           </a:lstStyle>
           <a:p>
-            <a:pPr marL="0" lvl="0" indent="0" algn="r" rtl="0">
-              <a:spcBef>
-                <a:spcPts val="0"/>
-              </a:spcBef>
-              <a:spcAft>
-                <a:spcPts val="0"/>
-              </a:spcAft>
-              <a:buNone/>
-            </a:pPr>
             <a:fld id="{00000000-1234-1234-1234-123412341234}" type="slidenum">
-              <a:rPr lang="es-CO"/>
+              <a:rPr lang="es-CO" smtClean="0"/>
+              <a:pPr/>
               <a:t>‹Nº›</a:t>
             </a:fld>
-            <a:endParaRPr/>
+            <a:endParaRPr lang="es-CO"/>
           </a:p>
         </p:txBody>
       </p:sp>
@@ -6881,7 +6833,7 @@
         </p:nvSpPr>
         <p:spPr>
           <a:xfrm>
-            <a:off x="831850" y="1709738"/>
+            <a:off x="831851" y="1709742"/>
             <a:ext cx="10515600" cy="2852737"/>
           </a:xfrm>
           <a:prstGeom prst="rect">
@@ -7021,7 +6973,7 @@
         </p:nvSpPr>
         <p:spPr>
           <a:xfrm>
-            <a:off x="831850" y="4589463"/>
+            <a:off x="831851" y="4589467"/>
             <a:ext cx="10515600" cy="1500187"/>
           </a:xfrm>
           <a:prstGeom prst="rect">
@@ -7037,7 +6989,7 @@
             <a:normAutofit/>
           </a:bodyPr>
           <a:lstStyle>
-            <a:lvl1pPr marL="457200" lvl="0" indent="-228600" algn="l">
+            <a:lvl1pPr marL="457189" lvl="0" indent="-228594" algn="l">
               <a:lnSpc>
                 <a:spcPct val="90000"/>
               </a:lnSpc>
@@ -7058,7 +7010,7 @@
                 </a:solidFill>
               </a:defRPr>
             </a:lvl1pPr>
-            <a:lvl2pPr marL="914400" lvl="1" indent="-228600" algn="l">
+            <a:lvl2pPr marL="914377" lvl="1" indent="-228594" algn="l">
               <a:lnSpc>
                 <a:spcPct val="90000"/>
               </a:lnSpc>
@@ -7079,7 +7031,7 @@
                 </a:solidFill>
               </a:defRPr>
             </a:lvl2pPr>
-            <a:lvl3pPr marL="1371600" lvl="2" indent="-228600" algn="l">
+            <a:lvl3pPr marL="1371566" lvl="2" indent="-228594" algn="l">
               <a:lnSpc>
                 <a:spcPct val="90000"/>
               </a:lnSpc>
@@ -7100,7 +7052,7 @@
                 </a:solidFill>
               </a:defRPr>
             </a:lvl3pPr>
-            <a:lvl4pPr marL="1828800" lvl="3" indent="-228600" algn="l">
+            <a:lvl4pPr marL="1828754" lvl="3" indent="-228594" algn="l">
               <a:lnSpc>
                 <a:spcPct val="90000"/>
               </a:lnSpc>
@@ -7121,7 +7073,7 @@
                 </a:solidFill>
               </a:defRPr>
             </a:lvl4pPr>
-            <a:lvl5pPr marL="2286000" lvl="4" indent="-228600" algn="l">
+            <a:lvl5pPr marL="2285943" lvl="4" indent="-228594" algn="l">
               <a:lnSpc>
                 <a:spcPct val="90000"/>
               </a:lnSpc>
@@ -7142,7 +7094,7 @@
                 </a:solidFill>
               </a:defRPr>
             </a:lvl5pPr>
-            <a:lvl6pPr marL="2743200" lvl="5" indent="-228600" algn="l">
+            <a:lvl6pPr marL="2743131" lvl="5" indent="-228594" algn="l">
               <a:lnSpc>
                 <a:spcPct val="90000"/>
               </a:lnSpc>
@@ -7163,7 +7115,7 @@
                 </a:solidFill>
               </a:defRPr>
             </a:lvl6pPr>
-            <a:lvl7pPr marL="3200400" lvl="6" indent="-228600" algn="l">
+            <a:lvl7pPr marL="3200320" lvl="6" indent="-228594" algn="l">
               <a:lnSpc>
                 <a:spcPct val="90000"/>
               </a:lnSpc>
@@ -7184,7 +7136,7 @@
                 </a:solidFill>
               </a:defRPr>
             </a:lvl7pPr>
-            <a:lvl8pPr marL="3657600" lvl="7" indent="-228600" algn="l">
+            <a:lvl8pPr marL="3657509" lvl="7" indent="-228594" algn="l">
               <a:lnSpc>
                 <a:spcPct val="90000"/>
               </a:lnSpc>
@@ -7205,7 +7157,7 @@
                 </a:solidFill>
               </a:defRPr>
             </a:lvl8pPr>
-            <a:lvl9pPr marL="4114800" lvl="8" indent="-228600" algn="l">
+            <a:lvl9pPr marL="4114697" lvl="8" indent="-228594" algn="l">
               <a:lnSpc>
                 <a:spcPct val="90000"/>
               </a:lnSpc>
@@ -7244,7 +7196,7 @@
         </p:nvSpPr>
         <p:spPr>
           <a:xfrm>
-            <a:off x="838200" y="6356350"/>
+            <a:off x="838200" y="6356354"/>
             <a:ext cx="2743200" cy="365125"/>
           </a:xfrm>
           <a:prstGeom prst="rect">
@@ -7377,7 +7329,7 @@
         </p:nvSpPr>
         <p:spPr>
           <a:xfrm>
-            <a:off x="4038600" y="6356350"/>
+            <a:off x="4038600" y="6356354"/>
             <a:ext cx="4114800" cy="365125"/>
           </a:xfrm>
           <a:prstGeom prst="rect">
@@ -7510,7 +7462,7 @@
         </p:nvSpPr>
         <p:spPr>
           <a:xfrm>
-            <a:off x="8610600" y="6356350"/>
+            <a:off x="8610600" y="6356354"/>
             <a:ext cx="2743200" cy="365125"/>
           </a:xfrm>
           <a:prstGeom prst="rect">
@@ -7591,20 +7543,12 @@
             </a:lvl9pPr>
           </a:lstStyle>
           <a:p>
-            <a:pPr marL="0" lvl="0" indent="0" algn="r" rtl="0">
-              <a:spcBef>
-                <a:spcPts val="0"/>
-              </a:spcBef>
-              <a:spcAft>
-                <a:spcPts val="0"/>
-              </a:spcAft>
-              <a:buNone/>
-            </a:pPr>
             <a:fld id="{00000000-1234-1234-1234-123412341234}" type="slidenum">
-              <a:rPr lang="es-CO"/>
+              <a:rPr lang="es-CO" smtClean="0"/>
+              <a:pPr/>
               <a:t>‹Nº›</a:t>
             </a:fld>
-            <a:endParaRPr/>
+            <a:endParaRPr lang="es-CO"/>
           </a:p>
         </p:txBody>
       </p:sp>
@@ -7645,7 +7589,7 @@
         </p:nvSpPr>
         <p:spPr>
           <a:xfrm>
-            <a:off x="838200" y="365125"/>
+            <a:off x="838200" y="365129"/>
             <a:ext cx="10515600" cy="1325563"/>
           </a:xfrm>
           <a:prstGeom prst="rect">
@@ -7800,7 +7744,7 @@
             <a:normAutofit/>
           </a:bodyPr>
           <a:lstStyle>
-            <a:lvl1pPr marL="457200" lvl="0" indent="-342900" algn="l">
+            <a:lvl1pPr marL="457189" lvl="0" indent="-342891" algn="l">
               <a:lnSpc>
                 <a:spcPct val="90000"/>
               </a:lnSpc>
@@ -7817,7 +7761,7 @@
               <a:buChar char="•"/>
               <a:defRPr/>
             </a:lvl1pPr>
-            <a:lvl2pPr marL="914400" lvl="1" indent="-342900" algn="l">
+            <a:lvl2pPr marL="914377" lvl="1" indent="-342891" algn="l">
               <a:lnSpc>
                 <a:spcPct val="90000"/>
               </a:lnSpc>
@@ -7834,7 +7778,7 @@
               <a:buChar char="•"/>
               <a:defRPr/>
             </a:lvl2pPr>
-            <a:lvl3pPr marL="1371600" lvl="2" indent="-342900" algn="l">
+            <a:lvl3pPr marL="1371566" lvl="2" indent="-342891" algn="l">
               <a:lnSpc>
                 <a:spcPct val="90000"/>
               </a:lnSpc>
@@ -7851,7 +7795,7 @@
               <a:buChar char="•"/>
               <a:defRPr/>
             </a:lvl3pPr>
-            <a:lvl4pPr marL="1828800" lvl="3" indent="-342900" algn="l">
+            <a:lvl4pPr marL="1828754" lvl="3" indent="-342891" algn="l">
               <a:lnSpc>
                 <a:spcPct val="90000"/>
               </a:lnSpc>
@@ -7868,7 +7812,7 @@
               <a:buChar char="•"/>
               <a:defRPr/>
             </a:lvl4pPr>
-            <a:lvl5pPr marL="2286000" lvl="4" indent="-342900" algn="l">
+            <a:lvl5pPr marL="2285943" lvl="4" indent="-342891" algn="l">
               <a:lnSpc>
                 <a:spcPct val="90000"/>
               </a:lnSpc>
@@ -7885,7 +7829,7 @@
               <a:buChar char="•"/>
               <a:defRPr/>
             </a:lvl5pPr>
-            <a:lvl6pPr marL="2743200" lvl="5" indent="-342900" algn="l">
+            <a:lvl6pPr marL="2743131" lvl="5" indent="-342891" algn="l">
               <a:lnSpc>
                 <a:spcPct val="90000"/>
               </a:lnSpc>
@@ -7902,7 +7846,7 @@
               <a:buChar char="•"/>
               <a:defRPr/>
             </a:lvl6pPr>
-            <a:lvl7pPr marL="3200400" lvl="6" indent="-342900" algn="l">
+            <a:lvl7pPr marL="3200320" lvl="6" indent="-342891" algn="l">
               <a:lnSpc>
                 <a:spcPct val="90000"/>
               </a:lnSpc>
@@ -7919,7 +7863,7 @@
               <a:buChar char="•"/>
               <a:defRPr/>
             </a:lvl7pPr>
-            <a:lvl8pPr marL="3657600" lvl="7" indent="-342900" algn="l">
+            <a:lvl8pPr marL="3657509" lvl="7" indent="-342891" algn="l">
               <a:lnSpc>
                 <a:spcPct val="90000"/>
               </a:lnSpc>
@@ -7936,7 +7880,7 @@
               <a:buChar char="•"/>
               <a:defRPr/>
             </a:lvl8pPr>
-            <a:lvl9pPr marL="4114800" lvl="8" indent="-342900" algn="l">
+            <a:lvl9pPr marL="4114697" lvl="8" indent="-342891" algn="l">
               <a:lnSpc>
                 <a:spcPct val="90000"/>
               </a:lnSpc>
@@ -7987,7 +7931,7 @@
             <a:normAutofit/>
           </a:bodyPr>
           <a:lstStyle>
-            <a:lvl1pPr marL="457200" lvl="0" indent="-342900" algn="l">
+            <a:lvl1pPr marL="457189" lvl="0" indent="-342891" algn="l">
               <a:lnSpc>
                 <a:spcPct val="90000"/>
               </a:lnSpc>
@@ -8004,7 +7948,7 @@
               <a:buChar char="•"/>
               <a:defRPr/>
             </a:lvl1pPr>
-            <a:lvl2pPr marL="914400" lvl="1" indent="-342900" algn="l">
+            <a:lvl2pPr marL="914377" lvl="1" indent="-342891" algn="l">
               <a:lnSpc>
                 <a:spcPct val="90000"/>
               </a:lnSpc>
@@ -8021,7 +7965,7 @@
               <a:buChar char="•"/>
               <a:defRPr/>
             </a:lvl2pPr>
-            <a:lvl3pPr marL="1371600" lvl="2" indent="-342900" algn="l">
+            <a:lvl3pPr marL="1371566" lvl="2" indent="-342891" algn="l">
               <a:lnSpc>
                 <a:spcPct val="90000"/>
               </a:lnSpc>
@@ -8038,7 +7982,7 @@
               <a:buChar char="•"/>
               <a:defRPr/>
             </a:lvl3pPr>
-            <a:lvl4pPr marL="1828800" lvl="3" indent="-342900" algn="l">
+            <a:lvl4pPr marL="1828754" lvl="3" indent="-342891" algn="l">
               <a:lnSpc>
                 <a:spcPct val="90000"/>
               </a:lnSpc>
@@ -8055,7 +7999,7 @@
               <a:buChar char="•"/>
               <a:defRPr/>
             </a:lvl4pPr>
-            <a:lvl5pPr marL="2286000" lvl="4" indent="-342900" algn="l">
+            <a:lvl5pPr marL="2285943" lvl="4" indent="-342891" algn="l">
               <a:lnSpc>
                 <a:spcPct val="90000"/>
               </a:lnSpc>
@@ -8072,7 +8016,7 @@
               <a:buChar char="•"/>
               <a:defRPr/>
             </a:lvl5pPr>
-            <a:lvl6pPr marL="2743200" lvl="5" indent="-342900" algn="l">
+            <a:lvl6pPr marL="2743131" lvl="5" indent="-342891" algn="l">
               <a:lnSpc>
                 <a:spcPct val="90000"/>
               </a:lnSpc>
@@ -8089,7 +8033,7 @@
               <a:buChar char="•"/>
               <a:defRPr/>
             </a:lvl6pPr>
-            <a:lvl7pPr marL="3200400" lvl="6" indent="-342900" algn="l">
+            <a:lvl7pPr marL="3200320" lvl="6" indent="-342891" algn="l">
               <a:lnSpc>
                 <a:spcPct val="90000"/>
               </a:lnSpc>
@@ -8106,7 +8050,7 @@
               <a:buChar char="•"/>
               <a:defRPr/>
             </a:lvl7pPr>
-            <a:lvl8pPr marL="3657600" lvl="7" indent="-342900" algn="l">
+            <a:lvl8pPr marL="3657509" lvl="7" indent="-342891" algn="l">
               <a:lnSpc>
                 <a:spcPct val="90000"/>
               </a:lnSpc>
@@ -8123,7 +8067,7 @@
               <a:buChar char="•"/>
               <a:defRPr/>
             </a:lvl8pPr>
-            <a:lvl9pPr marL="4114800" lvl="8" indent="-342900" algn="l">
+            <a:lvl9pPr marL="4114697" lvl="8" indent="-342891" algn="l">
               <a:lnSpc>
                 <a:spcPct val="90000"/>
               </a:lnSpc>
@@ -8158,7 +8102,7 @@
         </p:nvSpPr>
         <p:spPr>
           <a:xfrm>
-            <a:off x="838200" y="6356350"/>
+            <a:off x="838200" y="6356354"/>
             <a:ext cx="2743200" cy="365125"/>
           </a:xfrm>
           <a:prstGeom prst="rect">
@@ -8291,7 +8235,7 @@
         </p:nvSpPr>
         <p:spPr>
           <a:xfrm>
-            <a:off x="4038600" y="6356350"/>
+            <a:off x="4038600" y="6356354"/>
             <a:ext cx="4114800" cy="365125"/>
           </a:xfrm>
           <a:prstGeom prst="rect">
@@ -8424,7 +8368,7 @@
         </p:nvSpPr>
         <p:spPr>
           <a:xfrm>
-            <a:off x="8610600" y="6356350"/>
+            <a:off x="8610600" y="6356354"/>
             <a:ext cx="2743200" cy="365125"/>
           </a:xfrm>
           <a:prstGeom prst="rect">
@@ -8505,20 +8449,12 @@
             </a:lvl9pPr>
           </a:lstStyle>
           <a:p>
-            <a:pPr marL="0" lvl="0" indent="0" algn="r" rtl="0">
-              <a:spcBef>
-                <a:spcPts val="0"/>
-              </a:spcBef>
-              <a:spcAft>
-                <a:spcPts val="0"/>
-              </a:spcAft>
-              <a:buNone/>
-            </a:pPr>
             <a:fld id="{00000000-1234-1234-1234-123412341234}" type="slidenum">
-              <a:rPr lang="es-CO"/>
+              <a:rPr lang="es-CO" smtClean="0"/>
+              <a:pPr/>
               <a:t>‹Nº›</a:t>
             </a:fld>
-            <a:endParaRPr/>
+            <a:endParaRPr lang="es-CO"/>
           </a:p>
         </p:txBody>
       </p:sp>
@@ -8559,7 +8495,7 @@
         </p:nvSpPr>
         <p:spPr>
           <a:xfrm>
-            <a:off x="839788" y="365125"/>
+            <a:off x="839788" y="365129"/>
             <a:ext cx="10515600" cy="1325563"/>
           </a:xfrm>
           <a:prstGeom prst="rect">
@@ -8698,7 +8634,7 @@
         </p:nvSpPr>
         <p:spPr>
           <a:xfrm>
-            <a:off x="839788" y="1681163"/>
+            <a:off x="839789" y="1681163"/>
             <a:ext cx="5157787" cy="823912"/>
           </a:xfrm>
           <a:prstGeom prst="rect">
@@ -8714,7 +8650,7 @@
             <a:normAutofit/>
           </a:bodyPr>
           <a:lstStyle>
-            <a:lvl1pPr marL="457200" lvl="0" indent="-228600" algn="l">
+            <a:lvl1pPr marL="457189" lvl="0" indent="-228594" algn="l">
               <a:lnSpc>
                 <a:spcPct val="90000"/>
               </a:lnSpc>
@@ -8731,7 +8667,7 @@
               <a:buNone/>
               <a:defRPr sz="2400" b="1"/>
             </a:lvl1pPr>
-            <a:lvl2pPr marL="914400" lvl="1" indent="-228600" algn="l">
+            <a:lvl2pPr marL="914377" lvl="1" indent="-228594" algn="l">
               <a:lnSpc>
                 <a:spcPct val="90000"/>
               </a:lnSpc>
@@ -8748,7 +8684,7 @@
               <a:buNone/>
               <a:defRPr sz="2000" b="1"/>
             </a:lvl2pPr>
-            <a:lvl3pPr marL="1371600" lvl="2" indent="-228600" algn="l">
+            <a:lvl3pPr marL="1371566" lvl="2" indent="-228594" algn="l">
               <a:lnSpc>
                 <a:spcPct val="90000"/>
               </a:lnSpc>
@@ -8765,7 +8701,7 @@
               <a:buNone/>
               <a:defRPr sz="1800" b="1"/>
             </a:lvl3pPr>
-            <a:lvl4pPr marL="1828800" lvl="3" indent="-228600" algn="l">
+            <a:lvl4pPr marL="1828754" lvl="3" indent="-228594" algn="l">
               <a:lnSpc>
                 <a:spcPct val="90000"/>
               </a:lnSpc>
@@ -8782,7 +8718,7 @@
               <a:buNone/>
               <a:defRPr sz="1600" b="1"/>
             </a:lvl4pPr>
-            <a:lvl5pPr marL="2286000" lvl="4" indent="-228600" algn="l">
+            <a:lvl5pPr marL="2285943" lvl="4" indent="-228594" algn="l">
               <a:lnSpc>
                 <a:spcPct val="90000"/>
               </a:lnSpc>
@@ -8799,7 +8735,7 @@
               <a:buNone/>
               <a:defRPr sz="1600" b="1"/>
             </a:lvl5pPr>
-            <a:lvl6pPr marL="2743200" lvl="5" indent="-228600" algn="l">
+            <a:lvl6pPr marL="2743131" lvl="5" indent="-228594" algn="l">
               <a:lnSpc>
                 <a:spcPct val="90000"/>
               </a:lnSpc>
@@ -8816,7 +8752,7 @@
               <a:buNone/>
               <a:defRPr sz="1600" b="1"/>
             </a:lvl6pPr>
-            <a:lvl7pPr marL="3200400" lvl="6" indent="-228600" algn="l">
+            <a:lvl7pPr marL="3200320" lvl="6" indent="-228594" algn="l">
               <a:lnSpc>
                 <a:spcPct val="90000"/>
               </a:lnSpc>
@@ -8833,7 +8769,7 @@
               <a:buNone/>
               <a:defRPr sz="1600" b="1"/>
             </a:lvl7pPr>
-            <a:lvl8pPr marL="3657600" lvl="7" indent="-228600" algn="l">
+            <a:lvl8pPr marL="3657509" lvl="7" indent="-228594" algn="l">
               <a:lnSpc>
                 <a:spcPct val="90000"/>
               </a:lnSpc>
@@ -8850,7 +8786,7 @@
               <a:buNone/>
               <a:defRPr sz="1600" b="1"/>
             </a:lvl8pPr>
-            <a:lvl9pPr marL="4114800" lvl="8" indent="-228600" algn="l">
+            <a:lvl9pPr marL="4114697" lvl="8" indent="-228594" algn="l">
               <a:lnSpc>
                 <a:spcPct val="90000"/>
               </a:lnSpc>
@@ -8885,7 +8821,7 @@
         </p:nvSpPr>
         <p:spPr>
           <a:xfrm>
-            <a:off x="839788" y="2505075"/>
+            <a:off x="839789" y="2505075"/>
             <a:ext cx="5157787" cy="3684588"/>
           </a:xfrm>
           <a:prstGeom prst="rect">
@@ -8901,7 +8837,7 @@
             <a:normAutofit/>
           </a:bodyPr>
           <a:lstStyle>
-            <a:lvl1pPr marL="457200" lvl="0" indent="-342900" algn="l">
+            <a:lvl1pPr marL="457189" lvl="0" indent="-342891" algn="l">
               <a:lnSpc>
                 <a:spcPct val="90000"/>
               </a:lnSpc>
@@ -8918,7 +8854,7 @@
               <a:buChar char="•"/>
               <a:defRPr/>
             </a:lvl1pPr>
-            <a:lvl2pPr marL="914400" lvl="1" indent="-342900" algn="l">
+            <a:lvl2pPr marL="914377" lvl="1" indent="-342891" algn="l">
               <a:lnSpc>
                 <a:spcPct val="90000"/>
               </a:lnSpc>
@@ -8935,7 +8871,7 @@
               <a:buChar char="•"/>
               <a:defRPr/>
             </a:lvl2pPr>
-            <a:lvl3pPr marL="1371600" lvl="2" indent="-342900" algn="l">
+            <a:lvl3pPr marL="1371566" lvl="2" indent="-342891" algn="l">
               <a:lnSpc>
                 <a:spcPct val="90000"/>
               </a:lnSpc>
@@ -8952,7 +8888,7 @@
               <a:buChar char="•"/>
               <a:defRPr/>
             </a:lvl3pPr>
-            <a:lvl4pPr marL="1828800" lvl="3" indent="-342900" algn="l">
+            <a:lvl4pPr marL="1828754" lvl="3" indent="-342891" algn="l">
               <a:lnSpc>
                 <a:spcPct val="90000"/>
               </a:lnSpc>
@@ -8969,7 +8905,7 @@
               <a:buChar char="•"/>
               <a:defRPr/>
             </a:lvl4pPr>
-            <a:lvl5pPr marL="2286000" lvl="4" indent="-342900" algn="l">
+            <a:lvl5pPr marL="2285943" lvl="4" indent="-342891" algn="l">
               <a:lnSpc>
                 <a:spcPct val="90000"/>
               </a:lnSpc>
@@ -8986,7 +8922,7 @@
               <a:buChar char="•"/>
               <a:defRPr/>
             </a:lvl5pPr>
-            <a:lvl6pPr marL="2743200" lvl="5" indent="-342900" algn="l">
+            <a:lvl6pPr marL="2743131" lvl="5" indent="-342891" algn="l">
               <a:lnSpc>
                 <a:spcPct val="90000"/>
               </a:lnSpc>
@@ -9003,7 +8939,7 @@
               <a:buChar char="•"/>
               <a:defRPr/>
             </a:lvl6pPr>
-            <a:lvl7pPr marL="3200400" lvl="6" indent="-342900" algn="l">
+            <a:lvl7pPr marL="3200320" lvl="6" indent="-342891" algn="l">
               <a:lnSpc>
                 <a:spcPct val="90000"/>
               </a:lnSpc>
@@ -9020,7 +8956,7 @@
               <a:buChar char="•"/>
               <a:defRPr/>
             </a:lvl7pPr>
-            <a:lvl8pPr marL="3657600" lvl="7" indent="-342900" algn="l">
+            <a:lvl8pPr marL="3657509" lvl="7" indent="-342891" algn="l">
               <a:lnSpc>
                 <a:spcPct val="90000"/>
               </a:lnSpc>
@@ -9037,7 +8973,7 @@
               <a:buChar char="•"/>
               <a:defRPr/>
             </a:lvl8pPr>
-            <a:lvl9pPr marL="4114800" lvl="8" indent="-342900" algn="l">
+            <a:lvl9pPr marL="4114697" lvl="8" indent="-342891" algn="l">
               <a:lnSpc>
                 <a:spcPct val="90000"/>
               </a:lnSpc>
@@ -9072,7 +9008,7 @@
         </p:nvSpPr>
         <p:spPr>
           <a:xfrm>
-            <a:off x="6172200" y="1681163"/>
+            <a:off x="6172202" y="1681163"/>
             <a:ext cx="5183188" cy="823912"/>
           </a:xfrm>
           <a:prstGeom prst="rect">
@@ -9088,7 +9024,7 @@
             <a:normAutofit/>
           </a:bodyPr>
           <a:lstStyle>
-            <a:lvl1pPr marL="457200" lvl="0" indent="-228600" algn="l">
+            <a:lvl1pPr marL="457189" lvl="0" indent="-228594" algn="l">
               <a:lnSpc>
                 <a:spcPct val="90000"/>
               </a:lnSpc>
@@ -9105,7 +9041,7 @@
               <a:buNone/>
               <a:defRPr sz="2400" b="1"/>
             </a:lvl1pPr>
-            <a:lvl2pPr marL="914400" lvl="1" indent="-228600" algn="l">
+            <a:lvl2pPr marL="914377" lvl="1" indent="-228594" algn="l">
               <a:lnSpc>
                 <a:spcPct val="90000"/>
               </a:lnSpc>
@@ -9122,7 +9058,7 @@
               <a:buNone/>
               <a:defRPr sz="2000" b="1"/>
             </a:lvl2pPr>
-            <a:lvl3pPr marL="1371600" lvl="2" indent="-228600" algn="l">
+            <a:lvl3pPr marL="1371566" lvl="2" indent="-228594" algn="l">
               <a:lnSpc>
                 <a:spcPct val="90000"/>
               </a:lnSpc>
@@ -9139,7 +9075,7 @@
               <a:buNone/>
               <a:defRPr sz="1800" b="1"/>
             </a:lvl3pPr>
-            <a:lvl4pPr marL="1828800" lvl="3" indent="-228600" algn="l">
+            <a:lvl4pPr marL="1828754" lvl="3" indent="-228594" algn="l">
               <a:lnSpc>
                 <a:spcPct val="90000"/>
               </a:lnSpc>
@@ -9156,7 +9092,7 @@
               <a:buNone/>
               <a:defRPr sz="1600" b="1"/>
             </a:lvl4pPr>
-            <a:lvl5pPr marL="2286000" lvl="4" indent="-228600" algn="l">
+            <a:lvl5pPr marL="2285943" lvl="4" indent="-228594" algn="l">
               <a:lnSpc>
                 <a:spcPct val="90000"/>
               </a:lnSpc>
@@ -9173,7 +9109,7 @@
               <a:buNone/>
               <a:defRPr sz="1600" b="1"/>
             </a:lvl5pPr>
-            <a:lvl6pPr marL="2743200" lvl="5" indent="-228600" algn="l">
+            <a:lvl6pPr marL="2743131" lvl="5" indent="-228594" algn="l">
               <a:lnSpc>
                 <a:spcPct val="90000"/>
               </a:lnSpc>
@@ -9190,7 +9126,7 @@
               <a:buNone/>
               <a:defRPr sz="1600" b="1"/>
             </a:lvl6pPr>
-            <a:lvl7pPr marL="3200400" lvl="6" indent="-228600" algn="l">
+            <a:lvl7pPr marL="3200320" lvl="6" indent="-228594" algn="l">
               <a:lnSpc>
                 <a:spcPct val="90000"/>
               </a:lnSpc>
@@ -9207,7 +9143,7 @@
               <a:buNone/>
               <a:defRPr sz="1600" b="1"/>
             </a:lvl7pPr>
-            <a:lvl8pPr marL="3657600" lvl="7" indent="-228600" algn="l">
+            <a:lvl8pPr marL="3657509" lvl="7" indent="-228594" algn="l">
               <a:lnSpc>
                 <a:spcPct val="90000"/>
               </a:lnSpc>
@@ -9224,7 +9160,7 @@
               <a:buNone/>
               <a:defRPr sz="1600" b="1"/>
             </a:lvl8pPr>
-            <a:lvl9pPr marL="4114800" lvl="8" indent="-228600" algn="l">
+            <a:lvl9pPr marL="4114697" lvl="8" indent="-228594" algn="l">
               <a:lnSpc>
                 <a:spcPct val="90000"/>
               </a:lnSpc>
@@ -9259,7 +9195,7 @@
         </p:nvSpPr>
         <p:spPr>
           <a:xfrm>
-            <a:off x="6172200" y="2505075"/>
+            <a:off x="6172202" y="2505075"/>
             <a:ext cx="5183188" cy="3684588"/>
           </a:xfrm>
           <a:prstGeom prst="rect">
@@ -9275,7 +9211,7 @@
             <a:normAutofit/>
           </a:bodyPr>
           <a:lstStyle>
-            <a:lvl1pPr marL="457200" lvl="0" indent="-342900" algn="l">
+            <a:lvl1pPr marL="457189" lvl="0" indent="-342891" algn="l">
               <a:lnSpc>
                 <a:spcPct val="90000"/>
               </a:lnSpc>
@@ -9292,7 +9228,7 @@
               <a:buChar char="•"/>
               <a:defRPr/>
             </a:lvl1pPr>
-            <a:lvl2pPr marL="914400" lvl="1" indent="-342900" algn="l">
+            <a:lvl2pPr marL="914377" lvl="1" indent="-342891" algn="l">
               <a:lnSpc>
                 <a:spcPct val="90000"/>
               </a:lnSpc>
@@ -9309,7 +9245,7 @@
               <a:buChar char="•"/>
               <a:defRPr/>
             </a:lvl2pPr>
-            <a:lvl3pPr marL="1371600" lvl="2" indent="-342900" algn="l">
+            <a:lvl3pPr marL="1371566" lvl="2" indent="-342891" algn="l">
               <a:lnSpc>
                 <a:spcPct val="90000"/>
               </a:lnSpc>
@@ -9326,7 +9262,7 @@
               <a:buChar char="•"/>
               <a:defRPr/>
             </a:lvl3pPr>
-            <a:lvl4pPr marL="1828800" lvl="3" indent="-342900" algn="l">
+            <a:lvl4pPr marL="1828754" lvl="3" indent="-342891" algn="l">
               <a:lnSpc>
                 <a:spcPct val="90000"/>
               </a:lnSpc>
@@ -9343,7 +9279,7 @@
               <a:buChar char="•"/>
               <a:defRPr/>
             </a:lvl4pPr>
-            <a:lvl5pPr marL="2286000" lvl="4" indent="-342900" algn="l">
+            <a:lvl5pPr marL="2285943" lvl="4" indent="-342891" algn="l">
               <a:lnSpc>
                 <a:spcPct val="90000"/>
               </a:lnSpc>
@@ -9360,7 +9296,7 @@
               <a:buChar char="•"/>
               <a:defRPr/>
             </a:lvl5pPr>
-            <a:lvl6pPr marL="2743200" lvl="5" indent="-342900" algn="l">
+            <a:lvl6pPr marL="2743131" lvl="5" indent="-342891" algn="l">
               <a:lnSpc>
                 <a:spcPct val="90000"/>
               </a:lnSpc>
@@ -9377,7 +9313,7 @@
               <a:buChar char="•"/>
               <a:defRPr/>
             </a:lvl6pPr>
-            <a:lvl7pPr marL="3200400" lvl="6" indent="-342900" algn="l">
+            <a:lvl7pPr marL="3200320" lvl="6" indent="-342891" algn="l">
               <a:lnSpc>
                 <a:spcPct val="90000"/>
               </a:lnSpc>
@@ -9394,7 +9330,7 @@
               <a:buChar char="•"/>
               <a:defRPr/>
             </a:lvl7pPr>
-            <a:lvl8pPr marL="3657600" lvl="7" indent="-342900" algn="l">
+            <a:lvl8pPr marL="3657509" lvl="7" indent="-342891" algn="l">
               <a:lnSpc>
                 <a:spcPct val="90000"/>
               </a:lnSpc>
@@ -9411,7 +9347,7 @@
               <a:buChar char="•"/>
               <a:defRPr/>
             </a:lvl8pPr>
-            <a:lvl9pPr marL="4114800" lvl="8" indent="-342900" algn="l">
+            <a:lvl9pPr marL="4114697" lvl="8" indent="-342891" algn="l">
               <a:lnSpc>
                 <a:spcPct val="90000"/>
               </a:lnSpc>
@@ -9446,7 +9382,7 @@
         </p:nvSpPr>
         <p:spPr>
           <a:xfrm>
-            <a:off x="838200" y="6356350"/>
+            <a:off x="838200" y="6356354"/>
             <a:ext cx="2743200" cy="365125"/>
           </a:xfrm>
           <a:prstGeom prst="rect">
@@ -9579,7 +9515,7 @@
         </p:nvSpPr>
         <p:spPr>
           <a:xfrm>
-            <a:off x="4038600" y="6356350"/>
+            <a:off x="4038600" y="6356354"/>
             <a:ext cx="4114800" cy="365125"/>
           </a:xfrm>
           <a:prstGeom prst="rect">
@@ -9712,7 +9648,7 @@
         </p:nvSpPr>
         <p:spPr>
           <a:xfrm>
-            <a:off x="8610600" y="6356350"/>
+            <a:off x="8610600" y="6356354"/>
             <a:ext cx="2743200" cy="365125"/>
           </a:xfrm>
           <a:prstGeom prst="rect">
@@ -9793,20 +9729,12 @@
             </a:lvl9pPr>
           </a:lstStyle>
           <a:p>
-            <a:pPr marL="0" lvl="0" indent="0" algn="r" rtl="0">
-              <a:spcBef>
-                <a:spcPts val="0"/>
-              </a:spcBef>
-              <a:spcAft>
-                <a:spcPts val="0"/>
-              </a:spcAft>
-              <a:buNone/>
-            </a:pPr>
             <a:fld id="{00000000-1234-1234-1234-123412341234}" type="slidenum">
-              <a:rPr lang="es-CO"/>
+              <a:rPr lang="es-CO" smtClean="0"/>
+              <a:pPr/>
               <a:t>‹Nº›</a:t>
             </a:fld>
-            <a:endParaRPr/>
+            <a:endParaRPr lang="es-CO"/>
           </a:p>
         </p:txBody>
       </p:sp>
@@ -9847,7 +9775,7 @@
         </p:nvSpPr>
         <p:spPr>
           <a:xfrm>
-            <a:off x="838200" y="365125"/>
+            <a:off x="838200" y="365129"/>
             <a:ext cx="10515600" cy="1325563"/>
           </a:xfrm>
           <a:prstGeom prst="rect">
@@ -9986,7 +9914,7 @@
         </p:nvSpPr>
         <p:spPr>
           <a:xfrm>
-            <a:off x="838200" y="6356350"/>
+            <a:off x="838200" y="6356354"/>
             <a:ext cx="2743200" cy="365125"/>
           </a:xfrm>
           <a:prstGeom prst="rect">
@@ -10119,7 +10047,7 @@
         </p:nvSpPr>
         <p:spPr>
           <a:xfrm>
-            <a:off x="4038600" y="6356350"/>
+            <a:off x="4038600" y="6356354"/>
             <a:ext cx="4114800" cy="365125"/>
           </a:xfrm>
           <a:prstGeom prst="rect">
@@ -10252,7 +10180,7 @@
         </p:nvSpPr>
         <p:spPr>
           <a:xfrm>
-            <a:off x="8610600" y="6356350"/>
+            <a:off x="8610600" y="6356354"/>
             <a:ext cx="2743200" cy="365125"/>
           </a:xfrm>
           <a:prstGeom prst="rect">
@@ -10333,20 +10261,12 @@
             </a:lvl9pPr>
           </a:lstStyle>
           <a:p>
-            <a:pPr marL="0" lvl="0" indent="0" algn="r" rtl="0">
-              <a:spcBef>
-                <a:spcPts val="0"/>
-              </a:spcBef>
-              <a:spcAft>
-                <a:spcPts val="0"/>
-              </a:spcAft>
-              <a:buNone/>
-            </a:pPr>
             <a:fld id="{00000000-1234-1234-1234-123412341234}" type="slidenum">
-              <a:rPr lang="es-CO"/>
+              <a:rPr lang="es-CO" smtClean="0"/>
+              <a:pPr/>
               <a:t>‹Nº›</a:t>
             </a:fld>
-            <a:endParaRPr/>
+            <a:endParaRPr lang="es-CO"/>
           </a:p>
         </p:txBody>
       </p:sp>
@@ -10527,7 +10447,7 @@
         </p:nvSpPr>
         <p:spPr>
           <a:xfrm>
-            <a:off x="5183188" y="987425"/>
+            <a:off x="5183188" y="987429"/>
             <a:ext cx="6172200" cy="4873625"/>
           </a:xfrm>
           <a:prstGeom prst="rect">
@@ -10543,7 +10463,7 @@
             <a:normAutofit/>
           </a:bodyPr>
           <a:lstStyle>
-            <a:lvl1pPr marL="457200" lvl="0" indent="-431800" algn="l">
+            <a:lvl1pPr marL="457189" lvl="0" indent="-431789" algn="l">
               <a:lnSpc>
                 <a:spcPct val="90000"/>
               </a:lnSpc>
@@ -10560,7 +10480,7 @@
               <a:buChar char="•"/>
               <a:defRPr sz="3200"/>
             </a:lvl1pPr>
-            <a:lvl2pPr marL="914400" lvl="1" indent="-406400" algn="l">
+            <a:lvl2pPr marL="914377" lvl="1" indent="-406390" algn="l">
               <a:lnSpc>
                 <a:spcPct val="90000"/>
               </a:lnSpc>
@@ -10577,7 +10497,7 @@
               <a:buChar char="•"/>
               <a:defRPr sz="2800"/>
             </a:lvl2pPr>
-            <a:lvl3pPr marL="1371600" lvl="2" indent="-381000" algn="l">
+            <a:lvl3pPr marL="1371566" lvl="2" indent="-380990" algn="l">
               <a:lnSpc>
                 <a:spcPct val="90000"/>
               </a:lnSpc>
@@ -10594,7 +10514,7 @@
               <a:buChar char="•"/>
               <a:defRPr sz="2400"/>
             </a:lvl3pPr>
-            <a:lvl4pPr marL="1828800" lvl="3" indent="-355600" algn="l">
+            <a:lvl4pPr marL="1828754" lvl="3" indent="-355591" algn="l">
               <a:lnSpc>
                 <a:spcPct val="90000"/>
               </a:lnSpc>
@@ -10611,7 +10531,7 @@
               <a:buChar char="•"/>
               <a:defRPr sz="2000"/>
             </a:lvl4pPr>
-            <a:lvl5pPr marL="2286000" lvl="4" indent="-355600" algn="l">
+            <a:lvl5pPr marL="2285943" lvl="4" indent="-355591" algn="l">
               <a:lnSpc>
                 <a:spcPct val="90000"/>
               </a:lnSpc>
@@ -10628,7 +10548,7 @@
               <a:buChar char="•"/>
               <a:defRPr sz="2000"/>
             </a:lvl5pPr>
-            <a:lvl6pPr marL="2743200" lvl="5" indent="-355600" algn="l">
+            <a:lvl6pPr marL="2743131" lvl="5" indent="-355591" algn="l">
               <a:lnSpc>
                 <a:spcPct val="90000"/>
               </a:lnSpc>
@@ -10645,7 +10565,7 @@
               <a:buChar char="•"/>
               <a:defRPr sz="2000"/>
             </a:lvl6pPr>
-            <a:lvl7pPr marL="3200400" lvl="6" indent="-355600" algn="l">
+            <a:lvl7pPr marL="3200320" lvl="6" indent="-355591" algn="l">
               <a:lnSpc>
                 <a:spcPct val="90000"/>
               </a:lnSpc>
@@ -10662,7 +10582,7 @@
               <a:buChar char="•"/>
               <a:defRPr sz="2000"/>
             </a:lvl7pPr>
-            <a:lvl8pPr marL="3657600" lvl="7" indent="-355600" algn="l">
+            <a:lvl8pPr marL="3657509" lvl="7" indent="-355591" algn="l">
               <a:lnSpc>
                 <a:spcPct val="90000"/>
               </a:lnSpc>
@@ -10679,7 +10599,7 @@
               <a:buChar char="•"/>
               <a:defRPr sz="2000"/>
             </a:lvl8pPr>
-            <a:lvl9pPr marL="4114800" lvl="8" indent="-355600" algn="l">
+            <a:lvl9pPr marL="4114697" lvl="8" indent="-355591" algn="l">
               <a:lnSpc>
                 <a:spcPct val="90000"/>
               </a:lnSpc>
@@ -10730,7 +10650,7 @@
             <a:normAutofit/>
           </a:bodyPr>
           <a:lstStyle>
-            <a:lvl1pPr marL="457200" lvl="0" indent="-228600" algn="l">
+            <a:lvl1pPr marL="457189" lvl="0" indent="-228594" algn="l">
               <a:lnSpc>
                 <a:spcPct val="90000"/>
               </a:lnSpc>
@@ -10747,7 +10667,7 @@
               <a:buNone/>
               <a:defRPr sz="1600"/>
             </a:lvl1pPr>
-            <a:lvl2pPr marL="914400" lvl="1" indent="-228600" algn="l">
+            <a:lvl2pPr marL="914377" lvl="1" indent="-228594" algn="l">
               <a:lnSpc>
                 <a:spcPct val="90000"/>
               </a:lnSpc>
@@ -10764,7 +10684,7 @@
               <a:buNone/>
               <a:defRPr sz="1400"/>
             </a:lvl2pPr>
-            <a:lvl3pPr marL="1371600" lvl="2" indent="-228600" algn="l">
+            <a:lvl3pPr marL="1371566" lvl="2" indent="-228594" algn="l">
               <a:lnSpc>
                 <a:spcPct val="90000"/>
               </a:lnSpc>
@@ -10781,7 +10701,7 @@
               <a:buNone/>
               <a:defRPr sz="1200"/>
             </a:lvl3pPr>
-            <a:lvl4pPr marL="1828800" lvl="3" indent="-228600" algn="l">
+            <a:lvl4pPr marL="1828754" lvl="3" indent="-228594" algn="l">
               <a:lnSpc>
                 <a:spcPct val="90000"/>
               </a:lnSpc>
@@ -10798,7 +10718,7 @@
               <a:buNone/>
               <a:defRPr sz="1000"/>
             </a:lvl4pPr>
-            <a:lvl5pPr marL="2286000" lvl="4" indent="-228600" algn="l">
+            <a:lvl5pPr marL="2285943" lvl="4" indent="-228594" algn="l">
               <a:lnSpc>
                 <a:spcPct val="90000"/>
               </a:lnSpc>
@@ -10815,7 +10735,7 @@
               <a:buNone/>
               <a:defRPr sz="1000"/>
             </a:lvl5pPr>
-            <a:lvl6pPr marL="2743200" lvl="5" indent="-228600" algn="l">
+            <a:lvl6pPr marL="2743131" lvl="5" indent="-228594" algn="l">
               <a:lnSpc>
                 <a:spcPct val="90000"/>
               </a:lnSpc>
@@ -10832,7 +10752,7 @@
               <a:buNone/>
               <a:defRPr sz="1000"/>
             </a:lvl6pPr>
-            <a:lvl7pPr marL="3200400" lvl="6" indent="-228600" algn="l">
+            <a:lvl7pPr marL="3200320" lvl="6" indent="-228594" algn="l">
               <a:lnSpc>
                 <a:spcPct val="90000"/>
               </a:lnSpc>
@@ -10849,7 +10769,7 @@
               <a:buNone/>
               <a:defRPr sz="1000"/>
             </a:lvl7pPr>
-            <a:lvl8pPr marL="3657600" lvl="7" indent="-228600" algn="l">
+            <a:lvl8pPr marL="3657509" lvl="7" indent="-228594" algn="l">
               <a:lnSpc>
                 <a:spcPct val="90000"/>
               </a:lnSpc>
@@ -10866,7 +10786,7 @@
               <a:buNone/>
               <a:defRPr sz="1000"/>
             </a:lvl8pPr>
-            <a:lvl9pPr marL="4114800" lvl="8" indent="-228600" algn="l">
+            <a:lvl9pPr marL="4114697" lvl="8" indent="-228594" algn="l">
               <a:lnSpc>
                 <a:spcPct val="90000"/>
               </a:lnSpc>
@@ -10901,7 +10821,7 @@
         </p:nvSpPr>
         <p:spPr>
           <a:xfrm>
-            <a:off x="838200" y="6356350"/>
+            <a:off x="838200" y="6356354"/>
             <a:ext cx="2743200" cy="365125"/>
           </a:xfrm>
           <a:prstGeom prst="rect">
@@ -11034,7 +10954,7 @@
         </p:nvSpPr>
         <p:spPr>
           <a:xfrm>
-            <a:off x="4038600" y="6356350"/>
+            <a:off x="4038600" y="6356354"/>
             <a:ext cx="4114800" cy="365125"/>
           </a:xfrm>
           <a:prstGeom prst="rect">
@@ -11167,7 +11087,7 @@
         </p:nvSpPr>
         <p:spPr>
           <a:xfrm>
-            <a:off x="8610600" y="6356350"/>
+            <a:off x="8610600" y="6356354"/>
             <a:ext cx="2743200" cy="365125"/>
           </a:xfrm>
           <a:prstGeom prst="rect">
@@ -11248,20 +11168,12 @@
             </a:lvl9pPr>
           </a:lstStyle>
           <a:p>
-            <a:pPr marL="0" lvl="0" indent="0" algn="r" rtl="0">
-              <a:spcBef>
-                <a:spcPts val="0"/>
-              </a:spcBef>
-              <a:spcAft>
-                <a:spcPts val="0"/>
-              </a:spcAft>
-              <a:buNone/>
-            </a:pPr>
             <a:fld id="{00000000-1234-1234-1234-123412341234}" type="slidenum">
-              <a:rPr lang="es-CO"/>
+              <a:rPr lang="es-CO" smtClean="0"/>
+              <a:pPr/>
               <a:t>‹Nº›</a:t>
             </a:fld>
-            <a:endParaRPr/>
+            <a:endParaRPr lang="es-CO"/>
           </a:p>
         </p:txBody>
       </p:sp>
@@ -11442,7 +11354,7 @@
         </p:nvSpPr>
         <p:spPr>
           <a:xfrm>
-            <a:off x="5183188" y="987425"/>
+            <a:off x="5183188" y="987429"/>
             <a:ext cx="6172200" cy="4873625"/>
           </a:xfrm>
           <a:prstGeom prst="rect">
@@ -11482,7 +11394,7 @@
             <a:normAutofit/>
           </a:bodyPr>
           <a:lstStyle>
-            <a:lvl1pPr marL="457200" lvl="0" indent="-228600" algn="l">
+            <a:lvl1pPr marL="457189" lvl="0" indent="-228594" algn="l">
               <a:lnSpc>
                 <a:spcPct val="90000"/>
               </a:lnSpc>
@@ -11499,7 +11411,7 @@
               <a:buNone/>
               <a:defRPr sz="1600"/>
             </a:lvl1pPr>
-            <a:lvl2pPr marL="914400" lvl="1" indent="-228600" algn="l">
+            <a:lvl2pPr marL="914377" lvl="1" indent="-228594" algn="l">
               <a:lnSpc>
                 <a:spcPct val="90000"/>
               </a:lnSpc>
@@ -11516,7 +11428,7 @@
               <a:buNone/>
               <a:defRPr sz="1400"/>
             </a:lvl2pPr>
-            <a:lvl3pPr marL="1371600" lvl="2" indent="-228600" algn="l">
+            <a:lvl3pPr marL="1371566" lvl="2" indent="-228594" algn="l">
               <a:lnSpc>
                 <a:spcPct val="90000"/>
               </a:lnSpc>
@@ -11533,7 +11445,7 @@
               <a:buNone/>
               <a:defRPr sz="1200"/>
             </a:lvl3pPr>
-            <a:lvl4pPr marL="1828800" lvl="3" indent="-228600" algn="l">
+            <a:lvl4pPr marL="1828754" lvl="3" indent="-228594" algn="l">
               <a:lnSpc>
                 <a:spcPct val="90000"/>
               </a:lnSpc>
@@ -11550,7 +11462,7 @@
               <a:buNone/>
               <a:defRPr sz="1000"/>
             </a:lvl4pPr>
-            <a:lvl5pPr marL="2286000" lvl="4" indent="-228600" algn="l">
+            <a:lvl5pPr marL="2285943" lvl="4" indent="-228594" algn="l">
               <a:lnSpc>
                 <a:spcPct val="90000"/>
               </a:lnSpc>
@@ -11567,7 +11479,7 @@
               <a:buNone/>
               <a:defRPr sz="1000"/>
             </a:lvl5pPr>
-            <a:lvl6pPr marL="2743200" lvl="5" indent="-228600" algn="l">
+            <a:lvl6pPr marL="2743131" lvl="5" indent="-228594" algn="l">
               <a:lnSpc>
                 <a:spcPct val="90000"/>
               </a:lnSpc>
@@ -11584,7 +11496,7 @@
               <a:buNone/>
               <a:defRPr sz="1000"/>
             </a:lvl6pPr>
-            <a:lvl7pPr marL="3200400" lvl="6" indent="-228600" algn="l">
+            <a:lvl7pPr marL="3200320" lvl="6" indent="-228594" algn="l">
               <a:lnSpc>
                 <a:spcPct val="90000"/>
               </a:lnSpc>
@@ -11601,7 +11513,7 @@
               <a:buNone/>
               <a:defRPr sz="1000"/>
             </a:lvl7pPr>
-            <a:lvl8pPr marL="3657600" lvl="7" indent="-228600" algn="l">
+            <a:lvl8pPr marL="3657509" lvl="7" indent="-228594" algn="l">
               <a:lnSpc>
                 <a:spcPct val="90000"/>
               </a:lnSpc>
@@ -11618,7 +11530,7 @@
               <a:buNone/>
               <a:defRPr sz="1000"/>
             </a:lvl8pPr>
-            <a:lvl9pPr marL="4114800" lvl="8" indent="-228600" algn="l">
+            <a:lvl9pPr marL="4114697" lvl="8" indent="-228594" algn="l">
               <a:lnSpc>
                 <a:spcPct val="90000"/>
               </a:lnSpc>
@@ -11653,7 +11565,7 @@
         </p:nvSpPr>
         <p:spPr>
           <a:xfrm>
-            <a:off x="838200" y="6356350"/>
+            <a:off x="838200" y="6356354"/>
             <a:ext cx="2743200" cy="365125"/>
           </a:xfrm>
           <a:prstGeom prst="rect">
@@ -11786,7 +11698,7 @@
         </p:nvSpPr>
         <p:spPr>
           <a:xfrm>
-            <a:off x="4038600" y="6356350"/>
+            <a:off x="4038600" y="6356354"/>
             <a:ext cx="4114800" cy="365125"/>
           </a:xfrm>
           <a:prstGeom prst="rect">
@@ -11919,7 +11831,7 @@
         </p:nvSpPr>
         <p:spPr>
           <a:xfrm>
-            <a:off x="8610600" y="6356350"/>
+            <a:off x="8610600" y="6356354"/>
             <a:ext cx="2743200" cy="365125"/>
           </a:xfrm>
           <a:prstGeom prst="rect">
@@ -12000,20 +11912,12 @@
             </a:lvl9pPr>
           </a:lstStyle>
           <a:p>
-            <a:pPr marL="0" lvl="0" indent="0" algn="r" rtl="0">
-              <a:spcBef>
-                <a:spcPts val="0"/>
-              </a:spcBef>
-              <a:spcAft>
-                <a:spcPts val="0"/>
-              </a:spcAft>
-              <a:buNone/>
-            </a:pPr>
             <a:fld id="{00000000-1234-1234-1234-123412341234}" type="slidenum">
-              <a:rPr lang="es-CO"/>
+              <a:rPr lang="es-CO" smtClean="0"/>
+              <a:pPr/>
               <a:t>‹Nº›</a:t>
             </a:fld>
-            <a:endParaRPr/>
+            <a:endParaRPr lang="es-CO"/>
           </a:p>
         </p:txBody>
       </p:sp>
@@ -12062,7 +11966,7 @@
         </p:nvSpPr>
         <p:spPr>
           <a:xfrm>
-            <a:off x="838200" y="365125"/>
+            <a:off x="838200" y="365129"/>
             <a:ext cx="10515600" cy="1325563"/>
           </a:xfrm>
           <a:prstGeom prst="rect">
@@ -12478,7 +12382,7 @@
         </p:nvSpPr>
         <p:spPr>
           <a:xfrm>
-            <a:off x="838200" y="6356350"/>
+            <a:off x="838200" y="6356354"/>
             <a:ext cx="2743200" cy="365125"/>
           </a:xfrm>
           <a:prstGeom prst="rect">
@@ -12683,7 +12587,7 @@
         </p:nvSpPr>
         <p:spPr>
           <a:xfrm>
-            <a:off x="4038600" y="6356350"/>
+            <a:off x="4038600" y="6356354"/>
             <a:ext cx="4114800" cy="365125"/>
           </a:xfrm>
           <a:prstGeom prst="rect">
@@ -12888,7 +12792,7 @@
         </p:nvSpPr>
         <p:spPr>
           <a:xfrm>
-            <a:off x="8610600" y="6356350"/>
+            <a:off x="8610600" y="6356354"/>
             <a:ext cx="2743200" cy="365125"/>
           </a:xfrm>
           <a:prstGeom prst="rect">
@@ -13041,20 +12945,12 @@
             </a:lvl9pPr>
           </a:lstStyle>
           <a:p>
-            <a:pPr marL="0" lvl="0" indent="0" algn="r" rtl="0">
-              <a:spcBef>
-                <a:spcPts val="0"/>
-              </a:spcBef>
-              <a:spcAft>
-                <a:spcPts val="0"/>
-              </a:spcAft>
-              <a:buNone/>
-            </a:pPr>
             <a:fld id="{00000000-1234-1234-1234-123412341234}" type="slidenum">
-              <a:rPr lang="es-CO"/>
+              <a:rPr lang="es-CO" smtClean="0"/>
+              <a:pPr/>
               <a:t>‹Nº›</a:t>
             </a:fld>
-            <a:endParaRPr/>
+            <a:endParaRPr lang="es-CO"/>
           </a:p>
         </p:txBody>
       </p:sp>
@@ -13806,8 +13702,8 @@
         </p:nvSpPr>
         <p:spPr>
           <a:xfrm>
-            <a:off x="4996498" y="2505675"/>
-            <a:ext cx="2757600" cy="923400"/>
+            <a:off x="4996499" y="2505675"/>
+            <a:ext cx="2757600" cy="923289"/>
           </a:xfrm>
           <a:prstGeom prst="rect">
             <a:avLst/>
@@ -13823,22 +13719,14 @@
           </a:bodyPr>
           <a:lstStyle/>
           <a:p>
-            <a:pPr marL="0" marR="0" lvl="0" indent="0" algn="l" rtl="0">
-              <a:spcBef>
-                <a:spcPts val="0"/>
-              </a:spcBef>
-              <a:spcAft>
-                <a:spcPts val="0"/>
-              </a:spcAft>
+            <a:pPr>
               <a:buClr>
                 <a:srgbClr val="3F3F3F"/>
               </a:buClr>
               <a:buSzPts val="5400"/>
-              <a:buFont typeface="Work Sans"/>
-              <a:buNone/>
             </a:pPr>
             <a:r>
-              <a:rPr lang="es-CO" sz="5400" b="1" i="0" u="none" strike="noStrike" cap="none">
+              <a:rPr lang="es-CO" sz="5400" b="1">
                 <a:solidFill>
                   <a:srgbClr val="3F3F3F"/>
                 </a:solidFill>
@@ -13849,7 +13737,7 @@
               </a:rPr>
               <a:t>Panify</a:t>
             </a:r>
-            <a:endParaRPr sz="5400" b="1" i="0" u="none" strike="noStrike" cap="none">
+            <a:endParaRPr sz="5400" b="1">
               <a:solidFill>
                 <a:srgbClr val="3F3F3F"/>
               </a:solidFill>
@@ -13874,7 +13762,7 @@
         </p:blipFill>
         <p:spPr>
           <a:xfrm>
-            <a:off x="10062783" y="4903687"/>
+            <a:off x="10062786" y="4903689"/>
             <a:ext cx="1133501" cy="919163"/>
           </a:xfrm>
           <a:prstGeom prst="rect">
@@ -13894,8 +13782,8 @@
         </p:nvSpPr>
         <p:spPr>
           <a:xfrm>
-            <a:off x="3281551" y="3318933"/>
-            <a:ext cx="5628898" cy="461665"/>
+            <a:off x="3281551" y="3318937"/>
+            <a:ext cx="5628899" cy="461624"/>
           </a:xfrm>
           <a:prstGeom prst="rect">
             <a:avLst/>
@@ -13911,22 +13799,14 @@
           </a:bodyPr>
           <a:lstStyle/>
           <a:p>
-            <a:pPr marL="0" marR="0" lvl="0" indent="0" algn="l" rtl="0">
-              <a:spcBef>
-                <a:spcPts val="0"/>
-              </a:spcBef>
-              <a:spcAft>
-                <a:spcPts val="0"/>
-              </a:spcAft>
+            <a:pPr>
               <a:buClr>
                 <a:srgbClr val="F3B35A"/>
               </a:buClr>
               <a:buSzPts val="2400"/>
-              <a:buFont typeface="Calibri"/>
-              <a:buNone/>
             </a:pPr>
             <a:r>
-              <a:rPr lang="es-CO" sz="2400" b="0" i="1" u="none" strike="noStrike" cap="none">
+              <a:rPr lang="es-CO" sz="2400" i="1">
                 <a:solidFill>
                   <a:srgbClr val="F3B35A"/>
                 </a:solidFill>
@@ -13937,7 +13817,7 @@
               </a:rPr>
               <a:t>Horneamos Calidad, Entregamos Confianza.</a:t>
             </a:r>
-            <a:endParaRPr sz="2400" b="1" i="0" u="none" strike="noStrike" cap="none">
+            <a:endParaRPr sz="2400" b="1">
               <a:solidFill>
                 <a:srgbClr val="F3B35A"/>
               </a:solidFill>
@@ -13957,7 +13837,7 @@
         </p:nvSpPr>
         <p:spPr>
           <a:xfrm>
-            <a:off x="1124052" y="4161485"/>
+            <a:off x="1124052" y="4161486"/>
             <a:ext cx="2050200" cy="1169511"/>
           </a:xfrm>
           <a:prstGeom prst="rect">
@@ -13975,10 +13855,7 @@
           <a:lstStyle/>
           <a:p>
             <a:r>
-              <a:rPr lang="es-CO" sz="1400" i="0" u="none" strike="noStrike" cap="none" dirty="0">
-                <a:solidFill>
-                  <a:srgbClr val="000000"/>
-                </a:solidFill>
+              <a:rPr lang="es-CO" dirty="0">
                 <a:latin typeface="Work Sans"/>
                 <a:ea typeface="Work Sans"/>
                 <a:cs typeface="Work Sans"/>
@@ -13988,20 +13865,8 @@
             </a:r>
           </a:p>
           <a:p>
-            <a:pPr marL="0" marR="0" lvl="0" indent="0" algn="l" rtl="0">
-              <a:spcBef>
-                <a:spcPts val="0"/>
-              </a:spcBef>
-              <a:spcAft>
-                <a:spcPts val="0"/>
-              </a:spcAft>
-              <a:buNone/>
-            </a:pPr>
             <a:r>
-              <a:rPr lang="es-CO" sz="1400" i="0" u="none" strike="noStrike" cap="none" dirty="0">
-                <a:solidFill>
-                  <a:srgbClr val="000000"/>
-                </a:solidFill>
+              <a:rPr lang="es-CO" dirty="0">
                 <a:latin typeface="Work Sans"/>
                 <a:ea typeface="Work Sans"/>
                 <a:cs typeface="Work Sans"/>
@@ -14009,7 +13874,7 @@
               </a:rPr>
               <a:t>MARTÍN CRUZ </a:t>
             </a:r>
-            <a:endParaRPr sz="1400" i="0" u="none" strike="noStrike" cap="none" dirty="0">
+            <a:endParaRPr dirty="0">
               <a:solidFill>
                 <a:schemeClr val="dk1"/>
               </a:solidFill>
@@ -14020,20 +13885,8 @@
             </a:endParaRPr>
           </a:p>
           <a:p>
-            <a:pPr marL="0" marR="0" lvl="0" indent="0" algn="l" rtl="0">
-              <a:spcBef>
-                <a:spcPts val="0"/>
-              </a:spcBef>
-              <a:spcAft>
-                <a:spcPts val="0"/>
-              </a:spcAft>
-              <a:buNone/>
-            </a:pPr>
             <a:r>
-              <a:rPr lang="es-CO" sz="1400" i="0" u="none" strike="noStrike" cap="none" dirty="0">
-                <a:solidFill>
-                  <a:srgbClr val="000000"/>
-                </a:solidFill>
+              <a:rPr lang="es-CO" dirty="0">
                 <a:latin typeface="Work Sans"/>
                 <a:ea typeface="Work Sans"/>
                 <a:cs typeface="Work Sans"/>
@@ -14041,7 +13894,7 @@
               </a:rPr>
               <a:t>JEISON DIAZ</a:t>
             </a:r>
-            <a:endParaRPr sz="1400" i="0" u="none" strike="noStrike" cap="none" dirty="0">
+            <a:endParaRPr dirty="0">
               <a:solidFill>
                 <a:schemeClr val="dk1"/>
               </a:solidFill>
@@ -14052,20 +13905,8 @@
             </a:endParaRPr>
           </a:p>
           <a:p>
-            <a:pPr marL="0" marR="0" lvl="0" indent="0" algn="l" rtl="0">
-              <a:spcBef>
-                <a:spcPts val="0"/>
-              </a:spcBef>
-              <a:spcAft>
-                <a:spcPts val="0"/>
-              </a:spcAft>
-              <a:buNone/>
-            </a:pPr>
             <a:r>
-              <a:rPr lang="es-CO" sz="1400" i="0" u="none" strike="noStrike" cap="none" dirty="0">
-                <a:solidFill>
-                  <a:srgbClr val="000000"/>
-                </a:solidFill>
+              <a:rPr lang="es-CO" dirty="0">
                 <a:latin typeface="Work Sans"/>
                 <a:ea typeface="Work Sans"/>
                 <a:cs typeface="Work Sans"/>
@@ -14073,7 +13914,7 @@
               </a:rPr>
               <a:t>BRAYAN DEVIA</a:t>
             </a:r>
-            <a:endParaRPr sz="1400" i="0" u="none" strike="noStrike" cap="none" dirty="0">
+            <a:endParaRPr dirty="0">
               <a:solidFill>
                 <a:schemeClr val="dk1"/>
               </a:solidFill>
@@ -14084,20 +13925,8 @@
             </a:endParaRPr>
           </a:p>
           <a:p>
-            <a:pPr marL="0" marR="0" lvl="0" indent="0" algn="l" rtl="0">
-              <a:spcBef>
-                <a:spcPts val="0"/>
-              </a:spcBef>
-              <a:spcAft>
-                <a:spcPts val="0"/>
-              </a:spcAft>
-              <a:buNone/>
-            </a:pPr>
             <a:r>
-              <a:rPr lang="es-CO" sz="1400" i="0" u="none" strike="noStrike" cap="none" dirty="0">
-                <a:solidFill>
-                  <a:srgbClr val="000000"/>
-                </a:solidFill>
+              <a:rPr lang="es-CO" dirty="0">
                 <a:latin typeface="Work Sans"/>
                 <a:ea typeface="Work Sans"/>
                 <a:cs typeface="Work Sans"/>
@@ -14105,7 +13934,7 @@
               </a:rPr>
               <a:t>JULIÁN GONZÁLEZ</a:t>
             </a:r>
-            <a:endParaRPr sz="1400" i="0" u="none" strike="noStrike" cap="none" dirty="0">
+            <a:endParaRPr dirty="0">
               <a:solidFill>
                 <a:schemeClr val="dk1"/>
               </a:solidFill>
@@ -14163,7 +13992,7 @@
         </p:nvSpPr>
         <p:spPr>
           <a:xfrm>
-            <a:off x="1249019" y="2498277"/>
+            <a:off x="1249020" y="2498278"/>
             <a:ext cx="9776765" cy="1015622"/>
           </a:xfrm>
           <a:prstGeom prst="rect">
@@ -14180,17 +14009,9 @@
           </a:bodyPr>
           <a:lstStyle/>
           <a:p>
-            <a:pPr marL="0" marR="0" lvl="0" indent="0" algn="ctr" rtl="0">
-              <a:spcBef>
-                <a:spcPts val="0"/>
-              </a:spcBef>
-              <a:spcAft>
-                <a:spcPts val="0"/>
-              </a:spcAft>
-              <a:buNone/>
-            </a:pPr>
+            <a:pPr algn="ctr"/>
             <a:r>
-              <a:rPr lang="es-CO" sz="6000" b="1" u="none" strike="noStrike" cap="none" dirty="0">
+              <a:rPr lang="es-CO" sz="6000" b="1" dirty="0">
                 <a:solidFill>
                   <a:schemeClr val="lt1"/>
                 </a:solidFill>
@@ -14201,7 +14022,7 @@
               </a:rPr>
               <a:t>Diagrama de Clases UML</a:t>
             </a:r>
-            <a:endParaRPr sz="7200" b="1" u="none" strike="noStrike" cap="none" dirty="0">
+            <a:endParaRPr sz="7200" b="1" dirty="0">
               <a:solidFill>
                 <a:schemeClr val="lt1"/>
               </a:solidFill>
@@ -14221,7 +14042,7 @@
         </p:nvCxnSpPr>
         <p:spPr>
           <a:xfrm>
-            <a:off x="5013630" y="3555133"/>
+            <a:off x="5013631" y="3555133"/>
             <a:ext cx="2247544" cy="0"/>
           </a:xfrm>
           <a:prstGeom prst="straightConnector1">
@@ -14290,8 +14111,8 @@
         </p:nvSpPr>
         <p:spPr>
           <a:xfrm>
-            <a:off x="653143" y="325250"/>
-            <a:ext cx="9940834" cy="527874"/>
+            <a:off x="653143" y="325249"/>
+            <a:ext cx="9940835" cy="527875"/>
           </a:xfrm>
           <a:prstGeom prst="rect">
             <a:avLst/>
@@ -14307,23 +14128,11 @@
           </a:bodyPr>
           <a:lstStyle/>
           <a:p>
-            <a:pPr marL="0" marR="0" lvl="0" indent="0" defTabSz="914400" rtl="0" eaLnBrk="1" fontAlgn="auto" latinLnBrk="0" hangingPunct="1">
-              <a:lnSpc>
-                <a:spcPct val="100000"/>
-              </a:lnSpc>
-              <a:spcBef>
-                <a:spcPts val="0"/>
-              </a:spcBef>
-              <a:spcAft>
-                <a:spcPts val="0"/>
-              </a:spcAft>
+            <a:pPr>
               <a:buClr>
                 <a:srgbClr val="FFFFFF"/>
               </a:buClr>
               <a:buSzPts val="6000"/>
-              <a:buFont typeface="Work Sans"/>
-              <a:buNone/>
-              <a:tabLst/>
               <a:defRPr/>
             </a:pPr>
             <a:r>
@@ -14338,20 +14147,96 @@
               </a:rPr>
               <a:t>Diagrama de Clases</a:t>
             </a:r>
-            <a:endParaRPr kumimoji="0" sz="4000" b="1" i="0" u="none" strike="noStrike" kern="0" cap="none" spc="0" normalizeH="0" baseline="0" noProof="0" dirty="0">
-              <a:ln>
-                <a:noFill/>
-              </a:ln>
+            <a:endParaRPr sz="4000" b="1" dirty="0">
               <a:solidFill>
                 <a:srgbClr val="FFFFFF"/>
               </a:solidFill>
-              <a:effectLst/>
-              <a:uLnTx/>
-              <a:uFillTx/>
               <a:latin typeface="Work Sans"/>
               <a:ea typeface="Work Sans"/>
               <a:cs typeface="Work Sans"/>
               <a:sym typeface="Work Sans"/>
+            </a:endParaRPr>
+          </a:p>
+        </p:txBody>
+      </p:sp>
+      <p:pic>
+        <p:nvPicPr>
+          <p:cNvPr id="3" name="Imagen 2">
+            <a:extLst>
+              <a:ext uri="{FF2B5EF4-FFF2-40B4-BE49-F238E27FC236}">
+                <a16:creationId xmlns:a16="http://schemas.microsoft.com/office/drawing/2014/main" id="{F0641B44-96A0-0BB1-9339-AC1067BEDDD7}"/>
+              </a:ext>
+            </a:extLst>
+          </p:cNvPr>
+          <p:cNvPicPr>
+            <a:picLocks noChangeAspect="1"/>
+          </p:cNvPicPr>
+          <p:nvPr/>
+        </p:nvPicPr>
+        <p:blipFill>
+          <a:blip r:embed="rId4"/>
+          <a:stretch>
+            <a:fillRect/>
+          </a:stretch>
+        </p:blipFill>
+        <p:spPr>
+          <a:xfrm>
+            <a:off x="653143" y="1428750"/>
+            <a:ext cx="5000907" cy="5228692"/>
+          </a:xfrm>
+          <a:prstGeom prst="rect">
+            <a:avLst/>
+          </a:prstGeom>
+        </p:spPr>
+      </p:pic>
+      <p:sp>
+        <p:nvSpPr>
+          <p:cNvPr id="4" name="Google Shape;108;p3">
+            <a:extLst>
+              <a:ext uri="{FF2B5EF4-FFF2-40B4-BE49-F238E27FC236}">
+                <a16:creationId xmlns:a16="http://schemas.microsoft.com/office/drawing/2014/main" id="{FAC6E1CA-1577-309C-E305-2D2695BF00C2}"/>
+              </a:ext>
+            </a:extLst>
+          </p:cNvPr>
+          <p:cNvSpPr txBox="1"/>
+          <p:nvPr/>
+        </p:nvSpPr>
+        <p:spPr>
+          <a:xfrm>
+            <a:off x="6378452" y="3316469"/>
+            <a:ext cx="5000907" cy="646290"/>
+          </a:xfrm>
+          <a:prstGeom prst="rect">
+            <a:avLst/>
+          </a:prstGeom>
+          <a:noFill/>
+          <a:ln>
+            <a:noFill/>
+          </a:ln>
+        </p:spPr>
+        <p:txBody>
+          <a:bodyPr spcFirstLastPara="1" wrap="square" lIns="91425" tIns="45700" rIns="91425" bIns="45700" anchor="t" anchorCtr="0">
+            <a:spAutoFit/>
+          </a:bodyPr>
+          <a:lstStyle/>
+          <a:p>
+            <a:pPr algn="ctr"/>
+            <a:r>
+              <a:rPr lang="es-CO" sz="3600" dirty="0">
+                <a:solidFill>
+                  <a:schemeClr val="accent6"/>
+                </a:solidFill>
+                <a:latin typeface="Calibri"/>
+                <a:cs typeface="Calibri"/>
+                <a:sym typeface="Calibri"/>
+                <a:hlinkClick r:id="rId5"/>
+              </a:rPr>
+              <a:t>Diagrama de Clases UML</a:t>
+            </a:r>
+            <a:endParaRPr dirty="0">
+              <a:solidFill>
+                <a:schemeClr val="accent6"/>
+              </a:solidFill>
             </a:endParaRPr>
           </a:p>
         </p:txBody>
@@ -14407,7 +14292,7 @@
         </p:nvSpPr>
         <p:spPr>
           <a:xfrm>
-            <a:off x="1249019" y="2498277"/>
+            <a:off x="1249020" y="2498278"/>
             <a:ext cx="9776765" cy="1015622"/>
           </a:xfrm>
           <a:prstGeom prst="rect">
@@ -14424,17 +14309,9 @@
           </a:bodyPr>
           <a:lstStyle/>
           <a:p>
-            <a:pPr marL="0" marR="0" lvl="0" indent="0" algn="ctr" rtl="0">
-              <a:spcBef>
-                <a:spcPts val="0"/>
-              </a:spcBef>
-              <a:spcAft>
-                <a:spcPts val="0"/>
-              </a:spcAft>
-              <a:buNone/>
-            </a:pPr>
+            <a:pPr algn="ctr"/>
             <a:r>
-              <a:rPr lang="es-CO" sz="6000" b="1" u="none" strike="noStrike" cap="none" dirty="0">
+              <a:rPr lang="es-CO" sz="6000" b="1" dirty="0">
                 <a:solidFill>
                   <a:schemeClr val="lt1"/>
                 </a:solidFill>
@@ -14445,7 +14322,7 @@
               </a:rPr>
               <a:t>Diccionario de Datos</a:t>
             </a:r>
-            <a:endParaRPr sz="7200" b="1" u="none" strike="noStrike" cap="none" dirty="0">
+            <a:endParaRPr sz="7200" b="1" dirty="0">
               <a:solidFill>
                 <a:schemeClr val="lt1"/>
               </a:solidFill>
@@ -14465,7 +14342,7 @@
         </p:nvCxnSpPr>
         <p:spPr>
           <a:xfrm>
-            <a:off x="5013630" y="3555133"/>
+            <a:off x="5013631" y="3555133"/>
             <a:ext cx="2247544" cy="0"/>
           </a:xfrm>
           <a:prstGeom prst="straightConnector1">
@@ -14534,8 +14411,8 @@
         </p:nvSpPr>
         <p:spPr>
           <a:xfrm>
-            <a:off x="653143" y="325250"/>
-            <a:ext cx="9940834" cy="527874"/>
+            <a:off x="653143" y="325249"/>
+            <a:ext cx="9940835" cy="527875"/>
           </a:xfrm>
           <a:prstGeom prst="rect">
             <a:avLst/>
@@ -14551,23 +14428,11 @@
           </a:bodyPr>
           <a:lstStyle/>
           <a:p>
-            <a:pPr marL="0" marR="0" lvl="0" indent="0" defTabSz="914400" rtl="0" eaLnBrk="1" fontAlgn="auto" latinLnBrk="0" hangingPunct="1">
-              <a:lnSpc>
-                <a:spcPct val="100000"/>
-              </a:lnSpc>
-              <a:spcBef>
-                <a:spcPts val="0"/>
-              </a:spcBef>
-              <a:spcAft>
-                <a:spcPts val="0"/>
-              </a:spcAft>
+            <a:pPr>
               <a:buClr>
                 <a:srgbClr val="FFFFFF"/>
               </a:buClr>
               <a:buSzPts val="6000"/>
-              <a:buFont typeface="Work Sans"/>
-              <a:buNone/>
-              <a:tabLst/>
               <a:defRPr/>
             </a:pPr>
             <a:r>
@@ -14582,20 +14447,95 @@
               </a:rPr>
               <a:t>Diccionario de Datos</a:t>
             </a:r>
-            <a:endParaRPr kumimoji="0" sz="4000" b="1" i="0" u="none" strike="noStrike" kern="0" cap="none" spc="0" normalizeH="0" baseline="0" noProof="0" dirty="0">
-              <a:ln>
-                <a:noFill/>
-              </a:ln>
+            <a:endParaRPr sz="4000" b="1" dirty="0">
               <a:solidFill>
                 <a:srgbClr val="FFFFFF"/>
               </a:solidFill>
-              <a:effectLst/>
-              <a:uLnTx/>
-              <a:uFillTx/>
               <a:latin typeface="Work Sans"/>
               <a:ea typeface="Work Sans"/>
               <a:cs typeface="Work Sans"/>
               <a:sym typeface="Work Sans"/>
+            </a:endParaRPr>
+          </a:p>
+        </p:txBody>
+      </p:sp>
+      <p:pic>
+        <p:nvPicPr>
+          <p:cNvPr id="3" name="Imagen 2">
+            <a:extLst>
+              <a:ext uri="{FF2B5EF4-FFF2-40B4-BE49-F238E27FC236}">
+                <a16:creationId xmlns:a16="http://schemas.microsoft.com/office/drawing/2014/main" id="{33F43230-BDCB-9F8F-FF52-708793980E5E}"/>
+              </a:ext>
+            </a:extLst>
+          </p:cNvPr>
+          <p:cNvPicPr>
+            <a:picLocks noChangeAspect="1"/>
+          </p:cNvPicPr>
+          <p:nvPr/>
+        </p:nvPicPr>
+        <p:blipFill>
+          <a:blip r:embed="rId4"/>
+          <a:stretch>
+            <a:fillRect/>
+          </a:stretch>
+        </p:blipFill>
+        <p:spPr>
+          <a:xfrm>
+            <a:off x="1586735" y="1578324"/>
+            <a:ext cx="8501827" cy="4032767"/>
+          </a:xfrm>
+          <a:prstGeom prst="rect">
+            <a:avLst/>
+          </a:prstGeom>
+        </p:spPr>
+      </p:pic>
+      <p:sp>
+        <p:nvSpPr>
+          <p:cNvPr id="4" name="Google Shape;108;p3">
+            <a:extLst>
+              <a:ext uri="{FF2B5EF4-FFF2-40B4-BE49-F238E27FC236}">
+                <a16:creationId xmlns:a16="http://schemas.microsoft.com/office/drawing/2014/main" id="{B77A7AB3-8F11-8760-8720-B5C216F16768}"/>
+              </a:ext>
+            </a:extLst>
+          </p:cNvPr>
+          <p:cNvSpPr txBox="1"/>
+          <p:nvPr/>
+        </p:nvSpPr>
+        <p:spPr>
+          <a:xfrm>
+            <a:off x="653143" y="5886461"/>
+            <a:ext cx="4652787" cy="646290"/>
+          </a:xfrm>
+          <a:prstGeom prst="rect">
+            <a:avLst/>
+          </a:prstGeom>
+          <a:noFill/>
+          <a:ln>
+            <a:noFill/>
+          </a:ln>
+        </p:spPr>
+        <p:txBody>
+          <a:bodyPr spcFirstLastPara="1" wrap="square" lIns="91425" tIns="45700" rIns="91425" bIns="45700" anchor="t" anchorCtr="0">
+            <a:spAutoFit/>
+          </a:bodyPr>
+          <a:lstStyle/>
+          <a:p>
+            <a:r>
+              <a:rPr lang="es-CO" sz="3600" dirty="0">
+                <a:solidFill>
+                  <a:schemeClr val="accent6"/>
+                </a:solidFill>
+                <a:latin typeface="Calibri"/>
+                <a:cs typeface="Calibri"/>
+                <a:sym typeface="Calibri"/>
+                <a:hlinkClick r:id="rId5"/>
+              </a:rPr>
+              <a:t>Diccionario de Datos</a:t>
+            </a:r>
+            <a:endParaRPr dirty="0">
+              <a:solidFill>
+                <a:schemeClr val="accent6"/>
+              </a:solidFill>
             </a:endParaRPr>
           </a:p>
         </p:txBody>
@@ -14689,8 +14629,8 @@
         </p:nvSpPr>
         <p:spPr>
           <a:xfrm>
-            <a:off x="1838586" y="2430116"/>
-            <a:ext cx="8514826" cy="1015663"/>
+            <a:off x="1838585" y="2430118"/>
+            <a:ext cx="8514827" cy="1015622"/>
           </a:xfrm>
           <a:prstGeom prst="rect">
             <a:avLst/>
@@ -14706,17 +14646,9 @@
           </a:bodyPr>
           <a:lstStyle/>
           <a:p>
-            <a:pPr marL="0" marR="0" lvl="0" indent="0" algn="ctr" rtl="0">
-              <a:spcBef>
-                <a:spcPts val="0"/>
-              </a:spcBef>
-              <a:spcAft>
-                <a:spcPts val="0"/>
-              </a:spcAft>
-              <a:buNone/>
-            </a:pPr>
+            <a:pPr algn="ctr"/>
             <a:r>
-              <a:rPr lang="es-CO" sz="6000" b="1" i="0" u="none" strike="noStrike" cap="none">
+              <a:rPr lang="es-CO" sz="6000" b="1">
                 <a:solidFill>
                   <a:schemeClr val="lt1"/>
                 </a:solidFill>
@@ -14727,7 +14659,7 @@
               </a:rPr>
               <a:t>Objetivo General</a:t>
             </a:r>
-            <a:endParaRPr sz="7200" b="1" i="0" u="none" strike="noStrike" cap="none">
+            <a:endParaRPr sz="7200" b="1">
               <a:solidFill>
                 <a:schemeClr val="lt1"/>
               </a:solidFill>
@@ -14747,7 +14679,7 @@
         </p:nvCxnSpPr>
         <p:spPr>
           <a:xfrm>
-            <a:off x="5013630" y="3555133"/>
+            <a:off x="5013631" y="3555133"/>
             <a:ext cx="2247544" cy="0"/>
           </a:xfrm>
           <a:prstGeom prst="straightConnector1">
@@ -14811,8 +14743,8 @@
         </p:nvSpPr>
         <p:spPr>
           <a:xfrm>
-            <a:off x="956342" y="1273964"/>
-            <a:ext cx="4974195" cy="676598"/>
+            <a:off x="956343" y="1273965"/>
+            <a:ext cx="4974195" cy="676599"/>
           </a:xfrm>
           <a:prstGeom prst="rect">
             <a:avLst/>
@@ -14828,25 +14760,17 @@
           </a:bodyPr>
           <a:lstStyle/>
           <a:p>
-            <a:pPr marL="0" marR="0" lvl="0" indent="0" algn="l" rtl="0">
+            <a:pPr>
               <a:lnSpc>
                 <a:spcPct val="90000"/>
               </a:lnSpc>
-              <a:spcBef>
-                <a:spcPts val="0"/>
-              </a:spcBef>
-              <a:spcAft>
-                <a:spcPts val="0"/>
-              </a:spcAft>
               <a:buClr>
                 <a:srgbClr val="38AA00"/>
               </a:buClr>
               <a:buSzPts val="4400"/>
-              <a:buFont typeface="Work Sans"/>
-              <a:buNone/>
             </a:pPr>
             <a:r>
-              <a:rPr lang="es-CO" sz="4400" b="1" i="0" u="none" strike="noStrike" cap="none">
+              <a:rPr lang="es-CO" sz="4400" b="1">
                 <a:solidFill>
                   <a:srgbClr val="38AA00"/>
                 </a:solidFill>
@@ -14870,7 +14794,7 @@
         <p:spPr>
           <a:xfrm>
             <a:off x="956341" y="2301152"/>
-            <a:ext cx="9372992" cy="2308324"/>
+            <a:ext cx="9372992" cy="2308284"/>
           </a:xfrm>
           <a:prstGeom prst="rect">
             <a:avLst/>
@@ -14886,17 +14810,8 @@
           </a:bodyPr>
           <a:lstStyle/>
           <a:p>
-            <a:pPr marL="0" marR="0" lvl="0" indent="0" algn="l" rtl="0">
-              <a:spcBef>
-                <a:spcPts val="0"/>
-              </a:spcBef>
-              <a:spcAft>
-                <a:spcPts val="0"/>
-              </a:spcAft>
-              <a:buNone/>
-            </a:pPr>
             <a:r>
-              <a:rPr lang="es-CO" sz="3600" b="0" i="0" u="none" strike="noStrike" cap="none">
+              <a:rPr lang="es-CO" sz="3600" dirty="0">
                 <a:solidFill>
                   <a:schemeClr val="dk1"/>
                 </a:solidFill>
@@ -14907,7 +14822,7 @@
               </a:rPr>
               <a:t>Desarrollar una aplicación que gestione los pedidos, el inventario y la generación de recibos, facilitando la organización de la producción y las entregas en Oro Pan.</a:t>
             </a:r>
-            <a:endParaRPr/>
+            <a:endParaRPr dirty="0"/>
           </a:p>
         </p:txBody>
       </p:sp>
@@ -14919,7 +14834,7 @@
         </p:nvCxnSpPr>
         <p:spPr>
           <a:xfrm>
-            <a:off x="1038935" y="1950562"/>
+            <a:off x="1038936" y="1950563"/>
             <a:ext cx="1745123" cy="0"/>
           </a:xfrm>
           <a:prstGeom prst="straightConnector1">
@@ -14983,8 +14898,8 @@
         </p:nvSpPr>
         <p:spPr>
           <a:xfrm>
-            <a:off x="1838586" y="2430116"/>
-            <a:ext cx="8514826" cy="1015663"/>
+            <a:off x="1838585" y="2430118"/>
+            <a:ext cx="8514827" cy="1015622"/>
           </a:xfrm>
           <a:prstGeom prst="rect">
             <a:avLst/>
@@ -15000,17 +14915,9 @@
           </a:bodyPr>
           <a:lstStyle/>
           <a:p>
-            <a:pPr marL="0" marR="0" lvl="0" indent="0" algn="ctr" rtl="0">
-              <a:spcBef>
-                <a:spcPts val="0"/>
-              </a:spcBef>
-              <a:spcAft>
-                <a:spcPts val="0"/>
-              </a:spcAft>
-              <a:buNone/>
-            </a:pPr>
+            <a:pPr algn="ctr"/>
             <a:r>
-              <a:rPr lang="es-CO" sz="6000" b="1" u="none" strike="noStrike" cap="none">
+              <a:rPr lang="es-CO" sz="6000" b="1">
                 <a:solidFill>
                   <a:schemeClr val="lt1"/>
                 </a:solidFill>
@@ -15021,7 +14928,7 @@
               </a:rPr>
               <a:t>Objetivos Específicos</a:t>
             </a:r>
-            <a:endParaRPr sz="7200" b="1" u="none" strike="noStrike" cap="none">
+            <a:endParaRPr sz="7200" b="1">
               <a:solidFill>
                 <a:schemeClr val="lt1"/>
               </a:solidFill>
@@ -15041,7 +14948,7 @@
         </p:nvCxnSpPr>
         <p:spPr>
           <a:xfrm>
-            <a:off x="5013630" y="3555133"/>
+            <a:off x="5013631" y="3555133"/>
             <a:ext cx="2247544" cy="0"/>
           </a:xfrm>
           <a:prstGeom prst="straightConnector1">
@@ -15122,22 +15029,14 @@
           </a:bodyPr>
           <a:lstStyle/>
           <a:p>
-            <a:pPr marL="0" marR="0" lvl="0" indent="0" algn="l" rtl="0">
+            <a:pPr>
               <a:lnSpc>
                 <a:spcPct val="90000"/>
               </a:lnSpc>
-              <a:spcBef>
-                <a:spcPts val="0"/>
-              </a:spcBef>
-              <a:spcAft>
-                <a:spcPts val="0"/>
-              </a:spcAft>
               <a:buClr>
                 <a:srgbClr val="38AA00"/>
               </a:buClr>
               <a:buSzPts val="4400"/>
-              <a:buFont typeface="Work Sans"/>
-              <a:buNone/>
             </a:pPr>
             <a:r>
               <a:rPr lang="es-CO" sz="4400" b="1">
@@ -15171,7 +15070,7 @@
         </p:nvCxnSpPr>
         <p:spPr>
           <a:xfrm>
-            <a:off x="1157466" y="1600132"/>
+            <a:off x="1157467" y="1600132"/>
             <a:ext cx="1745123" cy="0"/>
           </a:xfrm>
           <a:prstGeom prst="straightConnector1">
@@ -15205,8 +15104,8 @@
         </p:blipFill>
         <p:spPr>
           <a:xfrm>
-            <a:off x="924726" y="2016925"/>
-            <a:ext cx="10342550" cy="4313525"/>
+            <a:off x="924726" y="2016928"/>
+            <a:ext cx="10342551" cy="4313525"/>
           </a:xfrm>
           <a:prstGeom prst="rect">
             <a:avLst/>
@@ -15263,8 +15162,8 @@
         </p:nvSpPr>
         <p:spPr>
           <a:xfrm>
-            <a:off x="399535" y="2287245"/>
-            <a:ext cx="11392930" cy="1015622"/>
+            <a:off x="399535" y="2287246"/>
+            <a:ext cx="11392931" cy="1015622"/>
           </a:xfrm>
           <a:prstGeom prst="rect">
             <a:avLst/>
@@ -15280,17 +15179,9 @@
           </a:bodyPr>
           <a:lstStyle/>
           <a:p>
-            <a:pPr marL="0" marR="0" lvl="0" indent="0" algn="ctr" rtl="0">
-              <a:spcBef>
-                <a:spcPts val="0"/>
-              </a:spcBef>
-              <a:spcAft>
-                <a:spcPts val="0"/>
-              </a:spcAft>
-              <a:buNone/>
-            </a:pPr>
+            <a:pPr algn="ctr"/>
             <a:r>
-              <a:rPr lang="es-CO" sz="6000" b="1" u="none" strike="noStrike" cap="none" dirty="0">
+              <a:rPr lang="es-CO" sz="6000" b="1" dirty="0">
                 <a:solidFill>
                   <a:schemeClr val="lt1"/>
                 </a:solidFill>
@@ -15301,7 +15192,7 @@
               </a:rPr>
               <a:t>Normalización del M.E. (3FN)</a:t>
             </a:r>
-            <a:endParaRPr sz="7200" b="1" u="none" strike="noStrike" cap="none" dirty="0">
+            <a:endParaRPr sz="7200" b="1" dirty="0">
               <a:solidFill>
                 <a:schemeClr val="lt1"/>
               </a:solidFill>
@@ -15321,7 +15212,7 @@
         </p:nvCxnSpPr>
         <p:spPr>
           <a:xfrm>
-            <a:off x="5013630" y="3555133"/>
+            <a:off x="5013631" y="3555133"/>
             <a:ext cx="2247544" cy="0"/>
           </a:xfrm>
           <a:prstGeom prst="straightConnector1">
@@ -15390,8 +15281,8 @@
         </p:nvSpPr>
         <p:spPr>
           <a:xfrm>
-            <a:off x="653143" y="325250"/>
-            <a:ext cx="9940834" cy="527874"/>
+            <a:off x="653143" y="325249"/>
+            <a:ext cx="9940835" cy="527875"/>
           </a:xfrm>
           <a:prstGeom prst="rect">
             <a:avLst/>
@@ -15407,36 +15298,18 @@
           </a:bodyPr>
           <a:lstStyle/>
           <a:p>
-            <a:pPr marL="0" marR="0" lvl="0" indent="0" defTabSz="914400" rtl="0" eaLnBrk="1" fontAlgn="auto" latinLnBrk="0" hangingPunct="1">
-              <a:lnSpc>
-                <a:spcPct val="100000"/>
-              </a:lnSpc>
-              <a:spcBef>
-                <a:spcPts val="0"/>
-              </a:spcBef>
-              <a:spcAft>
-                <a:spcPts val="0"/>
-              </a:spcAft>
+            <a:pPr>
               <a:buClr>
                 <a:srgbClr val="FFFFFF"/>
               </a:buClr>
               <a:buSzPts val="6000"/>
-              <a:buFont typeface="Work Sans"/>
-              <a:buNone/>
-              <a:tabLst/>
               <a:defRPr/>
             </a:pPr>
             <a:r>
-              <a:rPr kumimoji="0" lang="es-CO" sz="4000" b="1" i="0" u="none" strike="noStrike" kern="0" cap="none" spc="0" normalizeH="0" baseline="0" noProof="0" dirty="0">
-                <a:ln>
-                  <a:noFill/>
-                </a:ln>
+              <a:rPr lang="es-CO" sz="4000" b="1" dirty="0">
                 <a:solidFill>
                   <a:srgbClr val="FFFFFF"/>
                 </a:solidFill>
-                <a:effectLst/>
-                <a:uLnTx/>
-                <a:uFillTx/>
                 <a:latin typeface="Work Sans"/>
                 <a:ea typeface="Work Sans"/>
                 <a:cs typeface="Work Sans"/>
@@ -15444,20 +15317,95 @@
               </a:rPr>
               <a:t>Normalización</a:t>
             </a:r>
-            <a:endParaRPr kumimoji="0" sz="4000" b="1" i="0" u="none" strike="noStrike" kern="0" cap="none" spc="0" normalizeH="0" baseline="0" noProof="0" dirty="0">
-              <a:ln>
-                <a:noFill/>
-              </a:ln>
+            <a:endParaRPr sz="4000" b="1" dirty="0">
               <a:solidFill>
                 <a:srgbClr val="FFFFFF"/>
               </a:solidFill>
-              <a:effectLst/>
-              <a:uLnTx/>
-              <a:uFillTx/>
               <a:latin typeface="Work Sans"/>
               <a:ea typeface="Work Sans"/>
               <a:cs typeface="Work Sans"/>
               <a:sym typeface="Work Sans"/>
+            </a:endParaRPr>
+          </a:p>
+        </p:txBody>
+      </p:sp>
+      <p:pic>
+        <p:nvPicPr>
+          <p:cNvPr id="3" name="Imagen 2">
+            <a:extLst>
+              <a:ext uri="{FF2B5EF4-FFF2-40B4-BE49-F238E27FC236}">
+                <a16:creationId xmlns:a16="http://schemas.microsoft.com/office/drawing/2014/main" id="{D103AC4F-9E40-58A8-3918-C506D08367F4}"/>
+              </a:ext>
+            </a:extLst>
+          </p:cNvPr>
+          <p:cNvPicPr>
+            <a:picLocks noChangeAspect="1"/>
+          </p:cNvPicPr>
+          <p:nvPr/>
+        </p:nvPicPr>
+        <p:blipFill>
+          <a:blip r:embed="rId4"/>
+          <a:stretch>
+            <a:fillRect/>
+          </a:stretch>
+        </p:blipFill>
+        <p:spPr>
+          <a:xfrm>
+            <a:off x="1190027" y="1345034"/>
+            <a:ext cx="9205599" cy="4167935"/>
+          </a:xfrm>
+          <a:prstGeom prst="rect">
+            <a:avLst/>
+          </a:prstGeom>
+        </p:spPr>
+      </p:pic>
+      <p:sp>
+        <p:nvSpPr>
+          <p:cNvPr id="4" name="Google Shape;108;p3">
+            <a:extLst>
+              <a:ext uri="{FF2B5EF4-FFF2-40B4-BE49-F238E27FC236}">
+                <a16:creationId xmlns:a16="http://schemas.microsoft.com/office/drawing/2014/main" id="{CA32D6B8-E990-05EE-B505-D4C2127C1A8A}"/>
+              </a:ext>
+            </a:extLst>
+          </p:cNvPr>
+          <p:cNvSpPr txBox="1"/>
+          <p:nvPr/>
+        </p:nvSpPr>
+        <p:spPr>
+          <a:xfrm>
+            <a:off x="1106329" y="5886462"/>
+            <a:ext cx="4652787" cy="646290"/>
+          </a:xfrm>
+          <a:prstGeom prst="rect">
+            <a:avLst/>
+          </a:prstGeom>
+          <a:noFill/>
+          <a:ln>
+            <a:noFill/>
+          </a:ln>
+        </p:spPr>
+        <p:txBody>
+          <a:bodyPr spcFirstLastPara="1" wrap="square" lIns="91425" tIns="45700" rIns="91425" bIns="45700" anchor="t" anchorCtr="0">
+            <a:spAutoFit/>
+          </a:bodyPr>
+          <a:lstStyle/>
+          <a:p>
+            <a:r>
+              <a:rPr lang="es-CO" sz="3600" dirty="0">
+                <a:solidFill>
+                  <a:schemeClr val="accent6"/>
+                </a:solidFill>
+                <a:latin typeface="Calibri"/>
+                <a:cs typeface="Calibri"/>
+                <a:sym typeface="Calibri"/>
+                <a:hlinkClick r:id="rId5"/>
+              </a:rPr>
+              <a:t>Normalización del M.E.</a:t>
+            </a:r>
+            <a:endParaRPr dirty="0">
+              <a:solidFill>
+                <a:schemeClr val="accent6"/>
+              </a:solidFill>
             </a:endParaRPr>
           </a:p>
         </p:txBody>
@@ -15508,8 +15456,8 @@
         </p:nvSpPr>
         <p:spPr>
           <a:xfrm>
-            <a:off x="1838586" y="2430116"/>
-            <a:ext cx="8514826" cy="1015663"/>
+            <a:off x="1838585" y="2430118"/>
+            <a:ext cx="8514827" cy="1015622"/>
           </a:xfrm>
           <a:prstGeom prst="rect">
             <a:avLst/>
@@ -15525,27 +15473,7 @@
           </a:bodyPr>
           <a:lstStyle/>
           <a:p>
-            <a:pPr marL="0" marR="0" lvl="0" indent="0" algn="ctr" rtl="0">
-              <a:spcBef>
-                <a:spcPts val="0"/>
-              </a:spcBef>
-              <a:spcAft>
-                <a:spcPts val="0"/>
-              </a:spcAft>
-              <a:buNone/>
-            </a:pPr>
-            <a:r>
-              <a:rPr lang="es-CO" sz="6000" b="1" u="none" strike="noStrike" cap="none" dirty="0">
-                <a:solidFill>
-                  <a:schemeClr val="lt1"/>
-                </a:solidFill>
-                <a:latin typeface="Work Sans"/>
-                <a:ea typeface="Work Sans"/>
-                <a:cs typeface="Work Sans"/>
-                <a:sym typeface="Work Sans"/>
-              </a:rPr>
-              <a:t>M.E.R. </a:t>
-            </a:r>
+            <a:pPr algn="ctr"/>
             <a:r>
               <a:rPr lang="es-CO" sz="6000" b="1" dirty="0">
                 <a:solidFill>
@@ -15556,9 +15484,9 @@
                 <a:cs typeface="Work Sans"/>
                 <a:sym typeface="Work Sans"/>
               </a:rPr>
-              <a:t>Chen</a:t>
+              <a:t>M.E.R. Chen</a:t>
             </a:r>
-            <a:endParaRPr sz="7200" b="1" u="none" strike="noStrike" cap="none" dirty="0">
+            <a:endParaRPr sz="7200" b="1" dirty="0">
               <a:solidFill>
                 <a:schemeClr val="lt1"/>
               </a:solidFill>
@@ -15578,7 +15506,7 @@
         </p:nvCxnSpPr>
         <p:spPr>
           <a:xfrm>
-            <a:off x="5013630" y="3555133"/>
+            <a:off x="5013631" y="3555133"/>
             <a:ext cx="2247544" cy="0"/>
           </a:xfrm>
           <a:prstGeom prst="straightConnector1">
@@ -15647,8 +15575,8 @@
         </p:nvSpPr>
         <p:spPr>
           <a:xfrm>
-            <a:off x="653143" y="325250"/>
-            <a:ext cx="9940834" cy="527874"/>
+            <a:off x="653143" y="325249"/>
+            <a:ext cx="9940835" cy="527875"/>
           </a:xfrm>
           <a:prstGeom prst="rect">
             <a:avLst/>
@@ -15664,23 +15592,11 @@
           </a:bodyPr>
           <a:lstStyle/>
           <a:p>
-            <a:pPr marL="0" marR="0" lvl="0" indent="0" defTabSz="914400" rtl="0" eaLnBrk="1" fontAlgn="auto" latinLnBrk="0" hangingPunct="1">
-              <a:lnSpc>
-                <a:spcPct val="100000"/>
-              </a:lnSpc>
-              <a:spcBef>
-                <a:spcPts val="0"/>
-              </a:spcBef>
-              <a:spcAft>
-                <a:spcPts val="0"/>
-              </a:spcAft>
+            <a:pPr>
               <a:buClr>
                 <a:srgbClr val="FFFFFF"/>
               </a:buClr>
               <a:buSzPts val="6000"/>
-              <a:buFont typeface="Work Sans"/>
-              <a:buNone/>
-              <a:tabLst/>
               <a:defRPr/>
             </a:pPr>
             <a:r>
@@ -15695,20 +15611,95 @@
               </a:rPr>
               <a:t>Modelo Entidad Relación</a:t>
             </a:r>
-            <a:endParaRPr kumimoji="0" sz="4000" b="1" i="0" u="none" strike="noStrike" kern="0" cap="none" spc="0" normalizeH="0" baseline="0" noProof="0" dirty="0">
-              <a:ln>
-                <a:noFill/>
-              </a:ln>
+            <a:endParaRPr sz="4000" b="1" dirty="0">
               <a:solidFill>
                 <a:srgbClr val="FFFFFF"/>
               </a:solidFill>
-              <a:effectLst/>
-              <a:uLnTx/>
-              <a:uFillTx/>
               <a:latin typeface="Work Sans"/>
               <a:ea typeface="Work Sans"/>
               <a:cs typeface="Work Sans"/>
               <a:sym typeface="Work Sans"/>
+            </a:endParaRPr>
+          </a:p>
+        </p:txBody>
+      </p:sp>
+      <p:pic>
+        <p:nvPicPr>
+          <p:cNvPr id="8" name="Imagen 7">
+            <a:extLst>
+              <a:ext uri="{FF2B5EF4-FFF2-40B4-BE49-F238E27FC236}">
+                <a16:creationId xmlns:a16="http://schemas.microsoft.com/office/drawing/2014/main" id="{04CC157F-0E70-67B0-97C7-C610E0814542}"/>
+              </a:ext>
+            </a:extLst>
+          </p:cNvPr>
+          <p:cNvPicPr>
+            <a:picLocks noChangeAspect="1"/>
+          </p:cNvPicPr>
+          <p:nvPr/>
+        </p:nvPicPr>
+        <p:blipFill>
+          <a:blip r:embed="rId4"/>
+          <a:stretch>
+            <a:fillRect/>
+          </a:stretch>
+        </p:blipFill>
+        <p:spPr>
+          <a:xfrm>
+            <a:off x="1160761" y="1392768"/>
+            <a:ext cx="4319910" cy="5139983"/>
+          </a:xfrm>
+          <a:prstGeom prst="rect">
+            <a:avLst/>
+          </a:prstGeom>
+        </p:spPr>
+      </p:pic>
+      <p:sp>
+        <p:nvSpPr>
+          <p:cNvPr id="11" name="Google Shape;108;p3">
+            <a:extLst>
+              <a:ext uri="{FF2B5EF4-FFF2-40B4-BE49-F238E27FC236}">
+                <a16:creationId xmlns:a16="http://schemas.microsoft.com/office/drawing/2014/main" id="{E7FE2694-ECA2-D859-CFD1-F09CFB00393A}"/>
+              </a:ext>
+            </a:extLst>
+          </p:cNvPr>
+          <p:cNvSpPr txBox="1"/>
+          <p:nvPr/>
+        </p:nvSpPr>
+        <p:spPr>
+          <a:xfrm>
+            <a:off x="6378453" y="3316469"/>
+            <a:ext cx="4469656" cy="646290"/>
+          </a:xfrm>
+          <a:prstGeom prst="rect">
+            <a:avLst/>
+          </a:prstGeom>
+          <a:noFill/>
+          <a:ln>
+            <a:noFill/>
+          </a:ln>
+        </p:spPr>
+        <p:txBody>
+          <a:bodyPr spcFirstLastPara="1" wrap="square" lIns="91425" tIns="45700" rIns="91425" bIns="45700" anchor="t" anchorCtr="0">
+            <a:spAutoFit/>
+          </a:bodyPr>
+          <a:lstStyle/>
+          <a:p>
+            <a:r>
+              <a:rPr lang="es-CO" sz="3600" dirty="0">
+                <a:solidFill>
+                  <a:schemeClr val="accent6"/>
+                </a:solidFill>
+                <a:latin typeface="Calibri"/>
+                <a:cs typeface="Calibri"/>
+                <a:sym typeface="Calibri"/>
+                <a:hlinkClick r:id="rId5"/>
+              </a:rPr>
+              <a:t>M.E.R. Notación Chen</a:t>
+            </a:r>
+            <a:endParaRPr dirty="0">
+              <a:solidFill>
+                <a:schemeClr val="accent6"/>
+              </a:solidFill>
             </a:endParaRPr>
           </a:p>
         </p:txBody>

</xml_diff>

<commit_message>
docs(repo): reorganizar estructura de presentación del proyecto
</commit_message>
<xml_diff>
--- a/Tercer Trimestre/Presentación - 3 Trimestre.pptx
+++ b/Tercer Trimestre/Presentación - 3 Trimestre.pptx
@@ -5,7 +5,7 @@
     <p:sldMasterId id="2147483648" r:id="rId1"/>
   </p:sldMasterIdLst>
   <p:notesMasterIdLst>
-    <p:notesMasterId r:id="rId16"/>
+    <p:notesMasterId r:id="rId18"/>
   </p:notesMasterIdLst>
   <p:sldIdLst>
     <p:sldId id="256" r:id="rId2"/>
@@ -14,23 +14,25 @@
     <p:sldId id="259" r:id="rId5"/>
     <p:sldId id="260" r:id="rId6"/>
     <p:sldId id="271" r:id="rId7"/>
-    <p:sldId id="272" r:id="rId8"/>
-    <p:sldId id="268" r:id="rId9"/>
-    <p:sldId id="273" r:id="rId10"/>
-    <p:sldId id="269" r:id="rId11"/>
-    <p:sldId id="274" r:id="rId12"/>
-    <p:sldId id="270" r:id="rId13"/>
-    <p:sldId id="275" r:id="rId14"/>
-    <p:sldId id="267" r:id="rId15"/>
+    <p:sldId id="273" r:id="rId8"/>
+    <p:sldId id="274" r:id="rId9"/>
+    <p:sldId id="272" r:id="rId10"/>
+    <p:sldId id="275" r:id="rId11"/>
+    <p:sldId id="276" r:id="rId12"/>
+    <p:sldId id="277" r:id="rId13"/>
+    <p:sldId id="278" r:id="rId14"/>
+    <p:sldId id="279" r:id="rId15"/>
+    <p:sldId id="280" r:id="rId16"/>
+    <p:sldId id="267" r:id="rId17"/>
   </p:sldIdLst>
   <p:sldSz cx="12192000" cy="6858000"/>
   <p:notesSz cx="6858000" cy="9144000"/>
   <p:embeddedFontLst>
     <p:embeddedFont>
       <p:font typeface="Work Sans" pitchFamily="2" charset="0"/>
-      <p:regular r:id="rId17"/>
-      <p:bold r:id="rId18"/>
-      <p:boldItalic r:id="rId19"/>
+      <p:regular r:id="rId19"/>
+      <p:bold r:id="rId20"/>
+      <p:boldItalic r:id="rId21"/>
     </p:embeddedFont>
   </p:embeddedFontLst>
   <p:defaultTextStyle>
@@ -283,7 +285,7 @@
       </p15:sldGuideLst>
     </p:ext>
     <p:ext uri="GoogleSlidesCustomDataVersion2">
-      <go:slidesCustomData xmlns="" xmlns:mc="http://schemas.openxmlformats.org/markup-compatibility/2006" xmlns:mv="urn:schemas-microsoft-com:mac:vml" xmlns:c="http://schemas.openxmlformats.org/drawingml/2006/chart" xmlns:dgm="http://schemas.openxmlformats.org/drawingml/2006/diagram" xmlns:o="urn:schemas-microsoft-com:office:office" xmlns:v="urn:schemas-microsoft-com:vml" xmlns:pvml="urn:schemas-microsoft-com:office:powerpoint" xmlns:com="http://schemas.openxmlformats.org/drawingml/2006/compatibility" xmlns:p14="http://schemas.microsoft.com/office/powerpoint/2010/main" xmlns:p15="http://schemas.microsoft.com/office/powerpoint/2012/main" xmlns:ahyp="http://schemas.microsoft.com/office/drawing/2018/hyperlinkcolor" xmlns:go="http://customooxmlschemas.google.com/" r:id="rId24" roundtripDataSignature="AMtx7mg8ATteeCZnY9oSBywHj+xxF5qVxA=="/>
+      <go:slidesCustomData xmlns:go="http://customooxmlschemas.google.com/" xmlns:ahyp="http://schemas.microsoft.com/office/drawing/2018/hyperlinkcolor" xmlns:p15="http://schemas.microsoft.com/office/powerpoint/2012/main" xmlns:p14="http://schemas.microsoft.com/office/powerpoint/2010/main" xmlns:com="http://schemas.openxmlformats.org/drawingml/2006/compatibility" xmlns:pvml="urn:schemas-microsoft-com:office:powerpoint" xmlns:v="urn:schemas-microsoft-com:vml" xmlns:o="urn:schemas-microsoft-com:office:office" xmlns:dgm="http://schemas.openxmlformats.org/drawingml/2006/diagram" xmlns:c="http://schemas.openxmlformats.org/drawingml/2006/chart" xmlns:mv="urn:schemas-microsoft-com:mac:vml" xmlns:mc="http://schemas.openxmlformats.org/markup-compatibility/2006" xmlns="" r:id="rId24" roundtripDataSignature="AMtx7mg8ATteeCZnY9oSBywHj+xxF5qVxA=="/>
     </p:ext>
   </p:extLst>
 </p:presentation>
@@ -1591,333 +1593,6 @@
   <p:cSld>
     <p:spTree>
       <p:nvGrpSpPr>
-        <p:cNvPr id="1" name="Shape 110"/>
-        <p:cNvGrpSpPr/>
-        <p:nvPr/>
-      </p:nvGrpSpPr>
-      <p:grpSpPr>
-        <a:xfrm>
-          <a:off x="0" y="0"/>
-          <a:ext cx="0" cy="0"/>
-          <a:chOff x="0" y="0"/>
-          <a:chExt cx="0" cy="0"/>
-        </a:xfrm>
-      </p:grpSpPr>
-      <p:sp>
-        <p:nvSpPr>
-          <p:cNvPr id="111" name="Google Shape;111;p4:notes"/>
-          <p:cNvSpPr txBox="1">
-            <a:spLocks noGrp="1"/>
-          </p:cNvSpPr>
-          <p:nvPr>
-            <p:ph type="body" idx="1"/>
-          </p:nvPr>
-        </p:nvSpPr>
-        <p:spPr>
-          <a:xfrm>
-            <a:off x="685800" y="4400550"/>
-            <a:ext cx="5486400" cy="3600450"/>
-          </a:xfrm>
-          <a:prstGeom prst="rect">
-            <a:avLst/>
-          </a:prstGeom>
-        </p:spPr>
-        <p:txBody>
-          <a:bodyPr spcFirstLastPara="1" wrap="square" lIns="91425" tIns="45700" rIns="91425" bIns="45700" anchor="t" anchorCtr="0">
-            <a:noAutofit/>
-          </a:bodyPr>
-          <a:lstStyle/>
-          <a:p>
-            <a:pPr marL="0" lvl="0" indent="0" algn="l" rtl="0">
-              <a:spcBef>
-                <a:spcPts val="0"/>
-              </a:spcBef>
-              <a:spcAft>
-                <a:spcPts val="0"/>
-              </a:spcAft>
-              <a:buNone/>
-            </a:pPr>
-            <a:endParaRPr/>
-          </a:p>
-        </p:txBody>
-      </p:sp>
-      <p:sp>
-        <p:nvSpPr>
-          <p:cNvPr id="112" name="Google Shape;112;p4:notes"/>
-          <p:cNvSpPr>
-            <a:spLocks noGrp="1" noRot="1" noChangeAspect="1"/>
-          </p:cNvSpPr>
-          <p:nvPr>
-            <p:ph type="sldImg" idx="2"/>
-          </p:nvPr>
-        </p:nvSpPr>
-        <p:spPr>
-          <a:xfrm>
-            <a:off x="685800" y="1143000"/>
-            <a:ext cx="5486400" cy="3086100"/>
-          </a:xfrm>
-          <a:custGeom>
-            <a:avLst/>
-            <a:gdLst/>
-            <a:ahLst/>
-            <a:cxnLst/>
-            <a:rect l="l" t="t" r="r" b="b"/>
-            <a:pathLst>
-              <a:path w="120000" h="120000" extrusionOk="0">
-                <a:moveTo>
-                  <a:pt x="0" y="0"/>
-                </a:moveTo>
-                <a:lnTo>
-                  <a:pt x="120000" y="0"/>
-                </a:lnTo>
-                <a:lnTo>
-                  <a:pt x="120000" y="120000"/>
-                </a:lnTo>
-                <a:lnTo>
-                  <a:pt x="0" y="120000"/>
-                </a:lnTo>
-                <a:close/>
-              </a:path>
-            </a:pathLst>
-          </a:custGeom>
-        </p:spPr>
-      </p:sp>
-    </p:spTree>
-    <p:extLst>
-      <p:ext uri="{BB962C8B-B14F-4D97-AF65-F5344CB8AC3E}">
-        <p14:creationId xmlns:p14="http://schemas.microsoft.com/office/powerpoint/2010/main" val="4100974644"/>
-      </p:ext>
-    </p:extLst>
-  </p:cSld>
-  <p:clrMapOvr>
-    <a:masterClrMapping/>
-  </p:clrMapOvr>
-</p:notes>
-</file>
-
-<file path=ppt/notesSlides/notesSlide11.xml><?xml version="1.0" encoding="utf-8"?>
-<p:notes xmlns:a="http://schemas.openxmlformats.org/drawingml/2006/main" xmlns:r="http://schemas.openxmlformats.org/officeDocument/2006/relationships" xmlns:p="http://schemas.openxmlformats.org/presentationml/2006/main" showMasterSp="0" showMasterPhAnim="0">
-  <p:cSld>
-    <p:spTree>
-      <p:nvGrpSpPr>
-        <p:cNvPr id="1" name="Shape 141"/>
-        <p:cNvGrpSpPr/>
-        <p:nvPr/>
-      </p:nvGrpSpPr>
-      <p:grpSpPr>
-        <a:xfrm>
-          <a:off x="0" y="0"/>
-          <a:ext cx="0" cy="0"/>
-          <a:chOff x="0" y="0"/>
-          <a:chExt cx="0" cy="0"/>
-        </a:xfrm>
-      </p:grpSpPr>
-      <p:sp>
-        <p:nvSpPr>
-          <p:cNvPr id="142" name="Google Shape;142;p13:notes"/>
-          <p:cNvSpPr txBox="1">
-            <a:spLocks noGrp="1"/>
-          </p:cNvSpPr>
-          <p:nvPr>
-            <p:ph type="body" idx="1"/>
-          </p:nvPr>
-        </p:nvSpPr>
-        <p:spPr>
-          <a:xfrm>
-            <a:off x="685800" y="4400550"/>
-            <a:ext cx="5486400" cy="3600450"/>
-          </a:xfrm>
-          <a:prstGeom prst="rect">
-            <a:avLst/>
-          </a:prstGeom>
-        </p:spPr>
-        <p:txBody>
-          <a:bodyPr spcFirstLastPara="1" wrap="square" lIns="91425" tIns="45700" rIns="91425" bIns="45700" anchor="t" anchorCtr="0">
-            <a:noAutofit/>
-          </a:bodyPr>
-          <a:lstStyle/>
-          <a:p>
-            <a:pPr marL="0" lvl="0" indent="0" algn="l" rtl="0">
-              <a:spcBef>
-                <a:spcPts val="0"/>
-              </a:spcBef>
-              <a:spcAft>
-                <a:spcPts val="0"/>
-              </a:spcAft>
-              <a:buNone/>
-            </a:pPr>
-            <a:endParaRPr/>
-          </a:p>
-        </p:txBody>
-      </p:sp>
-      <p:sp>
-        <p:nvSpPr>
-          <p:cNvPr id="143" name="Google Shape;143;p13:notes"/>
-          <p:cNvSpPr>
-            <a:spLocks noGrp="1" noRot="1" noChangeAspect="1"/>
-          </p:cNvSpPr>
-          <p:nvPr>
-            <p:ph type="sldImg" idx="2"/>
-          </p:nvPr>
-        </p:nvSpPr>
-        <p:spPr>
-          <a:xfrm>
-            <a:off x="685800" y="1143000"/>
-            <a:ext cx="5486400" cy="3086100"/>
-          </a:xfrm>
-          <a:custGeom>
-            <a:avLst/>
-            <a:gdLst/>
-            <a:ahLst/>
-            <a:cxnLst/>
-            <a:rect l="l" t="t" r="r" b="b"/>
-            <a:pathLst>
-              <a:path w="120000" h="120000" extrusionOk="0">
-                <a:moveTo>
-                  <a:pt x="0" y="0"/>
-                </a:moveTo>
-                <a:lnTo>
-                  <a:pt x="120000" y="0"/>
-                </a:lnTo>
-                <a:lnTo>
-                  <a:pt x="120000" y="120000"/>
-                </a:lnTo>
-                <a:lnTo>
-                  <a:pt x="0" y="120000"/>
-                </a:lnTo>
-                <a:close/>
-              </a:path>
-            </a:pathLst>
-          </a:custGeom>
-        </p:spPr>
-      </p:sp>
-    </p:spTree>
-    <p:extLst>
-      <p:ext uri="{BB962C8B-B14F-4D97-AF65-F5344CB8AC3E}">
-        <p14:creationId xmlns:p14="http://schemas.microsoft.com/office/powerpoint/2010/main" val="260157013"/>
-      </p:ext>
-    </p:extLst>
-  </p:cSld>
-  <p:clrMapOvr>
-    <a:masterClrMapping/>
-  </p:clrMapOvr>
-</p:notes>
-</file>
-
-<file path=ppt/notesSlides/notesSlide12.xml><?xml version="1.0" encoding="utf-8"?>
-<p:notes xmlns:a="http://schemas.openxmlformats.org/drawingml/2006/main" xmlns:r="http://schemas.openxmlformats.org/officeDocument/2006/relationships" xmlns:p="http://schemas.openxmlformats.org/presentationml/2006/main" showMasterSp="0" showMasterPhAnim="0">
-  <p:cSld>
-    <p:spTree>
-      <p:nvGrpSpPr>
-        <p:cNvPr id="1" name="Shape 110"/>
-        <p:cNvGrpSpPr/>
-        <p:nvPr/>
-      </p:nvGrpSpPr>
-      <p:grpSpPr>
-        <a:xfrm>
-          <a:off x="0" y="0"/>
-          <a:ext cx="0" cy="0"/>
-          <a:chOff x="0" y="0"/>
-          <a:chExt cx="0" cy="0"/>
-        </a:xfrm>
-      </p:grpSpPr>
-      <p:sp>
-        <p:nvSpPr>
-          <p:cNvPr id="111" name="Google Shape;111;p4:notes"/>
-          <p:cNvSpPr txBox="1">
-            <a:spLocks noGrp="1"/>
-          </p:cNvSpPr>
-          <p:nvPr>
-            <p:ph type="body" idx="1"/>
-          </p:nvPr>
-        </p:nvSpPr>
-        <p:spPr>
-          <a:xfrm>
-            <a:off x="685800" y="4400550"/>
-            <a:ext cx="5486400" cy="3600450"/>
-          </a:xfrm>
-          <a:prstGeom prst="rect">
-            <a:avLst/>
-          </a:prstGeom>
-        </p:spPr>
-        <p:txBody>
-          <a:bodyPr spcFirstLastPara="1" wrap="square" lIns="91425" tIns="45700" rIns="91425" bIns="45700" anchor="t" anchorCtr="0">
-            <a:noAutofit/>
-          </a:bodyPr>
-          <a:lstStyle/>
-          <a:p>
-            <a:pPr marL="0" lvl="0" indent="0" algn="l" rtl="0">
-              <a:spcBef>
-                <a:spcPts val="0"/>
-              </a:spcBef>
-              <a:spcAft>
-                <a:spcPts val="0"/>
-              </a:spcAft>
-              <a:buNone/>
-            </a:pPr>
-            <a:endParaRPr/>
-          </a:p>
-        </p:txBody>
-      </p:sp>
-      <p:sp>
-        <p:nvSpPr>
-          <p:cNvPr id="112" name="Google Shape;112;p4:notes"/>
-          <p:cNvSpPr>
-            <a:spLocks noGrp="1" noRot="1" noChangeAspect="1"/>
-          </p:cNvSpPr>
-          <p:nvPr>
-            <p:ph type="sldImg" idx="2"/>
-          </p:nvPr>
-        </p:nvSpPr>
-        <p:spPr>
-          <a:xfrm>
-            <a:off x="685800" y="1143000"/>
-            <a:ext cx="5486400" cy="3086100"/>
-          </a:xfrm>
-          <a:custGeom>
-            <a:avLst/>
-            <a:gdLst/>
-            <a:ahLst/>
-            <a:cxnLst/>
-            <a:rect l="l" t="t" r="r" b="b"/>
-            <a:pathLst>
-              <a:path w="120000" h="120000" extrusionOk="0">
-                <a:moveTo>
-                  <a:pt x="0" y="0"/>
-                </a:moveTo>
-                <a:lnTo>
-                  <a:pt x="120000" y="0"/>
-                </a:lnTo>
-                <a:lnTo>
-                  <a:pt x="120000" y="120000"/>
-                </a:lnTo>
-                <a:lnTo>
-                  <a:pt x="0" y="120000"/>
-                </a:lnTo>
-                <a:close/>
-              </a:path>
-            </a:pathLst>
-          </a:custGeom>
-        </p:spPr>
-      </p:sp>
-    </p:spTree>
-    <p:extLst>
-      <p:ext uri="{BB962C8B-B14F-4D97-AF65-F5344CB8AC3E}">
-        <p14:creationId xmlns:p14="http://schemas.microsoft.com/office/powerpoint/2010/main" val="2706258694"/>
-      </p:ext>
-    </p:extLst>
-  </p:cSld>
-  <p:clrMapOvr>
-    <a:masterClrMapping/>
-  </p:clrMapOvr>
-</p:notes>
-</file>
-
-<file path=ppt/notesSlides/notesSlide13.xml><?xml version="1.0" encoding="utf-8"?>
-<p:notes xmlns:a="http://schemas.openxmlformats.org/drawingml/2006/main" xmlns:r="http://schemas.openxmlformats.org/officeDocument/2006/relationships" xmlns:p="http://schemas.openxmlformats.org/presentationml/2006/main" showMasterSp="0" showMasterPhAnim="0">
-  <p:cSld>
-    <p:spTree>
-      <p:nvGrpSpPr>
         <p:cNvPr id="1" name="Shape 141"/>
         <p:cNvGrpSpPr/>
         <p:nvPr/>
@@ -2022,7 +1697,552 @@
 </p:notes>
 </file>
 
+<file path=ppt/notesSlides/notesSlide11.xml><?xml version="1.0" encoding="utf-8"?>
+<p:notes xmlns:a="http://schemas.openxmlformats.org/drawingml/2006/main" xmlns:r="http://schemas.openxmlformats.org/officeDocument/2006/relationships" xmlns:p="http://schemas.openxmlformats.org/presentationml/2006/main" showMasterSp="0" showMasterPhAnim="0">
+  <p:cSld>
+    <p:spTree>
+      <p:nvGrpSpPr>
+        <p:cNvPr id="1" name="Shape 110"/>
+        <p:cNvGrpSpPr/>
+        <p:nvPr/>
+      </p:nvGrpSpPr>
+      <p:grpSpPr>
+        <a:xfrm>
+          <a:off x="0" y="0"/>
+          <a:ext cx="0" cy="0"/>
+          <a:chOff x="0" y="0"/>
+          <a:chExt cx="0" cy="0"/>
+        </a:xfrm>
+      </p:grpSpPr>
+      <p:sp>
+        <p:nvSpPr>
+          <p:cNvPr id="111" name="Google Shape;111;p4:notes"/>
+          <p:cNvSpPr txBox="1">
+            <a:spLocks noGrp="1"/>
+          </p:cNvSpPr>
+          <p:nvPr>
+            <p:ph type="body" idx="1"/>
+          </p:nvPr>
+        </p:nvSpPr>
+        <p:spPr>
+          <a:xfrm>
+            <a:off x="685800" y="4400550"/>
+            <a:ext cx="5486400" cy="3600450"/>
+          </a:xfrm>
+          <a:prstGeom prst="rect">
+            <a:avLst/>
+          </a:prstGeom>
+        </p:spPr>
+        <p:txBody>
+          <a:bodyPr spcFirstLastPara="1" wrap="square" lIns="91425" tIns="45700" rIns="91425" bIns="45700" anchor="t" anchorCtr="0">
+            <a:noAutofit/>
+          </a:bodyPr>
+          <a:lstStyle/>
+          <a:p>
+            <a:pPr marL="0" lvl="0" indent="0" algn="l" rtl="0">
+              <a:spcBef>
+                <a:spcPts val="0"/>
+              </a:spcBef>
+              <a:spcAft>
+                <a:spcPts val="0"/>
+              </a:spcAft>
+              <a:buNone/>
+            </a:pPr>
+            <a:endParaRPr/>
+          </a:p>
+        </p:txBody>
+      </p:sp>
+      <p:sp>
+        <p:nvSpPr>
+          <p:cNvPr id="112" name="Google Shape;112;p4:notes"/>
+          <p:cNvSpPr>
+            <a:spLocks noGrp="1" noRot="1" noChangeAspect="1"/>
+          </p:cNvSpPr>
+          <p:nvPr>
+            <p:ph type="sldImg" idx="2"/>
+          </p:nvPr>
+        </p:nvSpPr>
+        <p:spPr>
+          <a:xfrm>
+            <a:off x="685800" y="1143000"/>
+            <a:ext cx="5486400" cy="3086100"/>
+          </a:xfrm>
+          <a:custGeom>
+            <a:avLst/>
+            <a:gdLst/>
+            <a:ahLst/>
+            <a:cxnLst/>
+            <a:rect l="l" t="t" r="r" b="b"/>
+            <a:pathLst>
+              <a:path w="120000" h="120000" extrusionOk="0">
+                <a:moveTo>
+                  <a:pt x="0" y="0"/>
+                </a:moveTo>
+                <a:lnTo>
+                  <a:pt x="120000" y="0"/>
+                </a:lnTo>
+                <a:lnTo>
+                  <a:pt x="120000" y="120000"/>
+                </a:lnTo>
+                <a:lnTo>
+                  <a:pt x="0" y="120000"/>
+                </a:lnTo>
+                <a:close/>
+              </a:path>
+            </a:pathLst>
+          </a:custGeom>
+        </p:spPr>
+      </p:sp>
+    </p:spTree>
+    <p:extLst>
+      <p:ext uri="{BB962C8B-B14F-4D97-AF65-F5344CB8AC3E}">
+        <p14:creationId xmlns:p14="http://schemas.microsoft.com/office/powerpoint/2010/main" val="1509333727"/>
+      </p:ext>
+    </p:extLst>
+  </p:cSld>
+  <p:clrMapOvr>
+    <a:masterClrMapping/>
+  </p:clrMapOvr>
+</p:notes>
+</file>
+
+<file path=ppt/notesSlides/notesSlide12.xml><?xml version="1.0" encoding="utf-8"?>
+<p:notes xmlns:a="http://schemas.openxmlformats.org/drawingml/2006/main" xmlns:r="http://schemas.openxmlformats.org/officeDocument/2006/relationships" xmlns:p="http://schemas.openxmlformats.org/presentationml/2006/main" showMasterSp="0" showMasterPhAnim="0">
+  <p:cSld>
+    <p:spTree>
+      <p:nvGrpSpPr>
+        <p:cNvPr id="1" name="Shape 141"/>
+        <p:cNvGrpSpPr/>
+        <p:nvPr/>
+      </p:nvGrpSpPr>
+      <p:grpSpPr>
+        <a:xfrm>
+          <a:off x="0" y="0"/>
+          <a:ext cx="0" cy="0"/>
+          <a:chOff x="0" y="0"/>
+          <a:chExt cx="0" cy="0"/>
+        </a:xfrm>
+      </p:grpSpPr>
+      <p:sp>
+        <p:nvSpPr>
+          <p:cNvPr id="142" name="Google Shape;142;p13:notes"/>
+          <p:cNvSpPr txBox="1">
+            <a:spLocks noGrp="1"/>
+          </p:cNvSpPr>
+          <p:nvPr>
+            <p:ph type="body" idx="1"/>
+          </p:nvPr>
+        </p:nvSpPr>
+        <p:spPr>
+          <a:xfrm>
+            <a:off x="685800" y="4400550"/>
+            <a:ext cx="5486400" cy="3600450"/>
+          </a:xfrm>
+          <a:prstGeom prst="rect">
+            <a:avLst/>
+          </a:prstGeom>
+        </p:spPr>
+        <p:txBody>
+          <a:bodyPr spcFirstLastPara="1" wrap="square" lIns="91425" tIns="45700" rIns="91425" bIns="45700" anchor="t" anchorCtr="0">
+            <a:noAutofit/>
+          </a:bodyPr>
+          <a:lstStyle/>
+          <a:p>
+            <a:pPr marL="0" lvl="0" indent="0" algn="l" rtl="0">
+              <a:spcBef>
+                <a:spcPts val="0"/>
+              </a:spcBef>
+              <a:spcAft>
+                <a:spcPts val="0"/>
+              </a:spcAft>
+              <a:buNone/>
+            </a:pPr>
+            <a:endParaRPr/>
+          </a:p>
+        </p:txBody>
+      </p:sp>
+      <p:sp>
+        <p:nvSpPr>
+          <p:cNvPr id="143" name="Google Shape;143;p13:notes"/>
+          <p:cNvSpPr>
+            <a:spLocks noGrp="1" noRot="1" noChangeAspect="1"/>
+          </p:cNvSpPr>
+          <p:nvPr>
+            <p:ph type="sldImg" idx="2"/>
+          </p:nvPr>
+        </p:nvSpPr>
+        <p:spPr>
+          <a:xfrm>
+            <a:off x="685800" y="1143000"/>
+            <a:ext cx="5486400" cy="3086100"/>
+          </a:xfrm>
+          <a:custGeom>
+            <a:avLst/>
+            <a:gdLst/>
+            <a:ahLst/>
+            <a:cxnLst/>
+            <a:rect l="l" t="t" r="r" b="b"/>
+            <a:pathLst>
+              <a:path w="120000" h="120000" extrusionOk="0">
+                <a:moveTo>
+                  <a:pt x="0" y="0"/>
+                </a:moveTo>
+                <a:lnTo>
+                  <a:pt x="120000" y="0"/>
+                </a:lnTo>
+                <a:lnTo>
+                  <a:pt x="120000" y="120000"/>
+                </a:lnTo>
+                <a:lnTo>
+                  <a:pt x="0" y="120000"/>
+                </a:lnTo>
+                <a:close/>
+              </a:path>
+            </a:pathLst>
+          </a:custGeom>
+        </p:spPr>
+      </p:sp>
+    </p:spTree>
+    <p:extLst>
+      <p:ext uri="{BB962C8B-B14F-4D97-AF65-F5344CB8AC3E}">
+        <p14:creationId xmlns:p14="http://schemas.microsoft.com/office/powerpoint/2010/main" val="4248180530"/>
+      </p:ext>
+    </p:extLst>
+  </p:cSld>
+  <p:clrMapOvr>
+    <a:masterClrMapping/>
+  </p:clrMapOvr>
+</p:notes>
+</file>
+
+<file path=ppt/notesSlides/notesSlide13.xml><?xml version="1.0" encoding="utf-8"?>
+<p:notes xmlns:a="http://schemas.openxmlformats.org/drawingml/2006/main" xmlns:r="http://schemas.openxmlformats.org/officeDocument/2006/relationships" xmlns:p="http://schemas.openxmlformats.org/presentationml/2006/main" showMasterSp="0" showMasterPhAnim="0">
+  <p:cSld>
+    <p:spTree>
+      <p:nvGrpSpPr>
+        <p:cNvPr id="1" name="Shape 141"/>
+        <p:cNvGrpSpPr/>
+        <p:nvPr/>
+      </p:nvGrpSpPr>
+      <p:grpSpPr>
+        <a:xfrm>
+          <a:off x="0" y="0"/>
+          <a:ext cx="0" cy="0"/>
+          <a:chOff x="0" y="0"/>
+          <a:chExt cx="0" cy="0"/>
+        </a:xfrm>
+      </p:grpSpPr>
+      <p:sp>
+        <p:nvSpPr>
+          <p:cNvPr id="142" name="Google Shape;142;p13:notes"/>
+          <p:cNvSpPr txBox="1">
+            <a:spLocks noGrp="1"/>
+          </p:cNvSpPr>
+          <p:nvPr>
+            <p:ph type="body" idx="1"/>
+          </p:nvPr>
+        </p:nvSpPr>
+        <p:spPr>
+          <a:xfrm>
+            <a:off x="685800" y="4400550"/>
+            <a:ext cx="5486400" cy="3600450"/>
+          </a:xfrm>
+          <a:prstGeom prst="rect">
+            <a:avLst/>
+          </a:prstGeom>
+        </p:spPr>
+        <p:txBody>
+          <a:bodyPr spcFirstLastPara="1" wrap="square" lIns="91425" tIns="45700" rIns="91425" bIns="45700" anchor="t" anchorCtr="0">
+            <a:noAutofit/>
+          </a:bodyPr>
+          <a:lstStyle/>
+          <a:p>
+            <a:pPr marL="0" lvl="0" indent="0" algn="l" rtl="0">
+              <a:spcBef>
+                <a:spcPts val="0"/>
+              </a:spcBef>
+              <a:spcAft>
+                <a:spcPts val="0"/>
+              </a:spcAft>
+              <a:buNone/>
+            </a:pPr>
+            <a:endParaRPr/>
+          </a:p>
+        </p:txBody>
+      </p:sp>
+      <p:sp>
+        <p:nvSpPr>
+          <p:cNvPr id="143" name="Google Shape;143;p13:notes"/>
+          <p:cNvSpPr>
+            <a:spLocks noGrp="1" noRot="1" noChangeAspect="1"/>
+          </p:cNvSpPr>
+          <p:nvPr>
+            <p:ph type="sldImg" idx="2"/>
+          </p:nvPr>
+        </p:nvSpPr>
+        <p:spPr>
+          <a:xfrm>
+            <a:off x="685800" y="1143000"/>
+            <a:ext cx="5486400" cy="3086100"/>
+          </a:xfrm>
+          <a:custGeom>
+            <a:avLst/>
+            <a:gdLst/>
+            <a:ahLst/>
+            <a:cxnLst/>
+            <a:rect l="l" t="t" r="r" b="b"/>
+            <a:pathLst>
+              <a:path w="120000" h="120000" extrusionOk="0">
+                <a:moveTo>
+                  <a:pt x="0" y="0"/>
+                </a:moveTo>
+                <a:lnTo>
+                  <a:pt x="120000" y="0"/>
+                </a:lnTo>
+                <a:lnTo>
+                  <a:pt x="120000" y="120000"/>
+                </a:lnTo>
+                <a:lnTo>
+                  <a:pt x="0" y="120000"/>
+                </a:lnTo>
+                <a:close/>
+              </a:path>
+            </a:pathLst>
+          </a:custGeom>
+        </p:spPr>
+      </p:sp>
+    </p:spTree>
+    <p:extLst>
+      <p:ext uri="{BB962C8B-B14F-4D97-AF65-F5344CB8AC3E}">
+        <p14:creationId xmlns:p14="http://schemas.microsoft.com/office/powerpoint/2010/main" val="182298553"/>
+      </p:ext>
+    </p:extLst>
+  </p:cSld>
+  <p:clrMapOvr>
+    <a:masterClrMapping/>
+  </p:clrMapOvr>
+</p:notes>
+</file>
+
 <file path=ppt/notesSlides/notesSlide14.xml><?xml version="1.0" encoding="utf-8"?>
+<p:notes xmlns:a="http://schemas.openxmlformats.org/drawingml/2006/main" xmlns:r="http://schemas.openxmlformats.org/officeDocument/2006/relationships" xmlns:p="http://schemas.openxmlformats.org/presentationml/2006/main" showMasterSp="0" showMasterPhAnim="0">
+  <p:cSld>
+    <p:spTree>
+      <p:nvGrpSpPr>
+        <p:cNvPr id="1" name="Shape 110"/>
+        <p:cNvGrpSpPr/>
+        <p:nvPr/>
+      </p:nvGrpSpPr>
+      <p:grpSpPr>
+        <a:xfrm>
+          <a:off x="0" y="0"/>
+          <a:ext cx="0" cy="0"/>
+          <a:chOff x="0" y="0"/>
+          <a:chExt cx="0" cy="0"/>
+        </a:xfrm>
+      </p:grpSpPr>
+      <p:sp>
+        <p:nvSpPr>
+          <p:cNvPr id="111" name="Google Shape;111;p4:notes"/>
+          <p:cNvSpPr txBox="1">
+            <a:spLocks noGrp="1"/>
+          </p:cNvSpPr>
+          <p:nvPr>
+            <p:ph type="body" idx="1"/>
+          </p:nvPr>
+        </p:nvSpPr>
+        <p:spPr>
+          <a:xfrm>
+            <a:off x="685800" y="4400550"/>
+            <a:ext cx="5486400" cy="3600450"/>
+          </a:xfrm>
+          <a:prstGeom prst="rect">
+            <a:avLst/>
+          </a:prstGeom>
+        </p:spPr>
+        <p:txBody>
+          <a:bodyPr spcFirstLastPara="1" wrap="square" lIns="91425" tIns="45700" rIns="91425" bIns="45700" anchor="t" anchorCtr="0">
+            <a:noAutofit/>
+          </a:bodyPr>
+          <a:lstStyle/>
+          <a:p>
+            <a:pPr marL="0" lvl="0" indent="0" algn="l" rtl="0">
+              <a:spcBef>
+                <a:spcPts val="0"/>
+              </a:spcBef>
+              <a:spcAft>
+                <a:spcPts val="0"/>
+              </a:spcAft>
+              <a:buNone/>
+            </a:pPr>
+            <a:endParaRPr/>
+          </a:p>
+        </p:txBody>
+      </p:sp>
+      <p:sp>
+        <p:nvSpPr>
+          <p:cNvPr id="112" name="Google Shape;112;p4:notes"/>
+          <p:cNvSpPr>
+            <a:spLocks noGrp="1" noRot="1" noChangeAspect="1"/>
+          </p:cNvSpPr>
+          <p:nvPr>
+            <p:ph type="sldImg" idx="2"/>
+          </p:nvPr>
+        </p:nvSpPr>
+        <p:spPr>
+          <a:xfrm>
+            <a:off x="685800" y="1143000"/>
+            <a:ext cx="5486400" cy="3086100"/>
+          </a:xfrm>
+          <a:custGeom>
+            <a:avLst/>
+            <a:gdLst/>
+            <a:ahLst/>
+            <a:cxnLst/>
+            <a:rect l="l" t="t" r="r" b="b"/>
+            <a:pathLst>
+              <a:path w="120000" h="120000" extrusionOk="0">
+                <a:moveTo>
+                  <a:pt x="0" y="0"/>
+                </a:moveTo>
+                <a:lnTo>
+                  <a:pt x="120000" y="0"/>
+                </a:lnTo>
+                <a:lnTo>
+                  <a:pt x="120000" y="120000"/>
+                </a:lnTo>
+                <a:lnTo>
+                  <a:pt x="0" y="120000"/>
+                </a:lnTo>
+                <a:close/>
+              </a:path>
+            </a:pathLst>
+          </a:custGeom>
+        </p:spPr>
+      </p:sp>
+    </p:spTree>
+    <p:extLst>
+      <p:ext uri="{BB962C8B-B14F-4D97-AF65-F5344CB8AC3E}">
+        <p14:creationId xmlns:p14="http://schemas.microsoft.com/office/powerpoint/2010/main" val="3949990764"/>
+      </p:ext>
+    </p:extLst>
+  </p:cSld>
+  <p:clrMapOvr>
+    <a:masterClrMapping/>
+  </p:clrMapOvr>
+</p:notes>
+</file>
+
+<file path=ppt/notesSlides/notesSlide15.xml><?xml version="1.0" encoding="utf-8"?>
+<p:notes xmlns:a="http://schemas.openxmlformats.org/drawingml/2006/main" xmlns:r="http://schemas.openxmlformats.org/officeDocument/2006/relationships" xmlns:p="http://schemas.openxmlformats.org/presentationml/2006/main" showMasterSp="0" showMasterPhAnim="0">
+  <p:cSld>
+    <p:spTree>
+      <p:nvGrpSpPr>
+        <p:cNvPr id="1" name="Shape 141"/>
+        <p:cNvGrpSpPr/>
+        <p:nvPr/>
+      </p:nvGrpSpPr>
+      <p:grpSpPr>
+        <a:xfrm>
+          <a:off x="0" y="0"/>
+          <a:ext cx="0" cy="0"/>
+          <a:chOff x="0" y="0"/>
+          <a:chExt cx="0" cy="0"/>
+        </a:xfrm>
+      </p:grpSpPr>
+      <p:sp>
+        <p:nvSpPr>
+          <p:cNvPr id="142" name="Google Shape;142;p13:notes"/>
+          <p:cNvSpPr txBox="1">
+            <a:spLocks noGrp="1"/>
+          </p:cNvSpPr>
+          <p:nvPr>
+            <p:ph type="body" idx="1"/>
+          </p:nvPr>
+        </p:nvSpPr>
+        <p:spPr>
+          <a:xfrm>
+            <a:off x="685800" y="4400550"/>
+            <a:ext cx="5486400" cy="3600450"/>
+          </a:xfrm>
+          <a:prstGeom prst="rect">
+            <a:avLst/>
+          </a:prstGeom>
+        </p:spPr>
+        <p:txBody>
+          <a:bodyPr spcFirstLastPara="1" wrap="square" lIns="91425" tIns="45700" rIns="91425" bIns="45700" anchor="t" anchorCtr="0">
+            <a:noAutofit/>
+          </a:bodyPr>
+          <a:lstStyle/>
+          <a:p>
+            <a:pPr marL="0" lvl="0" indent="0" algn="l" rtl="0">
+              <a:spcBef>
+                <a:spcPts val="0"/>
+              </a:spcBef>
+              <a:spcAft>
+                <a:spcPts val="0"/>
+              </a:spcAft>
+              <a:buNone/>
+            </a:pPr>
+            <a:endParaRPr/>
+          </a:p>
+        </p:txBody>
+      </p:sp>
+      <p:sp>
+        <p:nvSpPr>
+          <p:cNvPr id="143" name="Google Shape;143;p13:notes"/>
+          <p:cNvSpPr>
+            <a:spLocks noGrp="1" noRot="1" noChangeAspect="1"/>
+          </p:cNvSpPr>
+          <p:nvPr>
+            <p:ph type="sldImg" idx="2"/>
+          </p:nvPr>
+        </p:nvSpPr>
+        <p:spPr>
+          <a:xfrm>
+            <a:off x="685800" y="1143000"/>
+            <a:ext cx="5486400" cy="3086100"/>
+          </a:xfrm>
+          <a:custGeom>
+            <a:avLst/>
+            <a:gdLst/>
+            <a:ahLst/>
+            <a:cxnLst/>
+            <a:rect l="l" t="t" r="r" b="b"/>
+            <a:pathLst>
+              <a:path w="120000" h="120000" extrusionOk="0">
+                <a:moveTo>
+                  <a:pt x="0" y="0"/>
+                </a:moveTo>
+                <a:lnTo>
+                  <a:pt x="120000" y="0"/>
+                </a:lnTo>
+                <a:lnTo>
+                  <a:pt x="120000" y="120000"/>
+                </a:lnTo>
+                <a:lnTo>
+                  <a:pt x="0" y="120000"/>
+                </a:lnTo>
+                <a:close/>
+              </a:path>
+            </a:pathLst>
+          </a:custGeom>
+        </p:spPr>
+      </p:sp>
+    </p:spTree>
+    <p:extLst>
+      <p:ext uri="{BB962C8B-B14F-4D97-AF65-F5344CB8AC3E}">
+        <p14:creationId xmlns:p14="http://schemas.microsoft.com/office/powerpoint/2010/main" val="2950394198"/>
+      </p:ext>
+    </p:extLst>
+  </p:cSld>
+  <p:clrMapOvr>
+    <a:masterClrMapping/>
+  </p:clrMapOvr>
+</p:notes>
+</file>
+
+<file path=ppt/notesSlides/notesSlide16.xml><?xml version="1.0" encoding="utf-8"?>
 <p:notes xmlns:a="http://schemas.openxmlformats.org/drawingml/2006/main" xmlns:r="http://schemas.openxmlformats.org/officeDocument/2006/relationships" xmlns:p="http://schemas.openxmlformats.org/presentationml/2006/main" showMasterSp="0" showMasterPhAnim="0">
   <p:cSld>
     <p:spTree>
@@ -2748,6 +2968,11 @@
         </p:spPr>
       </p:sp>
     </p:spTree>
+    <p:extLst>
+      <p:ext uri="{BB962C8B-B14F-4D97-AF65-F5344CB8AC3E}">
+        <p14:creationId xmlns:p14="http://schemas.microsoft.com/office/powerpoint/2010/main" val="2738815877"/>
+      </p:ext>
+    </p:extLst>
   </p:cSld>
   <p:clrMapOvr>
     <a:masterClrMapping/>
@@ -2760,7 +2985,7 @@
   <p:cSld>
     <p:spTree>
       <p:nvGrpSpPr>
-        <p:cNvPr id="1" name="Shape 110"/>
+        <p:cNvPr id="1" name="Shape 141"/>
         <p:cNvGrpSpPr/>
         <p:nvPr/>
       </p:nvGrpSpPr>
@@ -2774,7 +2999,7 @@
       </p:grpSpPr>
       <p:sp>
         <p:nvSpPr>
-          <p:cNvPr id="111" name="Google Shape;111;p4:notes"/>
+          <p:cNvPr id="142" name="Google Shape;142;p13:notes"/>
           <p:cNvSpPr txBox="1">
             <a:spLocks noGrp="1"/>
           </p:cNvSpPr>
@@ -2812,7 +3037,7 @@
       </p:sp>
       <p:sp>
         <p:nvSpPr>
-          <p:cNvPr id="112" name="Google Shape;112;p4:notes"/>
+          <p:cNvPr id="143" name="Google Shape;143;p13:notes"/>
           <p:cNvSpPr>
             <a:spLocks noGrp="1" noRot="1" noChangeAspect="1"/>
           </p:cNvSpPr>
@@ -2854,7 +3079,7 @@
     </p:spTree>
     <p:extLst>
       <p:ext uri="{BB962C8B-B14F-4D97-AF65-F5344CB8AC3E}">
-        <p14:creationId xmlns:p14="http://schemas.microsoft.com/office/powerpoint/2010/main" val="2010906346"/>
+        <p14:creationId xmlns:p14="http://schemas.microsoft.com/office/powerpoint/2010/main" val="260157013"/>
       </p:ext>
     </p:extLst>
   </p:cSld>
@@ -2961,11 +3186,6 @@
         </p:spPr>
       </p:sp>
     </p:spTree>
-    <p:extLst>
-      <p:ext uri="{BB962C8B-B14F-4D97-AF65-F5344CB8AC3E}">
-        <p14:creationId xmlns:p14="http://schemas.microsoft.com/office/powerpoint/2010/main" val="2738815877"/>
-      </p:ext>
-    </p:extLst>
   </p:cSld>
   <p:clrMapOvr>
     <a:masterClrMapping/>
@@ -13972,425 +14192,6 @@
     </p:bg>
     <p:spTree>
       <p:nvGrpSpPr>
-        <p:cNvPr id="1" name="Shape 113"/>
-        <p:cNvGrpSpPr/>
-        <p:nvPr/>
-      </p:nvGrpSpPr>
-      <p:grpSpPr>
-        <a:xfrm>
-          <a:off x="0" y="0"/>
-          <a:ext cx="0" cy="0"/>
-          <a:chOff x="0" y="0"/>
-          <a:chExt cx="0" cy="0"/>
-        </a:xfrm>
-      </p:grpSpPr>
-      <p:sp>
-        <p:nvSpPr>
-          <p:cNvPr id="114" name="Google Shape;114;p4"/>
-          <p:cNvSpPr txBox="1"/>
-          <p:nvPr/>
-        </p:nvSpPr>
-        <p:spPr>
-          <a:xfrm>
-            <a:off x="1249020" y="2498278"/>
-            <a:ext cx="9776765" cy="1015622"/>
-          </a:xfrm>
-          <a:prstGeom prst="rect">
-            <a:avLst/>
-          </a:prstGeom>
-          <a:noFill/>
-          <a:ln>
-            <a:noFill/>
-          </a:ln>
-        </p:spPr>
-        <p:txBody>
-          <a:bodyPr spcFirstLastPara="1" wrap="square" lIns="91425" tIns="45700" rIns="91425" bIns="45700" anchor="t" anchorCtr="0">
-            <a:spAutoFit/>
-          </a:bodyPr>
-          <a:lstStyle/>
-          <a:p>
-            <a:pPr algn="ctr"/>
-            <a:r>
-              <a:rPr lang="es-CO" sz="6000" b="1" dirty="0">
-                <a:solidFill>
-                  <a:schemeClr val="lt1"/>
-                </a:solidFill>
-                <a:latin typeface="Work Sans"/>
-                <a:ea typeface="Work Sans"/>
-                <a:cs typeface="Work Sans"/>
-                <a:sym typeface="Work Sans"/>
-              </a:rPr>
-              <a:t>Diagrama de Clases UML</a:t>
-            </a:r>
-            <a:endParaRPr sz="7200" b="1" dirty="0">
-              <a:solidFill>
-                <a:schemeClr val="lt1"/>
-              </a:solidFill>
-              <a:latin typeface="Work Sans"/>
-              <a:ea typeface="Work Sans"/>
-              <a:cs typeface="Work Sans"/>
-              <a:sym typeface="Work Sans"/>
-            </a:endParaRPr>
-          </a:p>
-        </p:txBody>
-      </p:sp>
-      <p:cxnSp>
-        <p:nvCxnSpPr>
-          <p:cNvPr id="115" name="Google Shape;115;p4"/>
-          <p:cNvCxnSpPr/>
-          <p:nvPr/>
-        </p:nvCxnSpPr>
-        <p:spPr>
-          <a:xfrm>
-            <a:off x="5013631" y="3555133"/>
-            <a:ext cx="2247544" cy="0"/>
-          </a:xfrm>
-          <a:prstGeom prst="straightConnector1">
-            <a:avLst/>
-          </a:prstGeom>
-          <a:noFill/>
-          <a:ln w="12700" cap="flat" cmpd="sng">
-            <a:solidFill>
-              <a:schemeClr val="lt1"/>
-            </a:solidFill>
-            <a:prstDash val="solid"/>
-            <a:miter lim="800000"/>
-            <a:headEnd type="none" w="sm" len="sm"/>
-            <a:tailEnd type="none" w="sm" len="sm"/>
-          </a:ln>
-        </p:spPr>
-      </p:cxnSp>
-    </p:spTree>
-    <p:extLst>
-      <p:ext uri="{BB962C8B-B14F-4D97-AF65-F5344CB8AC3E}">
-        <p14:creationId xmlns:p14="http://schemas.microsoft.com/office/powerpoint/2010/main" val="3875639161"/>
-      </p:ext>
-    </p:extLst>
-  </p:cSld>
-  <p:clrMapOvr>
-    <a:masterClrMapping/>
-  </p:clrMapOvr>
-</p:sld>
-</file>
-
-<file path=ppt/slides/slide11.xml><?xml version="1.0" encoding="utf-8"?>
-<p:sld xmlns:a="http://schemas.openxmlformats.org/drawingml/2006/main" xmlns:r="http://schemas.openxmlformats.org/officeDocument/2006/relationships" xmlns:p="http://schemas.openxmlformats.org/presentationml/2006/main">
-  <p:cSld>
-    <p:bg>
-      <p:bgPr>
-        <a:blipFill>
-          <a:blip r:embed="rId3">
-            <a:alphaModFix/>
-          </a:blip>
-          <a:stretch>
-            <a:fillRect/>
-          </a:stretch>
-        </a:blipFill>
-        <a:effectLst/>
-      </p:bgPr>
-    </p:bg>
-    <p:spTree>
-      <p:nvGrpSpPr>
-        <p:cNvPr id="1" name="Shape 144"/>
-        <p:cNvGrpSpPr/>
-        <p:nvPr/>
-      </p:nvGrpSpPr>
-      <p:grpSpPr>
-        <a:xfrm>
-          <a:off x="0" y="0"/>
-          <a:ext cx="0" cy="0"/>
-          <a:chOff x="0" y="0"/>
-          <a:chExt cx="0" cy="0"/>
-        </a:xfrm>
-      </p:grpSpPr>
-      <p:sp>
-        <p:nvSpPr>
-          <p:cNvPr id="145" name="Google Shape;145;p13"/>
-          <p:cNvSpPr txBox="1"/>
-          <p:nvPr/>
-        </p:nvSpPr>
-        <p:spPr>
-          <a:xfrm>
-            <a:off x="653143" y="325249"/>
-            <a:ext cx="9940835" cy="527875"/>
-          </a:xfrm>
-          <a:prstGeom prst="rect">
-            <a:avLst/>
-          </a:prstGeom>
-          <a:noFill/>
-          <a:ln>
-            <a:noFill/>
-          </a:ln>
-        </p:spPr>
-        <p:txBody>
-          <a:bodyPr spcFirstLastPara="1" wrap="square" lIns="91425" tIns="45700" rIns="91425" bIns="45700" anchor="t" anchorCtr="0">
-            <a:noAutofit/>
-          </a:bodyPr>
-          <a:lstStyle/>
-          <a:p>
-            <a:pPr>
-              <a:buClr>
-                <a:srgbClr val="FFFFFF"/>
-              </a:buClr>
-              <a:buSzPts val="6000"/>
-              <a:defRPr/>
-            </a:pPr>
-            <a:r>
-              <a:rPr lang="es-CO" sz="4000" b="1" dirty="0">
-                <a:solidFill>
-                  <a:srgbClr val="FFFFFF"/>
-                </a:solidFill>
-                <a:latin typeface="Work Sans"/>
-                <a:ea typeface="Work Sans"/>
-                <a:cs typeface="Work Sans"/>
-                <a:sym typeface="Work Sans"/>
-              </a:rPr>
-              <a:t>Diagrama de Clases</a:t>
-            </a:r>
-            <a:endParaRPr sz="4000" b="1" dirty="0">
-              <a:solidFill>
-                <a:srgbClr val="FFFFFF"/>
-              </a:solidFill>
-              <a:latin typeface="Work Sans"/>
-              <a:ea typeface="Work Sans"/>
-              <a:cs typeface="Work Sans"/>
-              <a:sym typeface="Work Sans"/>
-            </a:endParaRPr>
-          </a:p>
-        </p:txBody>
-      </p:sp>
-      <p:pic>
-        <p:nvPicPr>
-          <p:cNvPr id="3" name="Imagen 2">
-            <a:extLst>
-              <a:ext uri="{FF2B5EF4-FFF2-40B4-BE49-F238E27FC236}">
-                <a16:creationId xmlns:a16="http://schemas.microsoft.com/office/drawing/2014/main" id="{F0641B44-96A0-0BB1-9339-AC1067BEDDD7}"/>
-              </a:ext>
-            </a:extLst>
-          </p:cNvPr>
-          <p:cNvPicPr>
-            <a:picLocks noChangeAspect="1"/>
-          </p:cNvPicPr>
-          <p:nvPr/>
-        </p:nvPicPr>
-        <p:blipFill>
-          <a:blip r:embed="rId4"/>
-          <a:stretch>
-            <a:fillRect/>
-          </a:stretch>
-        </p:blipFill>
-        <p:spPr>
-          <a:xfrm>
-            <a:off x="653143" y="1428750"/>
-            <a:ext cx="5000907" cy="5228692"/>
-          </a:xfrm>
-          <a:prstGeom prst="rect">
-            <a:avLst/>
-          </a:prstGeom>
-        </p:spPr>
-      </p:pic>
-      <p:sp>
-        <p:nvSpPr>
-          <p:cNvPr id="4" name="Google Shape;108;p3">
-            <a:extLst>
-              <a:ext uri="{FF2B5EF4-FFF2-40B4-BE49-F238E27FC236}">
-                <a16:creationId xmlns:a16="http://schemas.microsoft.com/office/drawing/2014/main" id="{FAC6E1CA-1577-309C-E305-2D2695BF00C2}"/>
-              </a:ext>
-            </a:extLst>
-          </p:cNvPr>
-          <p:cNvSpPr txBox="1"/>
-          <p:nvPr/>
-        </p:nvSpPr>
-        <p:spPr>
-          <a:xfrm>
-            <a:off x="6378452" y="3316469"/>
-            <a:ext cx="5000907" cy="646290"/>
-          </a:xfrm>
-          <a:prstGeom prst="rect">
-            <a:avLst/>
-          </a:prstGeom>
-          <a:noFill/>
-          <a:ln>
-            <a:noFill/>
-          </a:ln>
-        </p:spPr>
-        <p:txBody>
-          <a:bodyPr spcFirstLastPara="1" wrap="square" lIns="91425" tIns="45700" rIns="91425" bIns="45700" anchor="t" anchorCtr="0">
-            <a:spAutoFit/>
-          </a:bodyPr>
-          <a:lstStyle/>
-          <a:p>
-            <a:pPr algn="ctr"/>
-            <a:r>
-              <a:rPr lang="es-CO" sz="3600" dirty="0">
-                <a:solidFill>
-                  <a:schemeClr val="accent6"/>
-                </a:solidFill>
-                <a:latin typeface="Calibri"/>
-                <a:cs typeface="Calibri"/>
-                <a:sym typeface="Calibri"/>
-                <a:hlinkClick r:id="rId5"/>
-              </a:rPr>
-              <a:t>Diagrama de Clases UML</a:t>
-            </a:r>
-            <a:endParaRPr dirty="0">
-              <a:solidFill>
-                <a:schemeClr val="accent6"/>
-              </a:solidFill>
-            </a:endParaRPr>
-          </a:p>
-        </p:txBody>
-      </p:sp>
-    </p:spTree>
-    <p:extLst>
-      <p:ext uri="{BB962C8B-B14F-4D97-AF65-F5344CB8AC3E}">
-        <p14:creationId xmlns:p14="http://schemas.microsoft.com/office/powerpoint/2010/main" val="1671775462"/>
-      </p:ext>
-    </p:extLst>
-  </p:cSld>
-  <p:clrMapOvr>
-    <a:masterClrMapping/>
-  </p:clrMapOvr>
-</p:sld>
-</file>
-
-<file path=ppt/slides/slide12.xml><?xml version="1.0" encoding="utf-8"?>
-<p:sld xmlns:a="http://schemas.openxmlformats.org/drawingml/2006/main" xmlns:r="http://schemas.openxmlformats.org/officeDocument/2006/relationships" xmlns:p="http://schemas.openxmlformats.org/presentationml/2006/main">
-  <p:cSld>
-    <p:bg>
-      <p:bgPr>
-        <a:blipFill>
-          <a:blip r:embed="rId3">
-            <a:alphaModFix/>
-          </a:blip>
-          <a:stretch>
-            <a:fillRect/>
-          </a:stretch>
-        </a:blipFill>
-        <a:effectLst/>
-      </p:bgPr>
-    </p:bg>
-    <p:spTree>
-      <p:nvGrpSpPr>
-        <p:cNvPr id="1" name="Shape 113"/>
-        <p:cNvGrpSpPr/>
-        <p:nvPr/>
-      </p:nvGrpSpPr>
-      <p:grpSpPr>
-        <a:xfrm>
-          <a:off x="0" y="0"/>
-          <a:ext cx="0" cy="0"/>
-          <a:chOff x="0" y="0"/>
-          <a:chExt cx="0" cy="0"/>
-        </a:xfrm>
-      </p:grpSpPr>
-      <p:sp>
-        <p:nvSpPr>
-          <p:cNvPr id="114" name="Google Shape;114;p4"/>
-          <p:cNvSpPr txBox="1"/>
-          <p:nvPr/>
-        </p:nvSpPr>
-        <p:spPr>
-          <a:xfrm>
-            <a:off x="1249020" y="2498278"/>
-            <a:ext cx="9776765" cy="1015622"/>
-          </a:xfrm>
-          <a:prstGeom prst="rect">
-            <a:avLst/>
-          </a:prstGeom>
-          <a:noFill/>
-          <a:ln>
-            <a:noFill/>
-          </a:ln>
-        </p:spPr>
-        <p:txBody>
-          <a:bodyPr spcFirstLastPara="1" wrap="square" lIns="91425" tIns="45700" rIns="91425" bIns="45700" anchor="t" anchorCtr="0">
-            <a:spAutoFit/>
-          </a:bodyPr>
-          <a:lstStyle/>
-          <a:p>
-            <a:pPr algn="ctr"/>
-            <a:r>
-              <a:rPr lang="es-CO" sz="6000" b="1" dirty="0">
-                <a:solidFill>
-                  <a:schemeClr val="lt1"/>
-                </a:solidFill>
-                <a:latin typeface="Work Sans"/>
-                <a:ea typeface="Work Sans"/>
-                <a:cs typeface="Work Sans"/>
-                <a:sym typeface="Work Sans"/>
-              </a:rPr>
-              <a:t>Diccionario de Datos</a:t>
-            </a:r>
-            <a:endParaRPr sz="7200" b="1" dirty="0">
-              <a:solidFill>
-                <a:schemeClr val="lt1"/>
-              </a:solidFill>
-              <a:latin typeface="Work Sans"/>
-              <a:ea typeface="Work Sans"/>
-              <a:cs typeface="Work Sans"/>
-              <a:sym typeface="Work Sans"/>
-            </a:endParaRPr>
-          </a:p>
-        </p:txBody>
-      </p:sp>
-      <p:cxnSp>
-        <p:nvCxnSpPr>
-          <p:cNvPr id="115" name="Google Shape;115;p4"/>
-          <p:cNvCxnSpPr/>
-          <p:nvPr/>
-        </p:nvCxnSpPr>
-        <p:spPr>
-          <a:xfrm>
-            <a:off x="5013631" y="3555133"/>
-            <a:ext cx="2247544" cy="0"/>
-          </a:xfrm>
-          <a:prstGeom prst="straightConnector1">
-            <a:avLst/>
-          </a:prstGeom>
-          <a:noFill/>
-          <a:ln w="12700" cap="flat" cmpd="sng">
-            <a:solidFill>
-              <a:schemeClr val="lt1"/>
-            </a:solidFill>
-            <a:prstDash val="solid"/>
-            <a:miter lim="800000"/>
-            <a:headEnd type="none" w="sm" len="sm"/>
-            <a:tailEnd type="none" w="sm" len="sm"/>
-          </a:ln>
-        </p:spPr>
-      </p:cxnSp>
-    </p:spTree>
-    <p:extLst>
-      <p:ext uri="{BB962C8B-B14F-4D97-AF65-F5344CB8AC3E}">
-        <p14:creationId xmlns:p14="http://schemas.microsoft.com/office/powerpoint/2010/main" val="2641333986"/>
-      </p:ext>
-    </p:extLst>
-  </p:cSld>
-  <p:clrMapOvr>
-    <a:masterClrMapping/>
-  </p:clrMapOvr>
-</p:sld>
-</file>
-
-<file path=ppt/slides/slide13.xml><?xml version="1.0" encoding="utf-8"?>
-<p:sld xmlns:a="http://schemas.openxmlformats.org/drawingml/2006/main" xmlns:r="http://schemas.openxmlformats.org/officeDocument/2006/relationships" xmlns:p="http://schemas.openxmlformats.org/presentationml/2006/main">
-  <p:cSld>
-    <p:bg>
-      <p:bgPr>
-        <a:blipFill>
-          <a:blip r:embed="rId3">
-            <a:alphaModFix/>
-          </a:blip>
-          <a:stretch>
-            <a:fillRect/>
-          </a:stretch>
-        </a:blipFill>
-        <a:effectLst/>
-      </p:bgPr>
-    </p:bg>
-    <p:spTree>
-      <p:nvGrpSpPr>
         <p:cNvPr id="1" name="Shape 144"/>
         <p:cNvGrpSpPr/>
         <p:nvPr/>
@@ -14553,7 +14354,542 @@
 </p:sld>
 </file>
 
+<file path=ppt/slides/slide11.xml><?xml version="1.0" encoding="utf-8"?>
+<p:sld xmlns:a="http://schemas.openxmlformats.org/drawingml/2006/main" xmlns:r="http://schemas.openxmlformats.org/officeDocument/2006/relationships" xmlns:p="http://schemas.openxmlformats.org/presentationml/2006/main">
+  <p:cSld>
+    <p:bg>
+      <p:bgPr>
+        <a:blipFill>
+          <a:blip r:embed="rId3">
+            <a:alphaModFix/>
+          </a:blip>
+          <a:stretch>
+            <a:fillRect/>
+          </a:stretch>
+        </a:blipFill>
+        <a:effectLst/>
+      </p:bgPr>
+    </p:bg>
+    <p:spTree>
+      <p:nvGrpSpPr>
+        <p:cNvPr id="1" name="Shape 113"/>
+        <p:cNvGrpSpPr/>
+        <p:nvPr/>
+      </p:nvGrpSpPr>
+      <p:grpSpPr>
+        <a:xfrm>
+          <a:off x="0" y="0"/>
+          <a:ext cx="0" cy="0"/>
+          <a:chOff x="0" y="0"/>
+          <a:chExt cx="0" cy="0"/>
+        </a:xfrm>
+      </p:grpSpPr>
+      <p:sp>
+        <p:nvSpPr>
+          <p:cNvPr id="114" name="Google Shape;114;p4"/>
+          <p:cNvSpPr txBox="1"/>
+          <p:nvPr/>
+        </p:nvSpPr>
+        <p:spPr>
+          <a:xfrm>
+            <a:off x="399535" y="2287246"/>
+            <a:ext cx="11392931" cy="1015622"/>
+          </a:xfrm>
+          <a:prstGeom prst="rect">
+            <a:avLst/>
+          </a:prstGeom>
+          <a:noFill/>
+          <a:ln>
+            <a:noFill/>
+          </a:ln>
+        </p:spPr>
+        <p:txBody>
+          <a:bodyPr spcFirstLastPara="1" wrap="square" lIns="91425" tIns="45700" rIns="91425" bIns="45700" anchor="t" anchorCtr="0">
+            <a:spAutoFit/>
+          </a:bodyPr>
+          <a:lstStyle/>
+          <a:p>
+            <a:pPr algn="ctr"/>
+            <a:r>
+              <a:rPr lang="es-CO" sz="6000" b="1" dirty="0">
+                <a:solidFill>
+                  <a:schemeClr val="lt1"/>
+                </a:solidFill>
+                <a:latin typeface="Work Sans"/>
+                <a:ea typeface="Work Sans"/>
+                <a:cs typeface="Work Sans"/>
+                <a:sym typeface="Work Sans"/>
+              </a:rPr>
+              <a:t>Diseño y Arquitectura del SW</a:t>
+            </a:r>
+            <a:endParaRPr sz="7200" b="1" dirty="0">
+              <a:solidFill>
+                <a:schemeClr val="lt1"/>
+              </a:solidFill>
+              <a:latin typeface="Work Sans"/>
+              <a:ea typeface="Work Sans"/>
+              <a:cs typeface="Work Sans"/>
+              <a:sym typeface="Work Sans"/>
+            </a:endParaRPr>
+          </a:p>
+        </p:txBody>
+      </p:sp>
+      <p:cxnSp>
+        <p:nvCxnSpPr>
+          <p:cNvPr id="115" name="Google Shape;115;p4"/>
+          <p:cNvCxnSpPr/>
+          <p:nvPr/>
+        </p:nvCxnSpPr>
+        <p:spPr>
+          <a:xfrm>
+            <a:off x="5013631" y="3555133"/>
+            <a:ext cx="2247544" cy="0"/>
+          </a:xfrm>
+          <a:prstGeom prst="straightConnector1">
+            <a:avLst/>
+          </a:prstGeom>
+          <a:noFill/>
+          <a:ln w="12700" cap="flat" cmpd="sng">
+            <a:solidFill>
+              <a:schemeClr val="lt1"/>
+            </a:solidFill>
+            <a:prstDash val="solid"/>
+            <a:miter lim="800000"/>
+            <a:headEnd type="none" w="sm" len="sm"/>
+            <a:tailEnd type="none" w="sm" len="sm"/>
+          </a:ln>
+        </p:spPr>
+      </p:cxnSp>
+    </p:spTree>
+    <p:extLst>
+      <p:ext uri="{BB962C8B-B14F-4D97-AF65-F5344CB8AC3E}">
+        <p14:creationId xmlns:p14="http://schemas.microsoft.com/office/powerpoint/2010/main" val="2351102792"/>
+      </p:ext>
+    </p:extLst>
+  </p:cSld>
+  <p:clrMapOvr>
+    <a:masterClrMapping/>
+  </p:clrMapOvr>
+</p:sld>
+</file>
+
+<file path=ppt/slides/slide12.xml><?xml version="1.0" encoding="utf-8"?>
+<p:sld xmlns:a="http://schemas.openxmlformats.org/drawingml/2006/main" xmlns:r="http://schemas.openxmlformats.org/officeDocument/2006/relationships" xmlns:p="http://schemas.openxmlformats.org/presentationml/2006/main">
+  <p:cSld>
+    <p:bg>
+      <p:bgPr>
+        <a:blipFill>
+          <a:blip r:embed="rId3">
+            <a:alphaModFix/>
+          </a:blip>
+          <a:stretch>
+            <a:fillRect/>
+          </a:stretch>
+        </a:blipFill>
+        <a:effectLst/>
+      </p:bgPr>
+    </p:bg>
+    <p:spTree>
+      <p:nvGrpSpPr>
+        <p:cNvPr id="1" name="Shape 144"/>
+        <p:cNvGrpSpPr/>
+        <p:nvPr/>
+      </p:nvGrpSpPr>
+      <p:grpSpPr>
+        <a:xfrm>
+          <a:off x="0" y="0"/>
+          <a:ext cx="0" cy="0"/>
+          <a:chOff x="0" y="0"/>
+          <a:chExt cx="0" cy="0"/>
+        </a:xfrm>
+      </p:grpSpPr>
+      <p:sp>
+        <p:nvSpPr>
+          <p:cNvPr id="145" name="Google Shape;145;p13"/>
+          <p:cNvSpPr txBox="1"/>
+          <p:nvPr/>
+        </p:nvSpPr>
+        <p:spPr>
+          <a:xfrm>
+            <a:off x="653143" y="325249"/>
+            <a:ext cx="9940835" cy="527875"/>
+          </a:xfrm>
+          <a:prstGeom prst="rect">
+            <a:avLst/>
+          </a:prstGeom>
+          <a:noFill/>
+          <a:ln>
+            <a:noFill/>
+          </a:ln>
+        </p:spPr>
+        <p:txBody>
+          <a:bodyPr spcFirstLastPara="1" wrap="square" lIns="91425" tIns="45700" rIns="91425" bIns="45700" anchor="t" anchorCtr="0">
+            <a:noAutofit/>
+          </a:bodyPr>
+          <a:lstStyle/>
+          <a:p>
+            <a:pPr>
+              <a:buClr>
+                <a:srgbClr val="FFFFFF"/>
+              </a:buClr>
+              <a:buSzPts val="6000"/>
+              <a:defRPr/>
+            </a:pPr>
+            <a:r>
+              <a:rPr lang="es-CO" sz="4000" b="1" dirty="0">
+                <a:solidFill>
+                  <a:srgbClr val="FFFFFF"/>
+                </a:solidFill>
+                <a:latin typeface="Work Sans"/>
+                <a:ea typeface="Work Sans"/>
+                <a:cs typeface="Work Sans"/>
+                <a:sym typeface="Work Sans"/>
+              </a:rPr>
+              <a:t>Diagrama de Clases</a:t>
+            </a:r>
+            <a:endParaRPr sz="4000" b="1" dirty="0">
+              <a:solidFill>
+                <a:srgbClr val="FFFFFF"/>
+              </a:solidFill>
+              <a:latin typeface="Work Sans"/>
+              <a:ea typeface="Work Sans"/>
+              <a:cs typeface="Work Sans"/>
+              <a:sym typeface="Work Sans"/>
+            </a:endParaRPr>
+          </a:p>
+        </p:txBody>
+      </p:sp>
+    </p:spTree>
+    <p:extLst>
+      <p:ext uri="{BB962C8B-B14F-4D97-AF65-F5344CB8AC3E}">
+        <p14:creationId xmlns:p14="http://schemas.microsoft.com/office/powerpoint/2010/main" val="48471826"/>
+      </p:ext>
+    </p:extLst>
+  </p:cSld>
+  <p:clrMapOvr>
+    <a:masterClrMapping/>
+  </p:clrMapOvr>
+</p:sld>
+</file>
+
+<file path=ppt/slides/slide13.xml><?xml version="1.0" encoding="utf-8"?>
+<p:sld xmlns:a="http://schemas.openxmlformats.org/drawingml/2006/main" xmlns:r="http://schemas.openxmlformats.org/officeDocument/2006/relationships" xmlns:p="http://schemas.openxmlformats.org/presentationml/2006/main">
+  <p:cSld>
+    <p:bg>
+      <p:bgPr>
+        <a:blipFill>
+          <a:blip r:embed="rId3">
+            <a:alphaModFix/>
+          </a:blip>
+          <a:stretch>
+            <a:fillRect/>
+          </a:stretch>
+        </a:blipFill>
+        <a:effectLst/>
+      </p:bgPr>
+    </p:bg>
+    <p:spTree>
+      <p:nvGrpSpPr>
+        <p:cNvPr id="1" name="Shape 144"/>
+        <p:cNvGrpSpPr/>
+        <p:nvPr/>
+      </p:nvGrpSpPr>
+      <p:grpSpPr>
+        <a:xfrm>
+          <a:off x="0" y="0"/>
+          <a:ext cx="0" cy="0"/>
+          <a:chOff x="0" y="0"/>
+          <a:chExt cx="0" cy="0"/>
+        </a:xfrm>
+      </p:grpSpPr>
+      <p:sp>
+        <p:nvSpPr>
+          <p:cNvPr id="145" name="Google Shape;145;p13"/>
+          <p:cNvSpPr txBox="1"/>
+          <p:nvPr/>
+        </p:nvSpPr>
+        <p:spPr>
+          <a:xfrm>
+            <a:off x="653143" y="325249"/>
+            <a:ext cx="9940835" cy="527875"/>
+          </a:xfrm>
+          <a:prstGeom prst="rect">
+            <a:avLst/>
+          </a:prstGeom>
+          <a:noFill/>
+          <a:ln>
+            <a:noFill/>
+          </a:ln>
+        </p:spPr>
+        <p:txBody>
+          <a:bodyPr spcFirstLastPara="1" wrap="square" lIns="91425" tIns="45700" rIns="91425" bIns="45700" anchor="t" anchorCtr="0">
+            <a:noAutofit/>
+          </a:bodyPr>
+          <a:lstStyle/>
+          <a:p>
+            <a:pPr>
+              <a:buClr>
+                <a:srgbClr val="FFFFFF"/>
+              </a:buClr>
+              <a:buSzPts val="6000"/>
+              <a:defRPr/>
+            </a:pPr>
+            <a:r>
+              <a:rPr lang="es-CO" sz="4000" b="1" dirty="0">
+                <a:solidFill>
+                  <a:srgbClr val="FFFFFF"/>
+                </a:solidFill>
+                <a:latin typeface="Work Sans"/>
+                <a:ea typeface="Work Sans"/>
+                <a:cs typeface="Work Sans"/>
+                <a:sym typeface="Work Sans"/>
+              </a:rPr>
+              <a:t>Diagrama Despliegue</a:t>
+            </a:r>
+            <a:endParaRPr sz="4000" b="1" dirty="0">
+              <a:solidFill>
+                <a:srgbClr val="FFFFFF"/>
+              </a:solidFill>
+              <a:latin typeface="Work Sans"/>
+              <a:ea typeface="Work Sans"/>
+              <a:cs typeface="Work Sans"/>
+              <a:sym typeface="Work Sans"/>
+            </a:endParaRPr>
+          </a:p>
+        </p:txBody>
+      </p:sp>
+    </p:spTree>
+    <p:extLst>
+      <p:ext uri="{BB962C8B-B14F-4D97-AF65-F5344CB8AC3E}">
+        <p14:creationId xmlns:p14="http://schemas.microsoft.com/office/powerpoint/2010/main" val="1821440979"/>
+      </p:ext>
+    </p:extLst>
+  </p:cSld>
+  <p:clrMapOvr>
+    <a:masterClrMapping/>
+  </p:clrMapOvr>
+</p:sld>
+</file>
+
 <file path=ppt/slides/slide14.xml><?xml version="1.0" encoding="utf-8"?>
+<p:sld xmlns:a="http://schemas.openxmlformats.org/drawingml/2006/main" xmlns:r="http://schemas.openxmlformats.org/officeDocument/2006/relationships" xmlns:p="http://schemas.openxmlformats.org/presentationml/2006/main">
+  <p:cSld>
+    <p:bg>
+      <p:bgPr>
+        <a:blipFill>
+          <a:blip r:embed="rId3">
+            <a:alphaModFix/>
+          </a:blip>
+          <a:stretch>
+            <a:fillRect/>
+          </a:stretch>
+        </a:blipFill>
+        <a:effectLst/>
+      </p:bgPr>
+    </p:bg>
+    <p:spTree>
+      <p:nvGrpSpPr>
+        <p:cNvPr id="1" name="Shape 113"/>
+        <p:cNvGrpSpPr/>
+        <p:nvPr/>
+      </p:nvGrpSpPr>
+      <p:grpSpPr>
+        <a:xfrm>
+          <a:off x="0" y="0"/>
+          <a:ext cx="0" cy="0"/>
+          <a:chOff x="0" y="0"/>
+          <a:chExt cx="0" cy="0"/>
+        </a:xfrm>
+      </p:grpSpPr>
+      <p:sp>
+        <p:nvSpPr>
+          <p:cNvPr id="114" name="Google Shape;114;p4"/>
+          <p:cNvSpPr txBox="1"/>
+          <p:nvPr/>
+        </p:nvSpPr>
+        <p:spPr>
+          <a:xfrm>
+            <a:off x="399535" y="2287246"/>
+            <a:ext cx="11392931" cy="1015622"/>
+          </a:xfrm>
+          <a:prstGeom prst="rect">
+            <a:avLst/>
+          </a:prstGeom>
+          <a:noFill/>
+          <a:ln>
+            <a:noFill/>
+          </a:ln>
+        </p:spPr>
+        <p:txBody>
+          <a:bodyPr spcFirstLastPara="1" wrap="square" lIns="91425" tIns="45700" rIns="91425" bIns="45700" anchor="t" anchorCtr="0">
+            <a:spAutoFit/>
+          </a:bodyPr>
+          <a:lstStyle/>
+          <a:p>
+            <a:pPr algn="ctr"/>
+            <a:r>
+              <a:rPr lang="es-CO" sz="6000" b="1" dirty="0">
+                <a:solidFill>
+                  <a:schemeClr val="lt1"/>
+                </a:solidFill>
+                <a:latin typeface="Work Sans"/>
+                <a:ea typeface="Work Sans"/>
+                <a:cs typeface="Work Sans"/>
+                <a:sym typeface="Work Sans"/>
+              </a:rPr>
+              <a:t>Diseño de Interfaces</a:t>
+            </a:r>
+            <a:endParaRPr sz="7200" b="1" dirty="0">
+              <a:solidFill>
+                <a:schemeClr val="lt1"/>
+              </a:solidFill>
+              <a:latin typeface="Work Sans"/>
+              <a:ea typeface="Work Sans"/>
+              <a:cs typeface="Work Sans"/>
+              <a:sym typeface="Work Sans"/>
+            </a:endParaRPr>
+          </a:p>
+        </p:txBody>
+      </p:sp>
+      <p:cxnSp>
+        <p:nvCxnSpPr>
+          <p:cNvPr id="115" name="Google Shape;115;p4"/>
+          <p:cNvCxnSpPr/>
+          <p:nvPr/>
+        </p:nvCxnSpPr>
+        <p:spPr>
+          <a:xfrm>
+            <a:off x="5013631" y="3555133"/>
+            <a:ext cx="2247544" cy="0"/>
+          </a:xfrm>
+          <a:prstGeom prst="straightConnector1">
+            <a:avLst/>
+          </a:prstGeom>
+          <a:noFill/>
+          <a:ln w="12700" cap="flat" cmpd="sng">
+            <a:solidFill>
+              <a:schemeClr val="lt1"/>
+            </a:solidFill>
+            <a:prstDash val="solid"/>
+            <a:miter lim="800000"/>
+            <a:headEnd type="none" w="sm" len="sm"/>
+            <a:tailEnd type="none" w="sm" len="sm"/>
+          </a:ln>
+        </p:spPr>
+      </p:cxnSp>
+    </p:spTree>
+    <p:extLst>
+      <p:ext uri="{BB962C8B-B14F-4D97-AF65-F5344CB8AC3E}">
+        <p14:creationId xmlns:p14="http://schemas.microsoft.com/office/powerpoint/2010/main" val="1413100068"/>
+      </p:ext>
+    </p:extLst>
+  </p:cSld>
+  <p:clrMapOvr>
+    <a:masterClrMapping/>
+  </p:clrMapOvr>
+</p:sld>
+</file>
+
+<file path=ppt/slides/slide15.xml><?xml version="1.0" encoding="utf-8"?>
+<p:sld xmlns:a="http://schemas.openxmlformats.org/drawingml/2006/main" xmlns:r="http://schemas.openxmlformats.org/officeDocument/2006/relationships" xmlns:p="http://schemas.openxmlformats.org/presentationml/2006/main">
+  <p:cSld>
+    <p:bg>
+      <p:bgPr>
+        <a:blipFill>
+          <a:blip r:embed="rId3">
+            <a:alphaModFix/>
+          </a:blip>
+          <a:stretch>
+            <a:fillRect/>
+          </a:stretch>
+        </a:blipFill>
+        <a:effectLst/>
+      </p:bgPr>
+    </p:bg>
+    <p:spTree>
+      <p:nvGrpSpPr>
+        <p:cNvPr id="1" name="Shape 144"/>
+        <p:cNvGrpSpPr/>
+        <p:nvPr/>
+      </p:nvGrpSpPr>
+      <p:grpSpPr>
+        <a:xfrm>
+          <a:off x="0" y="0"/>
+          <a:ext cx="0" cy="0"/>
+          <a:chOff x="0" y="0"/>
+          <a:chExt cx="0" cy="0"/>
+        </a:xfrm>
+      </p:grpSpPr>
+      <p:sp>
+        <p:nvSpPr>
+          <p:cNvPr id="145" name="Google Shape;145;p13"/>
+          <p:cNvSpPr txBox="1"/>
+          <p:nvPr/>
+        </p:nvSpPr>
+        <p:spPr>
+          <a:xfrm>
+            <a:off x="653143" y="325249"/>
+            <a:ext cx="9940835" cy="527875"/>
+          </a:xfrm>
+          <a:prstGeom prst="rect">
+            <a:avLst/>
+          </a:prstGeom>
+          <a:noFill/>
+          <a:ln>
+            <a:noFill/>
+          </a:ln>
+        </p:spPr>
+        <p:txBody>
+          <a:bodyPr spcFirstLastPara="1" wrap="square" lIns="91425" tIns="45700" rIns="91425" bIns="45700" anchor="t" anchorCtr="0">
+            <a:noAutofit/>
+          </a:bodyPr>
+          <a:lstStyle/>
+          <a:p>
+            <a:pPr>
+              <a:buClr>
+                <a:srgbClr val="FFFFFF"/>
+              </a:buClr>
+              <a:buSzPts val="6000"/>
+              <a:defRPr/>
+            </a:pPr>
+            <a:r>
+              <a:rPr lang="es-CO" sz="4000" b="1" dirty="0">
+                <a:solidFill>
+                  <a:srgbClr val="FFFFFF"/>
+                </a:solidFill>
+                <a:latin typeface="Work Sans"/>
+                <a:ea typeface="Work Sans"/>
+                <a:cs typeface="Work Sans"/>
+                <a:sym typeface="Work Sans"/>
+              </a:rPr>
+              <a:t>Maquetación</a:t>
+            </a:r>
+            <a:endParaRPr sz="4000" b="1" dirty="0">
+              <a:solidFill>
+                <a:srgbClr val="FFFFFF"/>
+              </a:solidFill>
+              <a:latin typeface="Work Sans"/>
+              <a:ea typeface="Work Sans"/>
+              <a:cs typeface="Work Sans"/>
+              <a:sym typeface="Work Sans"/>
+            </a:endParaRPr>
+          </a:p>
+        </p:txBody>
+      </p:sp>
+    </p:spTree>
+    <p:extLst>
+      <p:ext uri="{BB962C8B-B14F-4D97-AF65-F5344CB8AC3E}">
+        <p14:creationId xmlns:p14="http://schemas.microsoft.com/office/powerpoint/2010/main" val="2267534673"/>
+      </p:ext>
+    </p:extLst>
+  </p:cSld>
+  <p:clrMapOvr>
+    <a:masterClrMapping/>
+  </p:clrMapOvr>
+</p:sld>
+</file>
+
+<file path=ppt/slides/slide16.xml><?xml version="1.0" encoding="utf-8"?>
 <p:sld xmlns:a="http://schemas.openxmlformats.org/drawingml/2006/main" xmlns:r="http://schemas.openxmlformats.org/officeDocument/2006/relationships" xmlns:p="http://schemas.openxmlformats.org/presentationml/2006/main">
   <p:cSld>
     <p:bg>
@@ -15190,7 +15526,7 @@
                 <a:cs typeface="Work Sans"/>
                 <a:sym typeface="Work Sans"/>
               </a:rPr>
-              <a:t>Normalización del M.E. (3FN)</a:t>
+              <a:t>Diseño de Base de Datos</a:t>
             </a:r>
             <a:endParaRPr sz="7200" b="1" dirty="0">
               <a:solidFill>
@@ -15315,300 +15651,6 @@
                 <a:cs typeface="Work Sans"/>
                 <a:sym typeface="Work Sans"/>
               </a:rPr>
-              <a:t>Normalización</a:t>
-            </a:r>
-            <a:endParaRPr sz="4000" b="1" dirty="0">
-              <a:solidFill>
-                <a:srgbClr val="FFFFFF"/>
-              </a:solidFill>
-              <a:latin typeface="Work Sans"/>
-              <a:ea typeface="Work Sans"/>
-              <a:cs typeface="Work Sans"/>
-              <a:sym typeface="Work Sans"/>
-            </a:endParaRPr>
-          </a:p>
-        </p:txBody>
-      </p:sp>
-      <p:pic>
-        <p:nvPicPr>
-          <p:cNvPr id="3" name="Imagen 2">
-            <a:extLst>
-              <a:ext uri="{FF2B5EF4-FFF2-40B4-BE49-F238E27FC236}">
-                <a16:creationId xmlns:a16="http://schemas.microsoft.com/office/drawing/2014/main" id="{D103AC4F-9E40-58A8-3918-C506D08367F4}"/>
-              </a:ext>
-            </a:extLst>
-          </p:cNvPr>
-          <p:cNvPicPr>
-            <a:picLocks noChangeAspect="1"/>
-          </p:cNvPicPr>
-          <p:nvPr/>
-        </p:nvPicPr>
-        <p:blipFill>
-          <a:blip r:embed="rId4"/>
-          <a:stretch>
-            <a:fillRect/>
-          </a:stretch>
-        </p:blipFill>
-        <p:spPr>
-          <a:xfrm>
-            <a:off x="1190027" y="1345034"/>
-            <a:ext cx="9205599" cy="4167935"/>
-          </a:xfrm>
-          <a:prstGeom prst="rect">
-            <a:avLst/>
-          </a:prstGeom>
-        </p:spPr>
-      </p:pic>
-      <p:sp>
-        <p:nvSpPr>
-          <p:cNvPr id="4" name="Google Shape;108;p3">
-            <a:extLst>
-              <a:ext uri="{FF2B5EF4-FFF2-40B4-BE49-F238E27FC236}">
-                <a16:creationId xmlns:a16="http://schemas.microsoft.com/office/drawing/2014/main" id="{CA32D6B8-E990-05EE-B505-D4C2127C1A8A}"/>
-              </a:ext>
-            </a:extLst>
-          </p:cNvPr>
-          <p:cNvSpPr txBox="1"/>
-          <p:nvPr/>
-        </p:nvSpPr>
-        <p:spPr>
-          <a:xfrm>
-            <a:off x="1106329" y="5886462"/>
-            <a:ext cx="4652787" cy="646290"/>
-          </a:xfrm>
-          <a:prstGeom prst="rect">
-            <a:avLst/>
-          </a:prstGeom>
-          <a:noFill/>
-          <a:ln>
-            <a:noFill/>
-          </a:ln>
-        </p:spPr>
-        <p:txBody>
-          <a:bodyPr spcFirstLastPara="1" wrap="square" lIns="91425" tIns="45700" rIns="91425" bIns="45700" anchor="t" anchorCtr="0">
-            <a:spAutoFit/>
-          </a:bodyPr>
-          <a:lstStyle/>
-          <a:p>
-            <a:r>
-              <a:rPr lang="es-CO" sz="3600" dirty="0">
-                <a:solidFill>
-                  <a:schemeClr val="accent6"/>
-                </a:solidFill>
-                <a:latin typeface="Calibri"/>
-                <a:cs typeface="Calibri"/>
-                <a:sym typeface="Calibri"/>
-                <a:hlinkClick r:id="rId5"/>
-              </a:rPr>
-              <a:t>Normalización del M.E.</a:t>
-            </a:r>
-            <a:endParaRPr dirty="0">
-              <a:solidFill>
-                <a:schemeClr val="accent6"/>
-              </a:solidFill>
-            </a:endParaRPr>
-          </a:p>
-        </p:txBody>
-      </p:sp>
-    </p:spTree>
-  </p:cSld>
-  <p:clrMapOvr>
-    <a:masterClrMapping/>
-  </p:clrMapOvr>
-</p:sld>
-</file>
-
-<file path=ppt/slides/slide8.xml><?xml version="1.0" encoding="utf-8"?>
-<p:sld xmlns:a="http://schemas.openxmlformats.org/drawingml/2006/main" xmlns:r="http://schemas.openxmlformats.org/officeDocument/2006/relationships" xmlns:p="http://schemas.openxmlformats.org/presentationml/2006/main">
-  <p:cSld>
-    <p:bg>
-      <p:bgPr>
-        <a:blipFill>
-          <a:blip r:embed="rId3">
-            <a:alphaModFix/>
-          </a:blip>
-          <a:stretch>
-            <a:fillRect/>
-          </a:stretch>
-        </a:blipFill>
-        <a:effectLst/>
-      </p:bgPr>
-    </p:bg>
-    <p:spTree>
-      <p:nvGrpSpPr>
-        <p:cNvPr id="1" name="Shape 113"/>
-        <p:cNvGrpSpPr/>
-        <p:nvPr/>
-      </p:nvGrpSpPr>
-      <p:grpSpPr>
-        <a:xfrm>
-          <a:off x="0" y="0"/>
-          <a:ext cx="0" cy="0"/>
-          <a:chOff x="0" y="0"/>
-          <a:chExt cx="0" cy="0"/>
-        </a:xfrm>
-      </p:grpSpPr>
-      <p:sp>
-        <p:nvSpPr>
-          <p:cNvPr id="114" name="Google Shape;114;p4"/>
-          <p:cNvSpPr txBox="1"/>
-          <p:nvPr/>
-        </p:nvSpPr>
-        <p:spPr>
-          <a:xfrm>
-            <a:off x="1838585" y="2430118"/>
-            <a:ext cx="8514827" cy="1015622"/>
-          </a:xfrm>
-          <a:prstGeom prst="rect">
-            <a:avLst/>
-          </a:prstGeom>
-          <a:noFill/>
-          <a:ln>
-            <a:noFill/>
-          </a:ln>
-        </p:spPr>
-        <p:txBody>
-          <a:bodyPr spcFirstLastPara="1" wrap="square" lIns="91425" tIns="45700" rIns="91425" bIns="45700" anchor="t" anchorCtr="0">
-            <a:spAutoFit/>
-          </a:bodyPr>
-          <a:lstStyle/>
-          <a:p>
-            <a:pPr algn="ctr"/>
-            <a:r>
-              <a:rPr lang="es-CO" sz="6000" b="1" dirty="0">
-                <a:solidFill>
-                  <a:schemeClr val="lt1"/>
-                </a:solidFill>
-                <a:latin typeface="Work Sans"/>
-                <a:ea typeface="Work Sans"/>
-                <a:cs typeface="Work Sans"/>
-                <a:sym typeface="Work Sans"/>
-              </a:rPr>
-              <a:t>M.E.R. Chen</a:t>
-            </a:r>
-            <a:endParaRPr sz="7200" b="1" dirty="0">
-              <a:solidFill>
-                <a:schemeClr val="lt1"/>
-              </a:solidFill>
-              <a:latin typeface="Work Sans"/>
-              <a:ea typeface="Work Sans"/>
-              <a:cs typeface="Work Sans"/>
-              <a:sym typeface="Work Sans"/>
-            </a:endParaRPr>
-          </a:p>
-        </p:txBody>
-      </p:sp>
-      <p:cxnSp>
-        <p:nvCxnSpPr>
-          <p:cNvPr id="115" name="Google Shape;115;p4"/>
-          <p:cNvCxnSpPr/>
-          <p:nvPr/>
-        </p:nvCxnSpPr>
-        <p:spPr>
-          <a:xfrm>
-            <a:off x="5013631" y="3555133"/>
-            <a:ext cx="2247544" cy="0"/>
-          </a:xfrm>
-          <a:prstGeom prst="straightConnector1">
-            <a:avLst/>
-          </a:prstGeom>
-          <a:noFill/>
-          <a:ln w="12700" cap="flat" cmpd="sng">
-            <a:solidFill>
-              <a:schemeClr val="lt1"/>
-            </a:solidFill>
-            <a:prstDash val="solid"/>
-            <a:miter lim="800000"/>
-            <a:headEnd type="none" w="sm" len="sm"/>
-            <a:tailEnd type="none" w="sm" len="sm"/>
-          </a:ln>
-        </p:spPr>
-      </p:cxnSp>
-    </p:spTree>
-    <p:extLst>
-      <p:ext uri="{BB962C8B-B14F-4D97-AF65-F5344CB8AC3E}">
-        <p14:creationId xmlns:p14="http://schemas.microsoft.com/office/powerpoint/2010/main" val="2896308555"/>
-      </p:ext>
-    </p:extLst>
-  </p:cSld>
-  <p:clrMapOvr>
-    <a:masterClrMapping/>
-  </p:clrMapOvr>
-</p:sld>
-</file>
-
-<file path=ppt/slides/slide9.xml><?xml version="1.0" encoding="utf-8"?>
-<p:sld xmlns:a="http://schemas.openxmlformats.org/drawingml/2006/main" xmlns:r="http://schemas.openxmlformats.org/officeDocument/2006/relationships" xmlns:p="http://schemas.openxmlformats.org/presentationml/2006/main">
-  <p:cSld>
-    <p:bg>
-      <p:bgPr>
-        <a:blipFill>
-          <a:blip r:embed="rId3">
-            <a:alphaModFix/>
-          </a:blip>
-          <a:stretch>
-            <a:fillRect/>
-          </a:stretch>
-        </a:blipFill>
-        <a:effectLst/>
-      </p:bgPr>
-    </p:bg>
-    <p:spTree>
-      <p:nvGrpSpPr>
-        <p:cNvPr id="1" name="Shape 144"/>
-        <p:cNvGrpSpPr/>
-        <p:nvPr/>
-      </p:nvGrpSpPr>
-      <p:grpSpPr>
-        <a:xfrm>
-          <a:off x="0" y="0"/>
-          <a:ext cx="0" cy="0"/>
-          <a:chOff x="0" y="0"/>
-          <a:chExt cx="0" cy="0"/>
-        </a:xfrm>
-      </p:grpSpPr>
-      <p:sp>
-        <p:nvSpPr>
-          <p:cNvPr id="145" name="Google Shape;145;p13"/>
-          <p:cNvSpPr txBox="1"/>
-          <p:nvPr/>
-        </p:nvSpPr>
-        <p:spPr>
-          <a:xfrm>
-            <a:off x="653143" y="325249"/>
-            <a:ext cx="9940835" cy="527875"/>
-          </a:xfrm>
-          <a:prstGeom prst="rect">
-            <a:avLst/>
-          </a:prstGeom>
-          <a:noFill/>
-          <a:ln>
-            <a:noFill/>
-          </a:ln>
-        </p:spPr>
-        <p:txBody>
-          <a:bodyPr spcFirstLastPara="1" wrap="square" lIns="91425" tIns="45700" rIns="91425" bIns="45700" anchor="t" anchorCtr="0">
-            <a:noAutofit/>
-          </a:bodyPr>
-          <a:lstStyle/>
-          <a:p>
-            <a:pPr>
-              <a:buClr>
-                <a:srgbClr val="FFFFFF"/>
-              </a:buClr>
-              <a:buSzPts val="6000"/>
-              <a:defRPr/>
-            </a:pPr>
-            <a:r>
-              <a:rPr lang="es-CO" sz="4000" b="1" dirty="0">
-                <a:solidFill>
-                  <a:srgbClr val="FFFFFF"/>
-                </a:solidFill>
-                <a:latin typeface="Work Sans"/>
-                <a:ea typeface="Work Sans"/>
-                <a:cs typeface="Work Sans"/>
-                <a:sym typeface="Work Sans"/>
-              </a:rPr>
               <a:t>Modelo Entidad Relación</a:t>
             </a:r>
             <a:endParaRPr sz="4000" b="1" dirty="0">
@@ -15710,6 +15752,374 @@
         <p14:creationId xmlns:p14="http://schemas.microsoft.com/office/powerpoint/2010/main" val="3770741573"/>
       </p:ext>
     </p:extLst>
+  </p:cSld>
+  <p:clrMapOvr>
+    <a:masterClrMapping/>
+  </p:clrMapOvr>
+</p:sld>
+</file>
+
+<file path=ppt/slides/slide8.xml><?xml version="1.0" encoding="utf-8"?>
+<p:sld xmlns:a="http://schemas.openxmlformats.org/drawingml/2006/main" xmlns:r="http://schemas.openxmlformats.org/officeDocument/2006/relationships" xmlns:p="http://schemas.openxmlformats.org/presentationml/2006/main">
+  <p:cSld>
+    <p:bg>
+      <p:bgPr>
+        <a:blipFill>
+          <a:blip r:embed="rId3">
+            <a:alphaModFix/>
+          </a:blip>
+          <a:stretch>
+            <a:fillRect/>
+          </a:stretch>
+        </a:blipFill>
+        <a:effectLst/>
+      </p:bgPr>
+    </p:bg>
+    <p:spTree>
+      <p:nvGrpSpPr>
+        <p:cNvPr id="1" name="Shape 144"/>
+        <p:cNvGrpSpPr/>
+        <p:nvPr/>
+      </p:nvGrpSpPr>
+      <p:grpSpPr>
+        <a:xfrm>
+          <a:off x="0" y="0"/>
+          <a:ext cx="0" cy="0"/>
+          <a:chOff x="0" y="0"/>
+          <a:chExt cx="0" cy="0"/>
+        </a:xfrm>
+      </p:grpSpPr>
+      <p:sp>
+        <p:nvSpPr>
+          <p:cNvPr id="145" name="Google Shape;145;p13"/>
+          <p:cNvSpPr txBox="1"/>
+          <p:nvPr/>
+        </p:nvSpPr>
+        <p:spPr>
+          <a:xfrm>
+            <a:off x="653143" y="325249"/>
+            <a:ext cx="9940835" cy="527875"/>
+          </a:xfrm>
+          <a:prstGeom prst="rect">
+            <a:avLst/>
+          </a:prstGeom>
+          <a:noFill/>
+          <a:ln>
+            <a:noFill/>
+          </a:ln>
+        </p:spPr>
+        <p:txBody>
+          <a:bodyPr spcFirstLastPara="1" wrap="square" lIns="91425" tIns="45700" rIns="91425" bIns="45700" anchor="t" anchorCtr="0">
+            <a:noAutofit/>
+          </a:bodyPr>
+          <a:lstStyle/>
+          <a:p>
+            <a:pPr>
+              <a:buClr>
+                <a:srgbClr val="FFFFFF"/>
+              </a:buClr>
+              <a:buSzPts val="6000"/>
+              <a:defRPr/>
+            </a:pPr>
+            <a:r>
+              <a:rPr lang="es-CO" sz="4000" b="1" dirty="0">
+                <a:solidFill>
+                  <a:srgbClr val="FFFFFF"/>
+                </a:solidFill>
+                <a:latin typeface="Work Sans"/>
+                <a:ea typeface="Work Sans"/>
+                <a:cs typeface="Work Sans"/>
+                <a:sym typeface="Work Sans"/>
+              </a:rPr>
+              <a:t>Modelo Relacional</a:t>
+            </a:r>
+            <a:endParaRPr sz="4000" b="1" dirty="0">
+              <a:solidFill>
+                <a:srgbClr val="FFFFFF"/>
+              </a:solidFill>
+              <a:latin typeface="Work Sans"/>
+              <a:ea typeface="Work Sans"/>
+              <a:cs typeface="Work Sans"/>
+              <a:sym typeface="Work Sans"/>
+            </a:endParaRPr>
+          </a:p>
+        </p:txBody>
+      </p:sp>
+      <p:pic>
+        <p:nvPicPr>
+          <p:cNvPr id="3" name="Imagen 2">
+            <a:extLst>
+              <a:ext uri="{FF2B5EF4-FFF2-40B4-BE49-F238E27FC236}">
+                <a16:creationId xmlns:a16="http://schemas.microsoft.com/office/drawing/2014/main" id="{F0641B44-96A0-0BB1-9339-AC1067BEDDD7}"/>
+              </a:ext>
+            </a:extLst>
+          </p:cNvPr>
+          <p:cNvPicPr>
+            <a:picLocks noChangeAspect="1"/>
+          </p:cNvPicPr>
+          <p:nvPr/>
+        </p:nvPicPr>
+        <p:blipFill>
+          <a:blip r:embed="rId4"/>
+          <a:stretch>
+            <a:fillRect/>
+          </a:stretch>
+        </p:blipFill>
+        <p:spPr>
+          <a:xfrm>
+            <a:off x="653143" y="1428750"/>
+            <a:ext cx="5000907" cy="5228692"/>
+          </a:xfrm>
+          <a:prstGeom prst="rect">
+            <a:avLst/>
+          </a:prstGeom>
+        </p:spPr>
+      </p:pic>
+      <p:sp>
+        <p:nvSpPr>
+          <p:cNvPr id="4" name="Google Shape;108;p3">
+            <a:extLst>
+              <a:ext uri="{FF2B5EF4-FFF2-40B4-BE49-F238E27FC236}">
+                <a16:creationId xmlns:a16="http://schemas.microsoft.com/office/drawing/2014/main" id="{FAC6E1CA-1577-309C-E305-2D2695BF00C2}"/>
+              </a:ext>
+            </a:extLst>
+          </p:cNvPr>
+          <p:cNvSpPr txBox="1"/>
+          <p:nvPr/>
+        </p:nvSpPr>
+        <p:spPr>
+          <a:xfrm>
+            <a:off x="6378452" y="3316469"/>
+            <a:ext cx="5000907" cy="646290"/>
+          </a:xfrm>
+          <a:prstGeom prst="rect">
+            <a:avLst/>
+          </a:prstGeom>
+          <a:noFill/>
+          <a:ln>
+            <a:noFill/>
+          </a:ln>
+        </p:spPr>
+        <p:txBody>
+          <a:bodyPr spcFirstLastPara="1" wrap="square" lIns="91425" tIns="45700" rIns="91425" bIns="45700" anchor="t" anchorCtr="0">
+            <a:spAutoFit/>
+          </a:bodyPr>
+          <a:lstStyle/>
+          <a:p>
+            <a:pPr algn="ctr"/>
+            <a:r>
+              <a:rPr lang="es-CO" sz="3600" dirty="0">
+                <a:solidFill>
+                  <a:schemeClr val="accent6"/>
+                </a:solidFill>
+                <a:latin typeface="Calibri"/>
+                <a:cs typeface="Calibri"/>
+                <a:sym typeface="Calibri"/>
+                <a:hlinkClick r:id="rId5"/>
+              </a:rPr>
+              <a:t>M.E. </a:t>
+            </a:r>
+            <a:r>
+              <a:rPr lang="es-CO" sz="3600" dirty="0" err="1">
+                <a:solidFill>
+                  <a:schemeClr val="accent6"/>
+                </a:solidFill>
+                <a:latin typeface="Calibri"/>
+                <a:cs typeface="Calibri"/>
+                <a:sym typeface="Calibri"/>
+                <a:hlinkClick r:id="rId5"/>
+              </a:rPr>
+              <a:t>Workbench</a:t>
+            </a:r>
+            <a:endParaRPr dirty="0">
+              <a:solidFill>
+                <a:schemeClr val="accent6"/>
+              </a:solidFill>
+            </a:endParaRPr>
+          </a:p>
+        </p:txBody>
+      </p:sp>
+    </p:spTree>
+    <p:extLst>
+      <p:ext uri="{BB962C8B-B14F-4D97-AF65-F5344CB8AC3E}">
+        <p14:creationId xmlns:p14="http://schemas.microsoft.com/office/powerpoint/2010/main" val="1671775462"/>
+      </p:ext>
+    </p:extLst>
+  </p:cSld>
+  <p:clrMapOvr>
+    <a:masterClrMapping/>
+  </p:clrMapOvr>
+</p:sld>
+</file>
+
+<file path=ppt/slides/slide9.xml><?xml version="1.0" encoding="utf-8"?>
+<p:sld xmlns:a="http://schemas.openxmlformats.org/drawingml/2006/main" xmlns:r="http://schemas.openxmlformats.org/officeDocument/2006/relationships" xmlns:p="http://schemas.openxmlformats.org/presentationml/2006/main">
+  <p:cSld>
+    <p:bg>
+      <p:bgPr>
+        <a:blipFill>
+          <a:blip r:embed="rId3">
+            <a:alphaModFix/>
+          </a:blip>
+          <a:stretch>
+            <a:fillRect/>
+          </a:stretch>
+        </a:blipFill>
+        <a:effectLst/>
+      </p:bgPr>
+    </p:bg>
+    <p:spTree>
+      <p:nvGrpSpPr>
+        <p:cNvPr id="1" name="Shape 144"/>
+        <p:cNvGrpSpPr/>
+        <p:nvPr/>
+      </p:nvGrpSpPr>
+      <p:grpSpPr>
+        <a:xfrm>
+          <a:off x="0" y="0"/>
+          <a:ext cx="0" cy="0"/>
+          <a:chOff x="0" y="0"/>
+          <a:chExt cx="0" cy="0"/>
+        </a:xfrm>
+      </p:grpSpPr>
+      <p:sp>
+        <p:nvSpPr>
+          <p:cNvPr id="145" name="Google Shape;145;p13"/>
+          <p:cNvSpPr txBox="1"/>
+          <p:nvPr/>
+        </p:nvSpPr>
+        <p:spPr>
+          <a:xfrm>
+            <a:off x="653143" y="325249"/>
+            <a:ext cx="9940835" cy="527875"/>
+          </a:xfrm>
+          <a:prstGeom prst="rect">
+            <a:avLst/>
+          </a:prstGeom>
+          <a:noFill/>
+          <a:ln>
+            <a:noFill/>
+          </a:ln>
+        </p:spPr>
+        <p:txBody>
+          <a:bodyPr spcFirstLastPara="1" wrap="square" lIns="91425" tIns="45700" rIns="91425" bIns="45700" anchor="t" anchorCtr="0">
+            <a:noAutofit/>
+          </a:bodyPr>
+          <a:lstStyle/>
+          <a:p>
+            <a:pPr>
+              <a:buClr>
+                <a:srgbClr val="FFFFFF"/>
+              </a:buClr>
+              <a:buSzPts val="6000"/>
+              <a:defRPr/>
+            </a:pPr>
+            <a:r>
+              <a:rPr lang="es-CO" sz="4000" b="1" dirty="0">
+                <a:solidFill>
+                  <a:srgbClr val="FFFFFF"/>
+                </a:solidFill>
+                <a:latin typeface="Work Sans"/>
+                <a:ea typeface="Work Sans"/>
+                <a:cs typeface="Work Sans"/>
+                <a:sym typeface="Work Sans"/>
+              </a:rPr>
+              <a:t>Normalización</a:t>
+            </a:r>
+            <a:endParaRPr sz="4000" b="1" dirty="0">
+              <a:solidFill>
+                <a:srgbClr val="FFFFFF"/>
+              </a:solidFill>
+              <a:latin typeface="Work Sans"/>
+              <a:ea typeface="Work Sans"/>
+              <a:cs typeface="Work Sans"/>
+              <a:sym typeface="Work Sans"/>
+            </a:endParaRPr>
+          </a:p>
+        </p:txBody>
+      </p:sp>
+      <p:pic>
+        <p:nvPicPr>
+          <p:cNvPr id="3" name="Imagen 2">
+            <a:extLst>
+              <a:ext uri="{FF2B5EF4-FFF2-40B4-BE49-F238E27FC236}">
+                <a16:creationId xmlns:a16="http://schemas.microsoft.com/office/drawing/2014/main" id="{D103AC4F-9E40-58A8-3918-C506D08367F4}"/>
+              </a:ext>
+            </a:extLst>
+          </p:cNvPr>
+          <p:cNvPicPr>
+            <a:picLocks noChangeAspect="1"/>
+          </p:cNvPicPr>
+          <p:nvPr/>
+        </p:nvPicPr>
+        <p:blipFill>
+          <a:blip r:embed="rId4"/>
+          <a:stretch>
+            <a:fillRect/>
+          </a:stretch>
+        </p:blipFill>
+        <p:spPr>
+          <a:xfrm>
+            <a:off x="1190027" y="1345034"/>
+            <a:ext cx="9205599" cy="4167935"/>
+          </a:xfrm>
+          <a:prstGeom prst="rect">
+            <a:avLst/>
+          </a:prstGeom>
+        </p:spPr>
+      </p:pic>
+      <p:sp>
+        <p:nvSpPr>
+          <p:cNvPr id="4" name="Google Shape;108;p3">
+            <a:extLst>
+              <a:ext uri="{FF2B5EF4-FFF2-40B4-BE49-F238E27FC236}">
+                <a16:creationId xmlns:a16="http://schemas.microsoft.com/office/drawing/2014/main" id="{CA32D6B8-E990-05EE-B505-D4C2127C1A8A}"/>
+              </a:ext>
+            </a:extLst>
+          </p:cNvPr>
+          <p:cNvSpPr txBox="1"/>
+          <p:nvPr/>
+        </p:nvSpPr>
+        <p:spPr>
+          <a:xfrm>
+            <a:off x="1106329" y="5886462"/>
+            <a:ext cx="4652787" cy="646290"/>
+          </a:xfrm>
+          <a:prstGeom prst="rect">
+            <a:avLst/>
+          </a:prstGeom>
+          <a:noFill/>
+          <a:ln>
+            <a:noFill/>
+          </a:ln>
+        </p:spPr>
+        <p:txBody>
+          <a:bodyPr spcFirstLastPara="1" wrap="square" lIns="91425" tIns="45700" rIns="91425" bIns="45700" anchor="t" anchorCtr="0">
+            <a:spAutoFit/>
+          </a:bodyPr>
+          <a:lstStyle/>
+          <a:p>
+            <a:r>
+              <a:rPr lang="es-CO" sz="3600" dirty="0">
+                <a:solidFill>
+                  <a:schemeClr val="accent6"/>
+                </a:solidFill>
+                <a:latin typeface="Calibri"/>
+                <a:cs typeface="Calibri"/>
+                <a:sym typeface="Calibri"/>
+                <a:hlinkClick r:id="rId5"/>
+              </a:rPr>
+              <a:t>Normalización del M.E.</a:t>
+            </a:r>
+            <a:endParaRPr dirty="0">
+              <a:solidFill>
+                <a:schemeClr val="accent6"/>
+              </a:solidFill>
+            </a:endParaRPr>
+          </a:p>
+        </p:txBody>
+      </p:sp>
+    </p:spTree>
   </p:cSld>
   <p:clrMapOvr>
     <a:masterClrMapping/>

</xml_diff>

<commit_message>
docs: actualizar presentación de entregables del tercer trimestre
Se actualizó la presentación de los entregables del tercer trimestre reemplazando la imagen correspondiente a la normalización por la versión corregida del archivo Excel y modificando el hipervínculo para que apunte al documento actualizado, asegurando que la presentación refleje la versión más reciente del entregable.
</commit_message>
<xml_diff>
--- a/Tercer Trimestre/Presentación - 3 Trimestre.pptx
+++ b/Tercer Trimestre/Presentación - 3 Trimestre.pptx
@@ -285,7 +285,7 @@
       </p15:sldGuideLst>
     </p:ext>
     <p:ext uri="GoogleSlidesCustomDataVersion2">
-      <go:slidesCustomData xmlns:go="http://customooxmlschemas.google.com/" r:id="rId25" roundtripDataSignature="AMtx7mjmpj3un0rOpof+e6QkjoLLZ8Nu1w=="/>
+      <go:slidesCustomData xmlns:go="http://customooxmlschemas.google.com/" r:id="rId25" roundtripDataSignature="AMtx7mg93Xqpxt55p6BTs7CMPLVXaSoJtA=="/>
     </p:ext>
   </p:extLst>
 </p:presentation>
@@ -19575,8 +19575,8 @@
         </p:blipFill>
         <p:spPr>
           <a:xfrm>
-            <a:off x="307838" y="1862825"/>
-            <a:ext cx="11576325" cy="2412825"/>
+            <a:off x="192050" y="1485900"/>
+            <a:ext cx="11580976" cy="2570750"/>
           </a:xfrm>
           <a:prstGeom prst="rect">
             <a:avLst/>

</xml_diff>